<commit_message>
update_Towards Adversarial Attack on Vision-Language Pre-training Models**.
</commit_message>
<xml_diff>
--- a/Attack/Adversarial_Attack/VLP/论文作图.pptx
+++ b/Attack/Adversarial_Attack/VLP/论文作图.pptx
@@ -8,12 +8,14 @@
     <p:notesMasterId r:id="rId5"/>
   </p:notesMasterIdLst>
   <p:handoutMasterIdLst>
-    <p:handoutMasterId r:id="rId7"/>
+    <p:handoutMasterId r:id="rId9"/>
   </p:handoutMasterIdLst>
   <p:sldIdLst>
     <p:sldId id="258" r:id="rId3"/>
     <p:sldId id="256" r:id="rId4"/>
     <p:sldId id="257" r:id="rId6"/>
+    <p:sldId id="259" r:id="rId7"/>
+    <p:sldId id="260" r:id="rId8"/>
   </p:sldIdLst>
   <p:sldSz cx="12192000" cy="6858000"/>
   <p:notesSz cx="7103745" cy="10234295"/>
@@ -6599,7 +6601,7 @@
         </p:nvSpPr>
         <p:spPr>
           <a:xfrm>
-            <a:off x="1802130" y="156845"/>
+            <a:off x="2275840" y="283845"/>
             <a:ext cx="2799715" cy="575310"/>
           </a:xfrm>
           <a:prstGeom prst="rect">
@@ -6665,7 +6667,7 @@
         </p:nvSpPr>
         <p:spPr>
           <a:xfrm>
-            <a:off x="-483870" y="2442845"/>
+            <a:off x="-102870" y="2569845"/>
             <a:ext cx="2799715" cy="575310"/>
           </a:xfrm>
           <a:prstGeom prst="rect">
@@ -7054,7 +7056,7 @@
         </p:nvSpPr>
         <p:spPr>
           <a:xfrm>
-            <a:off x="2945130" y="2569845"/>
+            <a:off x="4432300" y="2346325"/>
             <a:ext cx="2799715" cy="575310"/>
           </a:xfrm>
           <a:prstGeom prst="rect">
@@ -7224,7 +7226,7 @@
         </p:nvSpPr>
         <p:spPr>
           <a:xfrm>
-            <a:off x="786130" y="4855845"/>
+            <a:off x="786130" y="4982845"/>
             <a:ext cx="2799715" cy="575310"/>
           </a:xfrm>
           <a:prstGeom prst="rect">
@@ -7240,11 +7242,1662 @@
             <a:pPr algn="ctr"/>
             <a:r>
               <a:rPr lang="en-US" altLang="zh-CN" sz="1200" b="1">
+                <a:solidFill>
+                  <a:srgbClr val="FF0000"/>
+                </a:solidFill>
                 <a:latin typeface="微软雅黑" charset="0"/>
                 <a:ea typeface="微软雅黑" charset="0"/>
                 <a:cs typeface="微软雅黑" charset="0"/>
               </a:rPr>
               <a:t>MF-it</a:t>
+            </a:r>
+            <a:endParaRPr lang="en-US" altLang="zh-CN" sz="1200" b="1">
+              <a:solidFill>
+                <a:srgbClr val="FF0000"/>
+              </a:solidFill>
+              <a:latin typeface="微软雅黑" charset="0"/>
+              <a:ea typeface="微软雅黑" charset="0"/>
+              <a:cs typeface="微软雅黑" charset="0"/>
+            </a:endParaRPr>
+          </a:p>
+        </p:txBody>
+      </p:sp>
+      <p:sp>
+        <p:nvSpPr>
+          <p:cNvPr id="21" name="文本框 20"/>
+          <p:cNvSpPr txBox="1"/>
+          <p:nvPr>
+            <p:custDataLst>
+              <p:tags r:id="rId21"/>
+            </p:custDataLst>
+          </p:nvPr>
+        </p:nvSpPr>
+        <p:spPr>
+          <a:xfrm>
+            <a:off x="4723130" y="4975860"/>
+            <a:ext cx="2799715" cy="575310"/>
+          </a:xfrm>
+          <a:prstGeom prst="rect">
+            <a:avLst/>
+          </a:prstGeom>
+          <a:noFill/>
+        </p:spPr>
+        <p:txBody>
+          <a:bodyPr wrap="square" rtlCol="0">
+            <a:noAutofit/>
+          </a:bodyPr>
+          <a:p>
+            <a:pPr algn="ctr"/>
+            <a:r>
+              <a:rPr lang="en-US" altLang="zh-CN" sz="1200" b="1">
+                <a:solidFill>
+                  <a:srgbClr val="FF0000"/>
+                </a:solidFill>
+                <a:latin typeface="微软雅黑" charset="0"/>
+                <a:ea typeface="微软雅黑" charset="0"/>
+                <a:cs typeface="微软雅黑" charset="0"/>
+              </a:rPr>
+              <a:t>MF-ii</a:t>
+            </a:r>
+            <a:endParaRPr lang="en-US" altLang="zh-CN" sz="1200" b="1">
+              <a:solidFill>
+                <a:srgbClr val="FF0000"/>
+              </a:solidFill>
+              <a:latin typeface="微软雅黑" charset="0"/>
+              <a:ea typeface="微软雅黑" charset="0"/>
+              <a:cs typeface="微软雅黑" charset="0"/>
+            </a:endParaRPr>
+          </a:p>
+        </p:txBody>
+      </p:sp>
+      <p:sp>
+        <p:nvSpPr>
+          <p:cNvPr id="22" name="文本框 21"/>
+          <p:cNvSpPr txBox="1"/>
+          <p:nvPr>
+            <p:custDataLst>
+              <p:tags r:id="rId22"/>
+            </p:custDataLst>
+          </p:nvPr>
+        </p:nvSpPr>
+        <p:spPr>
+          <a:xfrm>
+            <a:off x="8914130" y="4982845"/>
+            <a:ext cx="2799715" cy="575310"/>
+          </a:xfrm>
+          <a:prstGeom prst="rect">
+            <a:avLst/>
+          </a:prstGeom>
+          <a:noFill/>
+        </p:spPr>
+        <p:txBody>
+          <a:bodyPr wrap="square" rtlCol="0">
+            <a:noAutofit/>
+          </a:bodyPr>
+          <a:p>
+            <a:pPr algn="ctr"/>
+            <a:r>
+              <a:rPr lang="en-US" altLang="zh-CN" sz="1200" b="1">
+                <a:solidFill>
+                  <a:srgbClr val="FF0000"/>
+                </a:solidFill>
+                <a:latin typeface="微软雅黑" charset="0"/>
+                <a:ea typeface="微软雅黑" charset="0"/>
+                <a:cs typeface="微软雅黑" charset="0"/>
+              </a:rPr>
+              <a:t>MF-tt</a:t>
+            </a:r>
+            <a:endParaRPr lang="en-US" altLang="zh-CN" sz="1200" b="1">
+              <a:solidFill>
+                <a:srgbClr val="FF0000"/>
+              </a:solidFill>
+              <a:latin typeface="微软雅黑" charset="0"/>
+              <a:ea typeface="微软雅黑" charset="0"/>
+              <a:cs typeface="微软雅黑" charset="0"/>
+            </a:endParaRPr>
+          </a:p>
+        </p:txBody>
+      </p:sp>
+      <p:sp>
+        <p:nvSpPr>
+          <p:cNvPr id="23" name="文本框 22"/>
+          <p:cNvSpPr txBox="1"/>
+          <p:nvPr>
+            <p:custDataLst>
+              <p:tags r:id="rId23"/>
+            </p:custDataLst>
+          </p:nvPr>
+        </p:nvSpPr>
+        <p:spPr>
+          <a:xfrm>
+            <a:off x="659130" y="5490845"/>
+            <a:ext cx="2799715" cy="575310"/>
+          </a:xfrm>
+          <a:prstGeom prst="rect">
+            <a:avLst/>
+          </a:prstGeom>
+          <a:noFill/>
+        </p:spPr>
+        <p:txBody>
+          <a:bodyPr wrap="square" rtlCol="0">
+            <a:noAutofit/>
+          </a:bodyPr>
+          <a:p>
+            <a:pPr algn="ctr"/>
+            <a:r>
+              <a:rPr lang="zh-CN" altLang="en-US" sz="1200" b="1">
+                <a:latin typeface="微软雅黑" charset="0"/>
+                <a:ea typeface="微软雅黑" charset="0"/>
+                <a:cs typeface="微软雅黑" charset="0"/>
+              </a:rPr>
+              <a:t>第一种</a:t>
+            </a:r>
+            <a:r>
+              <a:rPr lang="en-US" altLang="zh-CN" sz="1200" b="1">
+                <a:latin typeface="微软雅黑" charset="0"/>
+                <a:ea typeface="微软雅黑" charset="0"/>
+                <a:cs typeface="微软雅黑" charset="0"/>
+              </a:rPr>
+              <a:t> </a:t>
+            </a:r>
+            <a:r>
+              <a:rPr lang="zh-CN" altLang="en-US" sz="1200" b="1">
+                <a:latin typeface="微软雅黑" charset="0"/>
+                <a:ea typeface="微软雅黑" charset="0"/>
+                <a:cs typeface="微软雅黑" charset="0"/>
+              </a:rPr>
+              <a:t>第一步</a:t>
+            </a:r>
+            <a:r>
+              <a:rPr lang="en-US" altLang="zh-CN" sz="1200" b="1">
+                <a:latin typeface="微软雅黑" charset="0"/>
+                <a:ea typeface="微软雅黑" charset="0"/>
+                <a:cs typeface="微软雅黑" charset="0"/>
+              </a:rPr>
+              <a:t> </a:t>
+            </a:r>
+            <a:r>
+              <a:rPr lang="zh-CN" altLang="en-US" sz="1200" b="1">
+                <a:latin typeface="微软雅黑" charset="0"/>
+                <a:ea typeface="微软雅黑" charset="0"/>
+                <a:cs typeface="微软雅黑" charset="0"/>
+              </a:rPr>
+              <a:t>图像左侧</a:t>
+            </a:r>
+            <a:br>
+              <a:rPr lang="zh-CN" altLang="en-US" sz="1200" b="1">
+                <a:latin typeface="微软雅黑" charset="0"/>
+                <a:ea typeface="微软雅黑" charset="0"/>
+                <a:cs typeface="微软雅黑" charset="0"/>
+              </a:rPr>
+            </a:br>
+            <a:r>
+              <a:rPr lang="zh-CN" altLang="en-US" sz="1200" b="1">
+                <a:latin typeface="微软雅黑" charset="0"/>
+                <a:ea typeface="微软雅黑" charset="0"/>
+                <a:cs typeface="微软雅黑" charset="0"/>
+              </a:rPr>
+              <a:t>让锚点文本和扰动图像特征内积</a:t>
+            </a:r>
+            <a:r>
+              <a:rPr lang="zh-CN" altLang="en-US" sz="1200" b="1">
+                <a:latin typeface="微软雅黑" charset="0"/>
+                <a:ea typeface="微软雅黑" charset="0"/>
+                <a:cs typeface="微软雅黑" charset="0"/>
+              </a:rPr>
+              <a:t>最大化</a:t>
+            </a:r>
+            <a:endParaRPr lang="zh-CN" altLang="en-US" sz="1200" b="1">
+              <a:latin typeface="微软雅黑" charset="0"/>
+              <a:ea typeface="微软雅黑" charset="0"/>
+              <a:cs typeface="微软雅黑" charset="0"/>
+            </a:endParaRPr>
+          </a:p>
+        </p:txBody>
+      </p:sp>
+      <p:sp>
+        <p:nvSpPr>
+          <p:cNvPr id="24" name="文本框 23"/>
+          <p:cNvSpPr txBox="1"/>
+          <p:nvPr>
+            <p:custDataLst>
+              <p:tags r:id="rId24"/>
+            </p:custDataLst>
+          </p:nvPr>
+        </p:nvSpPr>
+        <p:spPr>
+          <a:xfrm>
+            <a:off x="4518660" y="5490845"/>
+            <a:ext cx="3463290" cy="575310"/>
+          </a:xfrm>
+          <a:prstGeom prst="rect">
+            <a:avLst/>
+          </a:prstGeom>
+          <a:noFill/>
+        </p:spPr>
+        <p:txBody>
+          <a:bodyPr wrap="square" rtlCol="0">
+            <a:noAutofit/>
+          </a:bodyPr>
+          <a:p>
+            <a:pPr algn="ctr"/>
+            <a:r>
+              <a:rPr lang="zh-CN" altLang="en-US" sz="1200" b="1">
+                <a:latin typeface="微软雅黑" charset="0"/>
+                <a:ea typeface="微软雅黑" charset="0"/>
+                <a:cs typeface="微软雅黑" charset="0"/>
+              </a:rPr>
+              <a:t>第二种</a:t>
+            </a:r>
+            <a:r>
+              <a:rPr lang="en-US" altLang="zh-CN" sz="1200" b="1">
+                <a:latin typeface="微软雅黑" charset="0"/>
+                <a:ea typeface="微软雅黑" charset="0"/>
+                <a:cs typeface="微软雅黑" charset="0"/>
+              </a:rPr>
+              <a:t> </a:t>
+            </a:r>
+            <a:r>
+              <a:rPr lang="zh-CN" altLang="en-US" sz="1200" b="1">
+                <a:latin typeface="微软雅黑" charset="0"/>
+                <a:ea typeface="微软雅黑" charset="0"/>
+                <a:cs typeface="微软雅黑" charset="0"/>
+              </a:rPr>
+              <a:t>第一步</a:t>
+            </a:r>
+            <a:r>
+              <a:rPr lang="en-US" altLang="zh-CN" sz="1200" b="1">
+                <a:latin typeface="微软雅黑" charset="0"/>
+                <a:ea typeface="微软雅黑" charset="0"/>
+                <a:cs typeface="微软雅黑" charset="0"/>
+              </a:rPr>
+              <a:t> </a:t>
+            </a:r>
+            <a:r>
+              <a:rPr lang="zh-CN" altLang="en-US" sz="1200" b="1">
+                <a:latin typeface="微软雅黑" charset="0"/>
+                <a:ea typeface="微软雅黑" charset="0"/>
+                <a:cs typeface="微软雅黑" charset="0"/>
+              </a:rPr>
+              <a:t>图像左侧</a:t>
+            </a:r>
+            <a:br>
+              <a:rPr lang="zh-CN" altLang="en-US" sz="1200" b="1">
+                <a:latin typeface="微软雅黑" charset="0"/>
+                <a:ea typeface="微软雅黑" charset="0"/>
+                <a:cs typeface="微软雅黑" charset="0"/>
+              </a:rPr>
+            </a:br>
+            <a:r>
+              <a:rPr lang="zh-CN" altLang="en-US" sz="1200" b="1">
+                <a:latin typeface="微软雅黑" charset="0"/>
+                <a:ea typeface="微软雅黑" charset="0"/>
+                <a:cs typeface="微软雅黑" charset="0"/>
+              </a:rPr>
+              <a:t>让锚点文本生成的图像和扰动图像内积最大</a:t>
+            </a:r>
+            <a:r>
+              <a:rPr lang="zh-CN" altLang="en-US" sz="1200" b="1">
+                <a:latin typeface="微软雅黑" charset="0"/>
+                <a:ea typeface="微软雅黑" charset="0"/>
+                <a:cs typeface="微软雅黑" charset="0"/>
+              </a:rPr>
+              <a:t>化</a:t>
+            </a:r>
+            <a:endParaRPr lang="zh-CN" altLang="en-US" sz="1200" b="1">
+              <a:latin typeface="微软雅黑" charset="0"/>
+              <a:ea typeface="微软雅黑" charset="0"/>
+              <a:cs typeface="微软雅黑" charset="0"/>
+            </a:endParaRPr>
+          </a:p>
+        </p:txBody>
+      </p:sp>
+      <p:sp>
+        <p:nvSpPr>
+          <p:cNvPr id="25" name="文本框 24"/>
+          <p:cNvSpPr txBox="1"/>
+          <p:nvPr>
+            <p:custDataLst>
+              <p:tags r:id="rId25"/>
+            </p:custDataLst>
+          </p:nvPr>
+        </p:nvSpPr>
+        <p:spPr>
+          <a:xfrm>
+            <a:off x="8582660" y="5490845"/>
+            <a:ext cx="3463290" cy="575310"/>
+          </a:xfrm>
+          <a:prstGeom prst="rect">
+            <a:avLst/>
+          </a:prstGeom>
+          <a:noFill/>
+        </p:spPr>
+        <p:txBody>
+          <a:bodyPr wrap="square" rtlCol="0">
+            <a:noAutofit/>
+          </a:bodyPr>
+          <a:p>
+            <a:pPr algn="ctr"/>
+            <a:r>
+              <a:rPr lang="zh-CN" altLang="en-US" sz="1200" b="1">
+                <a:latin typeface="微软雅黑" charset="0"/>
+                <a:ea typeface="微软雅黑" charset="0"/>
+                <a:cs typeface="微软雅黑" charset="0"/>
+              </a:rPr>
+              <a:t>第二步</a:t>
+            </a:r>
+            <a:r>
+              <a:rPr lang="en-US" altLang="zh-CN" sz="1200" b="1">
+                <a:latin typeface="微软雅黑" charset="0"/>
+                <a:ea typeface="微软雅黑" charset="0"/>
+                <a:cs typeface="微软雅黑" charset="0"/>
+              </a:rPr>
+              <a:t> </a:t>
+            </a:r>
+            <a:r>
+              <a:rPr lang="zh-CN" altLang="en-US" sz="1200" b="1">
+                <a:latin typeface="微软雅黑" charset="0"/>
+                <a:ea typeface="微软雅黑" charset="0"/>
+                <a:cs typeface="微软雅黑" charset="0"/>
+              </a:rPr>
+              <a:t>图像右侧</a:t>
+            </a:r>
+            <a:br>
+              <a:rPr lang="zh-CN" altLang="en-US" sz="1200" b="1">
+                <a:latin typeface="微软雅黑" charset="0"/>
+                <a:ea typeface="微软雅黑" charset="0"/>
+                <a:cs typeface="微软雅黑" charset="0"/>
+              </a:rPr>
+            </a:br>
+            <a:r>
+              <a:rPr lang="zh-CN" altLang="en-US" sz="1200" b="1">
+                <a:latin typeface="微软雅黑" charset="0"/>
+                <a:ea typeface="微软雅黑" charset="0"/>
+                <a:cs typeface="微软雅黑" charset="0"/>
+              </a:rPr>
+              <a:t>让输入</a:t>
+            </a:r>
+            <a:r>
+              <a:rPr lang="en-US" altLang="zh-CN" sz="1200" b="1">
+                <a:latin typeface="微软雅黑" charset="0"/>
+                <a:ea typeface="微软雅黑" charset="0"/>
+                <a:cs typeface="微软雅黑" charset="0"/>
+              </a:rPr>
+              <a:t>VLM</a:t>
+            </a:r>
+            <a:r>
+              <a:rPr lang="zh-CN" altLang="en-US" sz="1200" b="1">
+                <a:latin typeface="微软雅黑" charset="0"/>
+                <a:ea typeface="微软雅黑" charset="0"/>
+                <a:cs typeface="微软雅黑" charset="0"/>
+              </a:rPr>
+              <a:t>的由第一步生成的扰动图像和文本生成的</a:t>
+            </a:r>
+            <a:r>
+              <a:rPr lang="en-US" altLang="zh-CN" sz="1200" b="1">
+                <a:latin typeface="微软雅黑" charset="0"/>
+                <a:ea typeface="微软雅黑" charset="0"/>
+                <a:cs typeface="微软雅黑" charset="0"/>
+              </a:rPr>
+              <a:t>LLM</a:t>
+            </a:r>
+            <a:r>
+              <a:rPr lang="zh-CN" altLang="en-US" sz="1200" b="1">
+                <a:latin typeface="微软雅黑" charset="0"/>
+                <a:ea typeface="微软雅黑" charset="0"/>
+                <a:cs typeface="微软雅黑" charset="0"/>
+              </a:rPr>
+              <a:t>和锚点文本的特征内积</a:t>
+            </a:r>
+            <a:r>
+              <a:rPr lang="zh-CN" altLang="en-US" sz="1200" b="1">
+                <a:latin typeface="微软雅黑" charset="0"/>
+                <a:ea typeface="微软雅黑" charset="0"/>
+                <a:cs typeface="微软雅黑" charset="0"/>
+              </a:rPr>
+              <a:t>最大化</a:t>
+            </a:r>
+            <a:endParaRPr lang="zh-CN" altLang="en-US" sz="1200" b="1">
+              <a:latin typeface="微软雅黑" charset="0"/>
+              <a:ea typeface="微软雅黑" charset="0"/>
+              <a:cs typeface="微软雅黑" charset="0"/>
+            </a:endParaRPr>
+          </a:p>
+        </p:txBody>
+      </p:sp>
+      <p:sp>
+        <p:nvSpPr>
+          <p:cNvPr id="26" name="文本框 25"/>
+          <p:cNvSpPr txBox="1"/>
+          <p:nvPr>
+            <p:custDataLst>
+              <p:tags r:id="rId26"/>
+            </p:custDataLst>
+          </p:nvPr>
+        </p:nvSpPr>
+        <p:spPr>
+          <a:xfrm>
+            <a:off x="2105660" y="6125845"/>
+            <a:ext cx="3463290" cy="575310"/>
+          </a:xfrm>
+          <a:prstGeom prst="rect">
+            <a:avLst/>
+          </a:prstGeom>
+          <a:noFill/>
+        </p:spPr>
+        <p:txBody>
+          <a:bodyPr wrap="square" rtlCol="0">
+            <a:noAutofit/>
+          </a:bodyPr>
+          <a:p>
+            <a:pPr algn="ctr"/>
+            <a:r>
+              <a:rPr lang="en-US" altLang="zh-CN" sz="1200" b="1">
+                <a:latin typeface="微软雅黑" charset="0"/>
+                <a:ea typeface="微软雅黑" charset="0"/>
+                <a:cs typeface="微软雅黑" charset="0"/>
+              </a:rPr>
+              <a:t>MF-tt</a:t>
+            </a:r>
+            <a:r>
+              <a:rPr lang="zh-CN" altLang="en-US" sz="1200" b="1">
+                <a:latin typeface="微软雅黑" charset="0"/>
+                <a:ea typeface="微软雅黑" charset="0"/>
+                <a:cs typeface="微软雅黑" charset="0"/>
+              </a:rPr>
+              <a:t>的优化策略</a:t>
+            </a:r>
+            <a:br>
+              <a:rPr lang="zh-CN" altLang="en-US" sz="1200" b="1">
+                <a:latin typeface="微软雅黑" charset="0"/>
+                <a:ea typeface="微软雅黑" charset="0"/>
+                <a:cs typeface="微软雅黑" charset="0"/>
+              </a:rPr>
+            </a:br>
+            <a:r>
+              <a:rPr lang="zh-CN" altLang="en-US" sz="1200" b="1">
+                <a:latin typeface="微软雅黑" charset="0"/>
+                <a:ea typeface="微软雅黑" charset="0"/>
+                <a:cs typeface="微软雅黑" charset="0"/>
+              </a:rPr>
+              <a:t>计算添加图像扰动前后的图像特征和目标文本的特征的相似度的差值来作为梯度来更新图像扰动</a:t>
+            </a:r>
+            <a:endParaRPr lang="zh-CN" altLang="en-US" sz="1200" b="1">
+              <a:latin typeface="微软雅黑" charset="0"/>
+              <a:ea typeface="微软雅黑" charset="0"/>
+              <a:cs typeface="微软雅黑" charset="0"/>
+            </a:endParaRPr>
+          </a:p>
+        </p:txBody>
+      </p:sp>
+      <p:sp>
+        <p:nvSpPr>
+          <p:cNvPr id="27" name="矩形: 圆角 36"/>
+          <p:cNvSpPr/>
+          <p:nvPr>
+            <p:custDataLst>
+              <p:tags r:id="rId27"/>
+            </p:custDataLst>
+          </p:nvPr>
+        </p:nvSpPr>
+        <p:spPr>
+          <a:xfrm rot="10800000" flipV="1">
+            <a:off x="1802130" y="132715"/>
+            <a:ext cx="3695700" cy="2051050"/>
+          </a:xfrm>
+          <a:prstGeom prst="roundRect">
+            <a:avLst>
+              <a:gd name="adj" fmla="val 10039"/>
+            </a:avLst>
+          </a:prstGeom>
+          <a:noFill/>
+          <a:ln w="38100">
+            <a:solidFill>
+              <a:schemeClr val="tx1"/>
+            </a:solidFill>
+            <a:prstDash val="lgDash"/>
+          </a:ln>
+        </p:spPr>
+        <p:style>
+          <a:lnRef idx="2">
+            <a:schemeClr val="accent1">
+              <a:shade val="15000"/>
+            </a:schemeClr>
+          </a:lnRef>
+          <a:fillRef idx="1">
+            <a:schemeClr val="accent1"/>
+          </a:fillRef>
+          <a:effectRef idx="0">
+            <a:schemeClr val="accent1"/>
+          </a:effectRef>
+          <a:fontRef idx="minor">
+            <a:schemeClr val="lt1"/>
+          </a:fontRef>
+        </p:style>
+        <p:txBody>
+          <a:bodyPr rtlCol="0" anchor="ctr"/>
+          <a:p>
+            <a:pPr algn="ctr"/>
+            <a:endParaRPr lang="zh-CN" altLang="en-US"/>
+          </a:p>
+        </p:txBody>
+      </p:sp>
+      <p:sp>
+        <p:nvSpPr>
+          <p:cNvPr id="28" name="矩形: 圆角 36"/>
+          <p:cNvSpPr/>
+          <p:nvPr>
+            <p:custDataLst>
+              <p:tags r:id="rId28"/>
+            </p:custDataLst>
+          </p:nvPr>
+        </p:nvSpPr>
+        <p:spPr>
+          <a:xfrm rot="10800000" flipV="1">
+            <a:off x="558800" y="2183765"/>
+            <a:ext cx="3136900" cy="1049655"/>
+          </a:xfrm>
+          <a:prstGeom prst="roundRect">
+            <a:avLst>
+              <a:gd name="adj" fmla="val 10039"/>
+            </a:avLst>
+          </a:prstGeom>
+          <a:noFill/>
+          <a:ln w="38100">
+            <a:solidFill>
+              <a:schemeClr val="tx1"/>
+            </a:solidFill>
+            <a:prstDash val="lgDash"/>
+          </a:ln>
+        </p:spPr>
+        <p:style>
+          <a:lnRef idx="2">
+            <a:schemeClr val="accent1">
+              <a:shade val="15000"/>
+            </a:schemeClr>
+          </a:lnRef>
+          <a:fillRef idx="1">
+            <a:schemeClr val="accent1"/>
+          </a:fillRef>
+          <a:effectRef idx="0">
+            <a:schemeClr val="accent1"/>
+          </a:effectRef>
+          <a:fontRef idx="minor">
+            <a:schemeClr val="lt1"/>
+          </a:fontRef>
+        </p:style>
+        <p:txBody>
+          <a:bodyPr rtlCol="0" anchor="ctr"/>
+          <a:p>
+            <a:pPr algn="ctr"/>
+            <a:endParaRPr lang="zh-CN" altLang="en-US"/>
+          </a:p>
+        </p:txBody>
+      </p:sp>
+      <p:sp>
+        <p:nvSpPr>
+          <p:cNvPr id="29" name="矩形: 圆角 36"/>
+          <p:cNvSpPr/>
+          <p:nvPr>
+            <p:custDataLst>
+              <p:tags r:id="rId29"/>
+            </p:custDataLst>
+          </p:nvPr>
+        </p:nvSpPr>
+        <p:spPr>
+          <a:xfrm rot="10800000" flipV="1">
+            <a:off x="3695700" y="2219325"/>
+            <a:ext cx="2661285" cy="1511300"/>
+          </a:xfrm>
+          <a:prstGeom prst="roundRect">
+            <a:avLst>
+              <a:gd name="adj" fmla="val 10039"/>
+            </a:avLst>
+          </a:prstGeom>
+          <a:noFill/>
+          <a:ln w="38100">
+            <a:solidFill>
+              <a:schemeClr val="tx1"/>
+            </a:solidFill>
+            <a:prstDash val="lgDash"/>
+          </a:ln>
+        </p:spPr>
+        <p:style>
+          <a:lnRef idx="2">
+            <a:schemeClr val="accent1">
+              <a:shade val="15000"/>
+            </a:schemeClr>
+          </a:lnRef>
+          <a:fillRef idx="1">
+            <a:schemeClr val="accent1"/>
+          </a:fillRef>
+          <a:effectRef idx="0">
+            <a:schemeClr val="accent1"/>
+          </a:effectRef>
+          <a:fontRef idx="minor">
+            <a:schemeClr val="lt1"/>
+          </a:fontRef>
+        </p:style>
+        <p:txBody>
+          <a:bodyPr rtlCol="0" anchor="ctr"/>
+          <a:p>
+            <a:pPr algn="ctr"/>
+            <a:endParaRPr lang="zh-CN" altLang="en-US"/>
+          </a:p>
+        </p:txBody>
+      </p:sp>
+      <p:sp>
+        <p:nvSpPr>
+          <p:cNvPr id="30" name="矩形: 圆角 36"/>
+          <p:cNvSpPr/>
+          <p:nvPr>
+            <p:custDataLst>
+              <p:tags r:id="rId30"/>
+            </p:custDataLst>
+          </p:nvPr>
+        </p:nvSpPr>
+        <p:spPr>
+          <a:xfrm rot="10800000" flipV="1">
+            <a:off x="6291580" y="428625"/>
+            <a:ext cx="4745990" cy="3168650"/>
+          </a:xfrm>
+          <a:prstGeom prst="roundRect">
+            <a:avLst>
+              <a:gd name="adj" fmla="val 10039"/>
+            </a:avLst>
+          </a:prstGeom>
+          <a:noFill/>
+          <a:ln w="38100">
+            <a:solidFill>
+              <a:schemeClr val="tx1"/>
+            </a:solidFill>
+            <a:prstDash val="lgDash"/>
+          </a:ln>
+        </p:spPr>
+        <p:style>
+          <a:lnRef idx="2">
+            <a:schemeClr val="accent1">
+              <a:shade val="15000"/>
+            </a:schemeClr>
+          </a:lnRef>
+          <a:fillRef idx="1">
+            <a:schemeClr val="accent1"/>
+          </a:fillRef>
+          <a:effectRef idx="0">
+            <a:schemeClr val="accent1"/>
+          </a:effectRef>
+          <a:fontRef idx="minor">
+            <a:schemeClr val="lt1"/>
+          </a:fontRef>
+        </p:style>
+        <p:txBody>
+          <a:bodyPr rtlCol="0" anchor="ctr"/>
+          <a:p>
+            <a:pPr algn="ctr"/>
+            <a:endParaRPr lang="zh-CN" altLang="en-US"/>
+          </a:p>
+        </p:txBody>
+      </p:sp>
+      <p:sp>
+        <p:nvSpPr>
+          <p:cNvPr id="32" name="矩形: 圆角 36"/>
+          <p:cNvSpPr/>
+          <p:nvPr>
+            <p:custDataLst>
+              <p:tags r:id="rId31"/>
+            </p:custDataLst>
+          </p:nvPr>
+        </p:nvSpPr>
+        <p:spPr>
+          <a:xfrm rot="10800000" flipV="1">
+            <a:off x="1824355" y="3733800"/>
+            <a:ext cx="4105275" cy="1206500"/>
+          </a:xfrm>
+          <a:prstGeom prst="roundRect">
+            <a:avLst>
+              <a:gd name="adj" fmla="val 10039"/>
+            </a:avLst>
+          </a:prstGeom>
+          <a:noFill/>
+          <a:ln w="38100">
+            <a:solidFill>
+              <a:schemeClr val="tx1"/>
+            </a:solidFill>
+            <a:prstDash val="lgDash"/>
+          </a:ln>
+        </p:spPr>
+        <p:style>
+          <a:lnRef idx="2">
+            <a:schemeClr val="accent1">
+              <a:shade val="15000"/>
+            </a:schemeClr>
+          </a:lnRef>
+          <a:fillRef idx="1">
+            <a:schemeClr val="accent1"/>
+          </a:fillRef>
+          <a:effectRef idx="0">
+            <a:schemeClr val="accent1"/>
+          </a:effectRef>
+          <a:fontRef idx="minor">
+            <a:schemeClr val="lt1"/>
+          </a:fontRef>
+        </p:style>
+        <p:txBody>
+          <a:bodyPr rtlCol="0" anchor="ctr"/>
+          <a:p>
+            <a:pPr algn="ctr"/>
+            <a:endParaRPr lang="zh-CN" altLang="en-US"/>
+          </a:p>
+        </p:txBody>
+      </p:sp>
+      <p:sp>
+        <p:nvSpPr>
+          <p:cNvPr id="33" name="矩形: 圆角 36"/>
+          <p:cNvSpPr/>
+          <p:nvPr>
+            <p:custDataLst>
+              <p:tags r:id="rId32"/>
+            </p:custDataLst>
+          </p:nvPr>
+        </p:nvSpPr>
+        <p:spPr>
+          <a:xfrm rot="10800000" flipV="1">
+            <a:off x="6396355" y="3733800"/>
+            <a:ext cx="4105275" cy="1206500"/>
+          </a:xfrm>
+          <a:prstGeom prst="roundRect">
+            <a:avLst>
+              <a:gd name="adj" fmla="val 10039"/>
+            </a:avLst>
+          </a:prstGeom>
+          <a:noFill/>
+          <a:ln w="38100">
+            <a:solidFill>
+              <a:schemeClr val="tx1"/>
+            </a:solidFill>
+            <a:prstDash val="lgDash"/>
+          </a:ln>
+        </p:spPr>
+        <p:style>
+          <a:lnRef idx="2">
+            <a:schemeClr val="accent1">
+              <a:shade val="15000"/>
+            </a:schemeClr>
+          </a:lnRef>
+          <a:fillRef idx="1">
+            <a:schemeClr val="accent1"/>
+          </a:fillRef>
+          <a:effectRef idx="0">
+            <a:schemeClr val="accent1"/>
+          </a:effectRef>
+          <a:fontRef idx="minor">
+            <a:schemeClr val="lt1"/>
+          </a:fontRef>
+        </p:style>
+        <p:txBody>
+          <a:bodyPr rtlCol="0" anchor="ctr"/>
+          <a:p>
+            <a:pPr algn="ctr"/>
+            <a:endParaRPr lang="zh-CN" altLang="en-US"/>
+          </a:p>
+        </p:txBody>
+      </p:sp>
+      <p:sp>
+        <p:nvSpPr>
+          <p:cNvPr id="34" name="矩形: 圆角 36"/>
+          <p:cNvSpPr/>
+          <p:nvPr>
+            <p:custDataLst>
+              <p:tags r:id="rId33"/>
+            </p:custDataLst>
+          </p:nvPr>
+        </p:nvSpPr>
+        <p:spPr>
+          <a:xfrm rot="10800000" flipV="1">
+            <a:off x="434975" y="4976495"/>
+            <a:ext cx="3435350" cy="1106805"/>
+          </a:xfrm>
+          <a:prstGeom prst="roundRect">
+            <a:avLst>
+              <a:gd name="adj" fmla="val 10039"/>
+            </a:avLst>
+          </a:prstGeom>
+          <a:noFill/>
+          <a:ln w="38100">
+            <a:solidFill>
+              <a:schemeClr val="tx1"/>
+            </a:solidFill>
+            <a:prstDash val="lgDash"/>
+          </a:ln>
+        </p:spPr>
+        <p:style>
+          <a:lnRef idx="2">
+            <a:schemeClr val="accent1">
+              <a:shade val="15000"/>
+            </a:schemeClr>
+          </a:lnRef>
+          <a:fillRef idx="1">
+            <a:schemeClr val="accent1"/>
+          </a:fillRef>
+          <a:effectRef idx="0">
+            <a:schemeClr val="accent1"/>
+          </a:effectRef>
+          <a:fontRef idx="minor">
+            <a:schemeClr val="lt1"/>
+          </a:fontRef>
+        </p:style>
+        <p:txBody>
+          <a:bodyPr rtlCol="0" anchor="ctr"/>
+          <a:p>
+            <a:pPr algn="ctr"/>
+            <a:endParaRPr lang="zh-CN" altLang="en-US"/>
+          </a:p>
+        </p:txBody>
+      </p:sp>
+      <p:sp>
+        <p:nvSpPr>
+          <p:cNvPr id="35" name="矩形: 圆角 36"/>
+          <p:cNvSpPr/>
+          <p:nvPr>
+            <p:custDataLst>
+              <p:tags r:id="rId34"/>
+            </p:custDataLst>
+          </p:nvPr>
+        </p:nvSpPr>
+        <p:spPr>
+          <a:xfrm rot="10800000" flipV="1">
+            <a:off x="4498975" y="4976495"/>
+            <a:ext cx="3435350" cy="1106805"/>
+          </a:xfrm>
+          <a:prstGeom prst="roundRect">
+            <a:avLst>
+              <a:gd name="adj" fmla="val 10039"/>
+            </a:avLst>
+          </a:prstGeom>
+          <a:noFill/>
+          <a:ln w="38100">
+            <a:solidFill>
+              <a:schemeClr val="tx1"/>
+            </a:solidFill>
+            <a:prstDash val="lgDash"/>
+          </a:ln>
+        </p:spPr>
+        <p:style>
+          <a:lnRef idx="2">
+            <a:schemeClr val="accent1">
+              <a:shade val="15000"/>
+            </a:schemeClr>
+          </a:lnRef>
+          <a:fillRef idx="1">
+            <a:schemeClr val="accent1"/>
+          </a:fillRef>
+          <a:effectRef idx="0">
+            <a:schemeClr val="accent1"/>
+          </a:effectRef>
+          <a:fontRef idx="minor">
+            <a:schemeClr val="lt1"/>
+          </a:fontRef>
+        </p:style>
+        <p:txBody>
+          <a:bodyPr rtlCol="0" anchor="ctr"/>
+          <a:p>
+            <a:pPr algn="ctr"/>
+            <a:endParaRPr lang="zh-CN" altLang="en-US"/>
+          </a:p>
+        </p:txBody>
+      </p:sp>
+      <p:sp>
+        <p:nvSpPr>
+          <p:cNvPr id="36" name="矩形: 圆角 36"/>
+          <p:cNvSpPr/>
+          <p:nvPr>
+            <p:custDataLst>
+              <p:tags r:id="rId35"/>
+            </p:custDataLst>
+          </p:nvPr>
+        </p:nvSpPr>
+        <p:spPr>
+          <a:xfrm rot="10800000" flipV="1">
+            <a:off x="8562975" y="4976495"/>
+            <a:ext cx="3435350" cy="1106805"/>
+          </a:xfrm>
+          <a:prstGeom prst="roundRect">
+            <a:avLst>
+              <a:gd name="adj" fmla="val 10039"/>
+            </a:avLst>
+          </a:prstGeom>
+          <a:noFill/>
+          <a:ln w="38100">
+            <a:solidFill>
+              <a:schemeClr val="tx1"/>
+            </a:solidFill>
+            <a:prstDash val="lgDash"/>
+          </a:ln>
+        </p:spPr>
+        <p:style>
+          <a:lnRef idx="2">
+            <a:schemeClr val="accent1">
+              <a:shade val="15000"/>
+            </a:schemeClr>
+          </a:lnRef>
+          <a:fillRef idx="1">
+            <a:schemeClr val="accent1"/>
+          </a:fillRef>
+          <a:effectRef idx="0">
+            <a:schemeClr val="accent1"/>
+          </a:effectRef>
+          <a:fontRef idx="minor">
+            <a:schemeClr val="lt1"/>
+          </a:fontRef>
+        </p:style>
+        <p:txBody>
+          <a:bodyPr rtlCol="0" anchor="ctr"/>
+          <a:p>
+            <a:pPr algn="ctr"/>
+            <a:endParaRPr lang="zh-CN" altLang="en-US"/>
+          </a:p>
+        </p:txBody>
+      </p:sp>
+    </p:spTree>
+  </p:cSld>
+  <p:clrMapOvr>
+    <a:masterClrMapping/>
+  </p:clrMapOvr>
+</p:sld>
+</file>
+
+<file path=ppt/slides/slide4.xml><?xml version="1.0" encoding="utf-8"?>
+<p:sld xmlns:a="http://schemas.openxmlformats.org/drawingml/2006/main" xmlns:r="http://schemas.openxmlformats.org/officeDocument/2006/relationships" xmlns:p="http://schemas.openxmlformats.org/presentationml/2006/main">
+  <p:cSld>
+    <p:spTree>
+      <p:nvGrpSpPr>
+        <p:cNvPr id="1" name=""/>
+        <p:cNvGrpSpPr/>
+        <p:nvPr/>
+      </p:nvGrpSpPr>
+      <p:grpSpPr/>
+      <p:sp>
+        <p:nvSpPr>
+          <p:cNvPr id="2" name="标题 1"/>
+          <p:cNvSpPr>
+            <a:spLocks noGrp="1"/>
+          </p:cNvSpPr>
+          <p:nvPr>
+            <p:ph type="ctrTitle"/>
+          </p:nvPr>
+        </p:nvSpPr>
+        <p:spPr/>
+        <p:txBody>
+          <a:bodyPr/>
+          <a:p>
+            <a:r>
+              <a:rPr lang="en-US" altLang="zh-CN"/>
+              <a:t>Co-Attack</a:t>
+            </a:r>
+            <a:endParaRPr lang="en-US" altLang="zh-CN"/>
+          </a:p>
+        </p:txBody>
+      </p:sp>
+      <p:sp>
+        <p:nvSpPr>
+          <p:cNvPr id="3" name="副标题 2"/>
+          <p:cNvSpPr>
+            <a:spLocks noGrp="1"/>
+          </p:cNvSpPr>
+          <p:nvPr>
+            <p:ph type="subTitle" idx="1"/>
+          </p:nvPr>
+        </p:nvSpPr>
+        <p:spPr/>
+        <p:txBody>
+          <a:bodyPr/>
+          <a:p>
+            <a:endParaRPr lang="zh-CN" altLang="en-US"/>
+          </a:p>
+        </p:txBody>
+      </p:sp>
+    </p:spTree>
+  </p:cSld>
+  <p:clrMapOvr>
+    <a:masterClrMapping/>
+  </p:clrMapOvr>
+</p:sld>
+</file>
+
+<file path=ppt/slides/slide5.xml><?xml version="1.0" encoding="utf-8"?>
+<p:sld xmlns:a="http://schemas.openxmlformats.org/drawingml/2006/main" xmlns:r="http://schemas.openxmlformats.org/officeDocument/2006/relationships" xmlns:p="http://schemas.openxmlformats.org/presentationml/2006/main">
+  <p:cSld>
+    <p:spTree>
+      <p:nvGrpSpPr>
+        <p:cNvPr id="1" name=""/>
+        <p:cNvGrpSpPr/>
+        <p:nvPr/>
+      </p:nvGrpSpPr>
+      <p:grpSpPr/>
+      <p:pic>
+        <p:nvPicPr>
+          <p:cNvPr id="4" name="图片 3"/>
+          <p:cNvPicPr>
+            <a:picLocks noChangeAspect="1"/>
+          </p:cNvPicPr>
+          <p:nvPr>
+            <p:custDataLst>
+              <p:tags r:id="rId1"/>
+            </p:custDataLst>
+          </p:nvPr>
+        </p:nvPicPr>
+        <p:blipFill>
+          <a:blip r:embed="rId2"/>
+          <a:stretch>
+            <a:fillRect/>
+          </a:stretch>
+        </p:blipFill>
+        <p:spPr>
+          <a:xfrm>
+            <a:off x="6664325" y="2835910"/>
+            <a:ext cx="5265420" cy="4010025"/>
+          </a:xfrm>
+          <a:prstGeom prst="rect">
+            <a:avLst/>
+          </a:prstGeom>
+        </p:spPr>
+      </p:pic>
+      <p:pic>
+        <p:nvPicPr>
+          <p:cNvPr id="7" name="图片 6"/>
+          <p:cNvPicPr>
+            <a:picLocks noChangeAspect="1"/>
+          </p:cNvPicPr>
+          <p:nvPr>
+            <p:custDataLst>
+              <p:tags r:id="rId3"/>
+            </p:custDataLst>
+          </p:nvPr>
+        </p:nvPicPr>
+        <p:blipFill>
+          <a:blip r:embed="rId4"/>
+          <a:stretch>
+            <a:fillRect/>
+          </a:stretch>
+        </p:blipFill>
+        <p:spPr>
+          <a:xfrm>
+            <a:off x="457835" y="2209800"/>
+            <a:ext cx="3124200" cy="596900"/>
+          </a:xfrm>
+          <a:prstGeom prst="rect">
+            <a:avLst/>
+          </a:prstGeom>
+        </p:spPr>
+      </p:pic>
+      <p:pic>
+        <p:nvPicPr>
+          <p:cNvPr id="8" name="图片 7"/>
+          <p:cNvPicPr>
+            <a:picLocks noChangeAspect="1"/>
+          </p:cNvPicPr>
+          <p:nvPr>
+            <p:custDataLst>
+              <p:tags r:id="rId5"/>
+            </p:custDataLst>
+          </p:nvPr>
+        </p:nvPicPr>
+        <p:blipFill>
+          <a:blip r:embed="rId6"/>
+          <a:stretch>
+            <a:fillRect/>
+          </a:stretch>
+        </p:blipFill>
+        <p:spPr>
+          <a:xfrm>
+            <a:off x="510540" y="865505"/>
+            <a:ext cx="3060700" cy="431800"/>
+          </a:xfrm>
+          <a:prstGeom prst="rect">
+            <a:avLst/>
+          </a:prstGeom>
+        </p:spPr>
+      </p:pic>
+      <p:sp>
+        <p:nvSpPr>
+          <p:cNvPr id="13" name="文本框 12"/>
+          <p:cNvSpPr txBox="1"/>
+          <p:nvPr>
+            <p:custDataLst>
+              <p:tags r:id="rId7"/>
+            </p:custDataLst>
+          </p:nvPr>
+        </p:nvSpPr>
+        <p:spPr>
+          <a:xfrm>
+            <a:off x="384175" y="253365"/>
+            <a:ext cx="3509010" cy="575310"/>
+          </a:xfrm>
+          <a:prstGeom prst="rect">
+            <a:avLst/>
+          </a:prstGeom>
+          <a:noFill/>
+        </p:spPr>
+        <p:txBody>
+          <a:bodyPr wrap="square" rtlCol="0">
+            <a:noAutofit/>
+          </a:bodyPr>
+          <a:p>
+            <a:pPr algn="ctr"/>
+            <a:r>
+              <a:rPr lang="zh-CN" altLang="en-US" sz="1200" b="1">
+                <a:latin typeface="微软雅黑" charset="0"/>
+                <a:ea typeface="微软雅黑" charset="0"/>
+                <a:cs typeface="微软雅黑" charset="0"/>
+              </a:rPr>
+              <a:t>对于图像模态的优化</a:t>
+            </a:r>
+            <a:br>
+              <a:rPr lang="zh-CN" altLang="en-US" sz="1200" b="1">
+                <a:latin typeface="微软雅黑" charset="0"/>
+                <a:ea typeface="微软雅黑" charset="0"/>
+                <a:cs typeface="微软雅黑" charset="0"/>
+              </a:rPr>
+            </a:br>
+            <a:r>
+              <a:rPr lang="zh-CN" altLang="en-US" sz="1200" b="1">
+                <a:latin typeface="微软雅黑" charset="0"/>
+                <a:ea typeface="微软雅黑" charset="0"/>
+                <a:cs typeface="微软雅黑" charset="0"/>
+              </a:rPr>
+              <a:t>朝着原图和对抗图像</a:t>
+            </a:r>
+            <a:r>
+              <a:rPr lang="en-US" altLang="zh-CN" sz="1200" b="1">
+                <a:latin typeface="微软雅黑" charset="0"/>
+                <a:ea typeface="微软雅黑" charset="0"/>
+                <a:cs typeface="微软雅黑" charset="0"/>
+              </a:rPr>
+              <a:t>KL</a:t>
+            </a:r>
+            <a:r>
+              <a:rPr lang="zh-CN" altLang="en-US" sz="1200" b="1">
+                <a:latin typeface="微软雅黑" charset="0"/>
+                <a:ea typeface="微软雅黑" charset="0"/>
+                <a:cs typeface="微软雅黑" charset="0"/>
+              </a:rPr>
+              <a:t>散度最大的方向更新扰动</a:t>
+            </a:r>
+            <a:br>
+              <a:rPr lang="zh-CN" altLang="en-US" sz="1200" b="1">
+                <a:latin typeface="微软雅黑" charset="0"/>
+                <a:ea typeface="微软雅黑" charset="0"/>
+                <a:cs typeface="微软雅黑" charset="0"/>
+              </a:rPr>
+            </a:br>
+            <a:r>
+              <a:rPr lang="zh-CN" altLang="en-US" sz="1200" b="1">
+                <a:latin typeface="微软雅黑" charset="0"/>
+                <a:ea typeface="微软雅黑" charset="0"/>
+                <a:cs typeface="微软雅黑" charset="0"/>
+              </a:rPr>
+              <a:t>在单图像</a:t>
+            </a:r>
+            <a:r>
+              <a:rPr lang="zh-CN" altLang="en-US" sz="1200" b="1">
+                <a:latin typeface="微软雅黑" charset="0"/>
+                <a:ea typeface="微软雅黑" charset="0"/>
+                <a:cs typeface="微软雅黑" charset="0"/>
+              </a:rPr>
+              <a:t>特征空间中</a:t>
+            </a:r>
+            <a:endParaRPr lang="zh-CN" altLang="en-US" sz="1200" b="1">
+              <a:latin typeface="微软雅黑" charset="0"/>
+              <a:ea typeface="微软雅黑" charset="0"/>
+              <a:cs typeface="微软雅黑" charset="0"/>
+            </a:endParaRPr>
+          </a:p>
+        </p:txBody>
+      </p:sp>
+      <p:sp>
+        <p:nvSpPr>
+          <p:cNvPr id="9" name="文本框 8"/>
+          <p:cNvSpPr txBox="1"/>
+          <p:nvPr>
+            <p:custDataLst>
+              <p:tags r:id="rId8"/>
+            </p:custDataLst>
+          </p:nvPr>
+        </p:nvSpPr>
+        <p:spPr>
+          <a:xfrm>
+            <a:off x="384175" y="1650365"/>
+            <a:ext cx="3509010" cy="575310"/>
+          </a:xfrm>
+          <a:prstGeom prst="rect">
+            <a:avLst/>
+          </a:prstGeom>
+          <a:noFill/>
+        </p:spPr>
+        <p:txBody>
+          <a:bodyPr wrap="square" rtlCol="0">
+            <a:noAutofit/>
+          </a:bodyPr>
+          <a:p>
+            <a:pPr algn="ctr"/>
+            <a:r>
+              <a:rPr lang="zh-CN" altLang="en-US" sz="1200" b="1">
+                <a:latin typeface="微软雅黑" charset="0"/>
+                <a:ea typeface="微软雅黑" charset="0"/>
+                <a:cs typeface="微软雅黑" charset="0"/>
+              </a:rPr>
+              <a:t>对于文本模态的优化</a:t>
+            </a:r>
+            <a:br>
+              <a:rPr lang="zh-CN" altLang="en-US" sz="1200" b="1">
+                <a:latin typeface="微软雅黑" charset="0"/>
+                <a:ea typeface="微软雅黑" charset="0"/>
+                <a:cs typeface="微软雅黑" charset="0"/>
+              </a:rPr>
+            </a:br>
+            <a:r>
+              <a:rPr lang="zh-CN" altLang="en-US" sz="1200" b="1">
+                <a:latin typeface="微软雅黑" charset="0"/>
+                <a:ea typeface="微软雅黑" charset="0"/>
+                <a:cs typeface="微软雅黑" charset="0"/>
+              </a:rPr>
+              <a:t>找到一个新的文本，让原始</a:t>
+            </a:r>
+            <a:r>
+              <a:rPr lang="zh-CN" altLang="en-US" sz="1200" b="1">
+                <a:latin typeface="微软雅黑" charset="0"/>
+                <a:ea typeface="微软雅黑" charset="0"/>
+                <a:cs typeface="微软雅黑" charset="0"/>
+              </a:rPr>
+              <a:t>文本和新的</a:t>
+            </a:r>
+            <a:r>
+              <a:rPr lang="zh-CN" altLang="en-US" sz="1200" b="1">
+                <a:latin typeface="微软雅黑" charset="0"/>
+                <a:ea typeface="微软雅黑" charset="0"/>
+                <a:cs typeface="微软雅黑" charset="0"/>
+              </a:rPr>
+              <a:t>文本在特征空间中距离</a:t>
+            </a:r>
+            <a:r>
+              <a:rPr lang="zh-CN" altLang="en-US" sz="1200" b="1">
+                <a:latin typeface="微软雅黑" charset="0"/>
+                <a:ea typeface="微软雅黑" charset="0"/>
+                <a:cs typeface="微软雅黑" charset="0"/>
+              </a:rPr>
+              <a:t>最远的方向更新</a:t>
+            </a:r>
+            <a:r>
+              <a:rPr lang="zh-CN" altLang="en-US" sz="1200" b="1">
+                <a:latin typeface="微软雅黑" charset="0"/>
+                <a:ea typeface="微软雅黑" charset="0"/>
+                <a:cs typeface="微软雅黑" charset="0"/>
+              </a:rPr>
+              <a:t>扰动</a:t>
+            </a:r>
+            <a:endParaRPr lang="zh-CN" altLang="en-US" sz="1200" b="1">
+              <a:latin typeface="微软雅黑" charset="0"/>
+              <a:ea typeface="微软雅黑" charset="0"/>
+              <a:cs typeface="微软雅黑" charset="0"/>
+            </a:endParaRPr>
+          </a:p>
+        </p:txBody>
+      </p:sp>
+      <p:pic>
+        <p:nvPicPr>
+          <p:cNvPr id="10" name="图片 9"/>
+          <p:cNvPicPr>
+            <a:picLocks noChangeAspect="1"/>
+          </p:cNvPicPr>
+          <p:nvPr>
+            <p:custDataLst>
+              <p:tags r:id="rId9"/>
+            </p:custDataLst>
+          </p:nvPr>
+        </p:nvPicPr>
+        <p:blipFill>
+          <a:blip r:embed="rId10"/>
+          <a:stretch>
+            <a:fillRect/>
+          </a:stretch>
+        </p:blipFill>
+        <p:spPr>
+          <a:xfrm>
+            <a:off x="6767195" y="2229485"/>
+            <a:ext cx="4927600" cy="571500"/>
+          </a:xfrm>
+          <a:prstGeom prst="rect">
+            <a:avLst/>
+          </a:prstGeom>
+        </p:spPr>
+      </p:pic>
+      <p:pic>
+        <p:nvPicPr>
+          <p:cNvPr id="11" name="图片 10"/>
+          <p:cNvPicPr>
+            <a:picLocks noChangeAspect="1"/>
+          </p:cNvPicPr>
+          <p:nvPr>
+            <p:custDataLst>
+              <p:tags r:id="rId11"/>
+            </p:custDataLst>
+          </p:nvPr>
+        </p:nvPicPr>
+        <p:blipFill>
+          <a:blip r:embed="rId12"/>
+          <a:stretch>
+            <a:fillRect/>
+          </a:stretch>
+        </p:blipFill>
+        <p:spPr>
+          <a:xfrm>
+            <a:off x="6767195" y="815340"/>
+            <a:ext cx="4953000" cy="457200"/>
+          </a:xfrm>
+          <a:prstGeom prst="rect">
+            <a:avLst/>
+          </a:prstGeom>
+        </p:spPr>
+      </p:pic>
+      <p:sp>
+        <p:nvSpPr>
+          <p:cNvPr id="12" name="文本框 11"/>
+          <p:cNvSpPr txBox="1"/>
+          <p:nvPr>
+            <p:custDataLst>
+              <p:tags r:id="rId13"/>
+            </p:custDataLst>
+          </p:nvPr>
+        </p:nvSpPr>
+        <p:spPr>
+          <a:xfrm>
+            <a:off x="7496175" y="253365"/>
+            <a:ext cx="3509010" cy="575310"/>
+          </a:xfrm>
+          <a:prstGeom prst="rect">
+            <a:avLst/>
+          </a:prstGeom>
+          <a:noFill/>
+        </p:spPr>
+        <p:txBody>
+          <a:bodyPr wrap="square" rtlCol="0">
+            <a:noAutofit/>
+          </a:bodyPr>
+          <a:p>
+            <a:pPr algn="ctr"/>
+            <a:r>
+              <a:rPr lang="zh-CN" altLang="en-US" sz="1200" b="1">
+                <a:latin typeface="微软雅黑" charset="0"/>
+                <a:ea typeface="微软雅黑" charset="0"/>
+                <a:cs typeface="微软雅黑" charset="0"/>
+              </a:rPr>
+              <a:t>对于图像模态的优化</a:t>
+            </a:r>
+            <a:br>
+              <a:rPr lang="zh-CN" altLang="en-US" sz="1200" b="1">
+                <a:latin typeface="微软雅黑" charset="0"/>
+                <a:ea typeface="微软雅黑" charset="0"/>
+                <a:cs typeface="微软雅黑" charset="0"/>
+              </a:rPr>
+            </a:br>
+            <a:r>
+              <a:rPr lang="zh-CN" altLang="en-US" sz="1200" b="1">
+                <a:latin typeface="微软雅黑" charset="0"/>
+                <a:ea typeface="微软雅黑" charset="0"/>
+                <a:cs typeface="微软雅黑" charset="0"/>
+              </a:rPr>
+              <a:t>朝着原图和对抗图像</a:t>
+            </a:r>
+            <a:r>
+              <a:rPr lang="en-US" altLang="zh-CN" sz="1200" b="1">
+                <a:latin typeface="微软雅黑" charset="0"/>
+                <a:ea typeface="微软雅黑" charset="0"/>
+                <a:cs typeface="微软雅黑" charset="0"/>
+              </a:rPr>
+              <a:t>KL</a:t>
+            </a:r>
+            <a:r>
+              <a:rPr lang="zh-CN" altLang="en-US" sz="1200" b="1">
+                <a:latin typeface="微软雅黑" charset="0"/>
+                <a:ea typeface="微软雅黑" charset="0"/>
+                <a:cs typeface="微软雅黑" charset="0"/>
+              </a:rPr>
+              <a:t>散度最大的方向更新扰动</a:t>
+            </a:r>
+            <a:br>
+              <a:rPr lang="zh-CN" altLang="en-US" sz="1200" b="1">
+                <a:latin typeface="微软雅黑" charset="0"/>
+                <a:ea typeface="微软雅黑" charset="0"/>
+                <a:cs typeface="微软雅黑" charset="0"/>
+              </a:rPr>
+            </a:br>
+            <a:r>
+              <a:rPr lang="zh-CN" altLang="en-US" sz="1200" b="1">
+                <a:latin typeface="微软雅黑" charset="0"/>
+                <a:ea typeface="微软雅黑" charset="0"/>
+                <a:cs typeface="微软雅黑" charset="0"/>
+              </a:rPr>
+              <a:t>在图文混合</a:t>
+            </a:r>
+            <a:r>
+              <a:rPr lang="zh-CN" altLang="en-US" sz="1200" b="1">
+                <a:latin typeface="微软雅黑" charset="0"/>
+                <a:ea typeface="微软雅黑" charset="0"/>
+                <a:cs typeface="微软雅黑" charset="0"/>
+              </a:rPr>
+              <a:t>特征空间中</a:t>
+            </a:r>
+            <a:endParaRPr lang="zh-CN" altLang="en-US" sz="1200" b="1">
+              <a:latin typeface="微软雅黑" charset="0"/>
+              <a:ea typeface="微软雅黑" charset="0"/>
+              <a:cs typeface="微软雅黑" charset="0"/>
+            </a:endParaRPr>
+          </a:p>
+        </p:txBody>
+      </p:sp>
+      <p:sp>
+        <p:nvSpPr>
+          <p:cNvPr id="15" name="文本框 14"/>
+          <p:cNvSpPr txBox="1"/>
+          <p:nvPr>
+            <p:custDataLst>
+              <p:tags r:id="rId14"/>
+            </p:custDataLst>
+          </p:nvPr>
+        </p:nvSpPr>
+        <p:spPr>
+          <a:xfrm>
+            <a:off x="7623175" y="1650365"/>
+            <a:ext cx="3509010" cy="575310"/>
+          </a:xfrm>
+          <a:prstGeom prst="rect">
+            <a:avLst/>
+          </a:prstGeom>
+          <a:noFill/>
+        </p:spPr>
+        <p:txBody>
+          <a:bodyPr wrap="square" rtlCol="0">
+            <a:noAutofit/>
+          </a:bodyPr>
+          <a:p>
+            <a:pPr algn="ctr"/>
+            <a:r>
+              <a:rPr lang="zh-CN" altLang="en-US" sz="1200" b="1">
+                <a:latin typeface="微软雅黑" charset="0"/>
+                <a:ea typeface="微软雅黑" charset="0"/>
+                <a:cs typeface="微软雅黑" charset="0"/>
+              </a:rPr>
+              <a:t>对于文本模态的优化</a:t>
+            </a:r>
+            <a:br>
+              <a:rPr lang="zh-CN" altLang="en-US" sz="1200" b="1">
+                <a:latin typeface="微软雅黑" charset="0"/>
+                <a:ea typeface="微软雅黑" charset="0"/>
+                <a:cs typeface="微软雅黑" charset="0"/>
+              </a:rPr>
+            </a:br>
+            <a:r>
+              <a:rPr lang="zh-CN" altLang="en-US" sz="1200" b="1">
+                <a:latin typeface="微软雅黑" charset="0"/>
+                <a:ea typeface="微软雅黑" charset="0"/>
+                <a:cs typeface="微软雅黑" charset="0"/>
+              </a:rPr>
+              <a:t>找到一个新的文本，让原始文本和新的文本在</a:t>
+            </a:r>
+            <a:r>
+              <a:rPr lang="zh-CN" altLang="en-US" sz="1200" b="1">
+                <a:solidFill>
+                  <a:srgbClr val="FF0000"/>
+                </a:solidFill>
+                <a:latin typeface="微软雅黑" charset="0"/>
+                <a:ea typeface="微软雅黑" charset="0"/>
+                <a:cs typeface="微软雅黑" charset="0"/>
+              </a:rPr>
+              <a:t>图文混合特征空间</a:t>
+            </a:r>
+            <a:r>
+              <a:rPr lang="zh-CN" altLang="en-US" sz="1200" b="1">
+                <a:latin typeface="微软雅黑" charset="0"/>
+                <a:ea typeface="微软雅黑" charset="0"/>
+                <a:cs typeface="微软雅黑" charset="0"/>
+              </a:rPr>
+              <a:t>中距离</a:t>
+            </a:r>
+            <a:r>
+              <a:rPr lang="zh-CN" altLang="en-US" sz="1200" b="1">
+                <a:latin typeface="微软雅黑" charset="0"/>
+                <a:ea typeface="微软雅黑" charset="0"/>
+                <a:cs typeface="微软雅黑" charset="0"/>
+              </a:rPr>
+              <a:t>最远的方向更新</a:t>
+            </a:r>
+            <a:r>
+              <a:rPr lang="zh-CN" altLang="en-US" sz="1200" b="1">
+                <a:latin typeface="微软雅黑" charset="0"/>
+                <a:ea typeface="微软雅黑" charset="0"/>
+                <a:cs typeface="微软雅黑" charset="0"/>
+              </a:rPr>
+              <a:t>扰动</a:t>
+            </a:r>
+            <a:endParaRPr lang="zh-CN" altLang="en-US" sz="1200" b="1">
+              <a:latin typeface="微软雅黑" charset="0"/>
+              <a:ea typeface="微软雅黑" charset="0"/>
+              <a:cs typeface="微软雅黑" charset="0"/>
+            </a:endParaRPr>
+          </a:p>
+        </p:txBody>
+      </p:sp>
+      <p:sp>
+        <p:nvSpPr>
+          <p:cNvPr id="16" name="右箭头 15"/>
+          <p:cNvSpPr/>
+          <p:nvPr/>
+        </p:nvSpPr>
+        <p:spPr>
+          <a:xfrm>
+            <a:off x="5289550" y="1268730"/>
+            <a:ext cx="602615" cy="344170"/>
+          </a:xfrm>
+          <a:prstGeom prst="rightArrow">
+            <a:avLst/>
+          </a:prstGeom>
+        </p:spPr>
+        <p:style>
+          <a:lnRef idx="2">
+            <a:schemeClr val="accent1">
+              <a:lumMod val="75000"/>
+            </a:schemeClr>
+          </a:lnRef>
+          <a:fillRef idx="1">
+            <a:schemeClr val="accent1"/>
+          </a:fillRef>
+          <a:effectRef idx="0">
+            <a:srgbClr val="FFFFFF"/>
+          </a:effectRef>
+          <a:fontRef idx="minor">
+            <a:schemeClr val="lt1"/>
+          </a:fontRef>
+        </p:style>
+        <p:txBody>
+          <a:bodyPr rtlCol="0" anchor="ctr"/>
+          <a:p>
+            <a:pPr algn="ctr"/>
+            <a:endParaRPr lang="zh-CN" altLang="en-US"/>
+          </a:p>
+        </p:txBody>
+      </p:sp>
+      <p:sp>
+        <p:nvSpPr>
+          <p:cNvPr id="17" name="文本框 16"/>
+          <p:cNvSpPr txBox="1"/>
+          <p:nvPr>
+            <p:custDataLst>
+              <p:tags r:id="rId15"/>
+            </p:custDataLst>
+          </p:nvPr>
+        </p:nvSpPr>
+        <p:spPr>
+          <a:xfrm>
+            <a:off x="3469640" y="3429000"/>
+            <a:ext cx="3509010" cy="1005205"/>
+          </a:xfrm>
+          <a:prstGeom prst="rect">
+            <a:avLst/>
+          </a:prstGeom>
+          <a:noFill/>
+        </p:spPr>
+        <p:txBody>
+          <a:bodyPr wrap="square" rtlCol="0">
+            <a:noAutofit/>
+          </a:bodyPr>
+          <a:p>
+            <a:pPr algn="ctr"/>
+            <a:r>
+              <a:rPr lang="zh-CN" altLang="en-US" sz="1200" b="1">
+                <a:latin typeface="微软雅黑" charset="0"/>
+                <a:ea typeface="微软雅黑" charset="0"/>
+                <a:cs typeface="微软雅黑" charset="0"/>
+              </a:rPr>
+              <a:t>对于单模态攻击</a:t>
+            </a:r>
+            <a:br>
+              <a:rPr lang="zh-CN" altLang="en-US" sz="1200" b="1">
+                <a:latin typeface="微软雅黑" charset="0"/>
+                <a:ea typeface="微软雅黑" charset="0"/>
+                <a:cs typeface="微软雅黑" charset="0"/>
+              </a:rPr>
+            </a:br>
+            <a:r>
+              <a:rPr lang="zh-CN" altLang="en-US" sz="1200" b="1">
+                <a:latin typeface="微软雅黑" charset="0"/>
+                <a:ea typeface="微软雅黑" charset="0"/>
+                <a:cs typeface="微软雅黑" charset="0"/>
+              </a:rPr>
+              <a:t>对于图像模态，攻击整图</a:t>
+            </a:r>
+            <a:r>
+              <a:rPr lang="en-US" altLang="zh-CN" sz="1200" b="1">
+                <a:latin typeface="微软雅黑" charset="0"/>
+                <a:ea typeface="微软雅黑" charset="0"/>
+                <a:cs typeface="微软雅黑" charset="0"/>
+              </a:rPr>
+              <a:t>embed&gt;</a:t>
+            </a:r>
+            <a:r>
+              <a:rPr lang="zh-CN" altLang="en-US" sz="1200" b="1">
+                <a:latin typeface="微软雅黑" charset="0"/>
+                <a:ea typeface="微软雅黑" charset="0"/>
+                <a:cs typeface="微软雅黑" charset="0"/>
+              </a:rPr>
+              <a:t>攻击</a:t>
+            </a:r>
+            <a:r>
+              <a:rPr lang="en-US" altLang="zh-CN" sz="1200" b="1">
+                <a:latin typeface="微软雅黑" charset="0"/>
+                <a:ea typeface="微软雅黑" charset="0"/>
+                <a:cs typeface="微软雅黑" charset="0"/>
+              </a:rPr>
+              <a:t>CLS</a:t>
             </a:r>
             <a:endParaRPr lang="en-US" altLang="zh-CN" sz="1200" b="1">
               <a:latin typeface="微软雅黑" charset="0"/>
@@ -7252,41 +8905,102 @@
               <a:cs typeface="微软雅黑" charset="0"/>
             </a:endParaRPr>
           </a:p>
-        </p:txBody>
-      </p:sp>
-      <p:sp>
-        <p:nvSpPr>
-          <p:cNvPr id="21" name="文本框 20"/>
-          <p:cNvSpPr txBox="1"/>
-          <p:nvPr>
-            <p:custDataLst>
-              <p:tags r:id="rId21"/>
-            </p:custDataLst>
-          </p:nvPr>
-        </p:nvSpPr>
-        <p:spPr>
-          <a:xfrm>
-            <a:off x="4723130" y="4855845"/>
-            <a:ext cx="2799715" cy="575310"/>
-          </a:xfrm>
-          <a:prstGeom prst="rect">
-            <a:avLst/>
-          </a:prstGeom>
-          <a:noFill/>
-        </p:spPr>
-        <p:txBody>
-          <a:bodyPr wrap="square" rtlCol="0">
-            <a:noAutofit/>
-          </a:bodyPr>
           <a:p>
             <a:pPr algn="ctr"/>
             <a:r>
+              <a:rPr lang="zh-CN" altLang="en-US" sz="1200" b="1">
+                <a:latin typeface="微软雅黑" charset="0"/>
+                <a:ea typeface="微软雅黑" charset="0"/>
+                <a:cs typeface="微软雅黑" charset="0"/>
+              </a:rPr>
+              <a:t>对于文本模态，攻击文本</a:t>
+            </a:r>
+            <a:r>
               <a:rPr lang="en-US" altLang="zh-CN" sz="1200" b="1">
                 <a:latin typeface="微软雅黑" charset="0"/>
                 <a:ea typeface="微软雅黑" charset="0"/>
                 <a:cs typeface="微软雅黑" charset="0"/>
               </a:rPr>
-              <a:t>MF-ii</a:t>
+              <a:t>embed&lt;</a:t>
+            </a:r>
+            <a:r>
+              <a:rPr lang="zh-CN" altLang="en-US" sz="1200" b="1">
+                <a:latin typeface="微软雅黑" charset="0"/>
+                <a:ea typeface="微软雅黑" charset="0"/>
+                <a:cs typeface="微软雅黑" charset="0"/>
+              </a:rPr>
+              <a:t>攻击</a:t>
+            </a:r>
+            <a:r>
+              <a:rPr lang="en-US" altLang="zh-CN" sz="1200" b="1">
+                <a:latin typeface="微软雅黑" charset="0"/>
+                <a:ea typeface="微软雅黑" charset="0"/>
+                <a:cs typeface="微软雅黑" charset="0"/>
+              </a:rPr>
+              <a:t>CLS</a:t>
+            </a:r>
+            <a:br>
+              <a:rPr lang="en-US" altLang="zh-CN" sz="1200" b="1">
+                <a:latin typeface="微软雅黑" charset="0"/>
+                <a:ea typeface="微软雅黑" charset="0"/>
+                <a:cs typeface="微软雅黑" charset="0"/>
+              </a:rPr>
+            </a:br>
+            <a:r>
+              <a:rPr lang="zh-CN" altLang="en-US" sz="1200" b="1">
+                <a:latin typeface="微软雅黑" charset="0"/>
+                <a:ea typeface="微软雅黑" charset="0"/>
+                <a:cs typeface="微软雅黑" charset="0"/>
+              </a:rPr>
+              <a:t>对于混合模态</a:t>
+            </a:r>
+            <a:r>
+              <a:rPr lang="zh-CN" altLang="en-US" sz="1200" b="1">
+                <a:latin typeface="微软雅黑" charset="0"/>
+                <a:ea typeface="微软雅黑" charset="0"/>
+                <a:cs typeface="微软雅黑" charset="0"/>
+              </a:rPr>
+              <a:t>攻击</a:t>
+            </a:r>
+            <a:endParaRPr lang="zh-CN" altLang="en-US" sz="1200" b="1">
+              <a:latin typeface="微软雅黑" charset="0"/>
+              <a:ea typeface="微软雅黑" charset="0"/>
+              <a:cs typeface="微软雅黑" charset="0"/>
+            </a:endParaRPr>
+          </a:p>
+          <a:p>
+            <a:pPr algn="ctr"/>
+            <a:r>
+              <a:rPr lang="zh-CN" altLang="en-US" sz="1200" b="1">
+                <a:latin typeface="微软雅黑" charset="0"/>
+                <a:ea typeface="微软雅黑" charset="0"/>
+                <a:cs typeface="微软雅黑" charset="0"/>
+              </a:rPr>
+              <a:t>不攻击</a:t>
+            </a:r>
+            <a:r>
+              <a:rPr lang="en-US" altLang="zh-CN" sz="1200" b="1">
+                <a:latin typeface="微软雅黑" charset="0"/>
+                <a:ea typeface="微软雅黑" charset="0"/>
+                <a:cs typeface="微软雅黑" charset="0"/>
+              </a:rPr>
+              <a:t>CLS</a:t>
+            </a:r>
+            <a:r>
+              <a:rPr lang="zh-CN" altLang="en-US" sz="1200" b="1">
+                <a:latin typeface="微软雅黑" charset="0"/>
+                <a:ea typeface="微软雅黑" charset="0"/>
+                <a:cs typeface="微软雅黑" charset="0"/>
+              </a:rPr>
+              <a:t>，对图像和文本都攻击全部</a:t>
+            </a:r>
+            <a:r>
+              <a:rPr lang="en-US" altLang="zh-CN" sz="1200" b="1">
+                <a:latin typeface="微软雅黑" charset="0"/>
+                <a:ea typeface="微软雅黑" charset="0"/>
+                <a:cs typeface="微软雅黑" charset="0"/>
+              </a:rPr>
+              <a:t>embed</a:t>
             </a:r>
             <a:endParaRPr lang="en-US" altLang="zh-CN" sz="1200" b="1">
               <a:latin typeface="微软雅黑" charset="0"/>
@@ -7298,18 +9012,66 @@
       </p:sp>
       <p:sp>
         <p:nvSpPr>
-          <p:cNvPr id="22" name="文本框 21"/>
+          <p:cNvPr id="27" name="矩形: 圆角 36"/>
+          <p:cNvSpPr/>
+          <p:nvPr>
+            <p:custDataLst>
+              <p:tags r:id="rId16"/>
+            </p:custDataLst>
+          </p:nvPr>
+        </p:nvSpPr>
+        <p:spPr>
+          <a:xfrm rot="10800000" flipV="1">
+            <a:off x="405130" y="132715"/>
+            <a:ext cx="3695700" cy="2673985"/>
+          </a:xfrm>
+          <a:prstGeom prst="roundRect">
+            <a:avLst>
+              <a:gd name="adj" fmla="val 10039"/>
+            </a:avLst>
+          </a:prstGeom>
+          <a:noFill/>
+          <a:ln w="38100">
+            <a:solidFill>
+              <a:schemeClr val="tx1"/>
+            </a:solidFill>
+            <a:prstDash val="lgDash"/>
+          </a:ln>
+        </p:spPr>
+        <p:style>
+          <a:lnRef idx="2">
+            <a:schemeClr val="accent1">
+              <a:shade val="15000"/>
+            </a:schemeClr>
+          </a:lnRef>
+          <a:fillRef idx="1">
+            <a:schemeClr val="accent1"/>
+          </a:fillRef>
+          <a:effectRef idx="0">
+            <a:schemeClr val="accent1"/>
+          </a:effectRef>
+          <a:fontRef idx="minor">
+            <a:schemeClr val="lt1"/>
+          </a:fontRef>
+        </p:style>
+        <p:txBody>
+          <a:bodyPr rtlCol="0" anchor="ctr"/>
+          <a:p>
+            <a:pPr algn="ctr"/>
+            <a:endParaRPr lang="zh-CN" altLang="en-US"/>
+          </a:p>
+        </p:txBody>
+      </p:sp>
+      <p:sp>
+        <p:nvSpPr>
+          <p:cNvPr id="18" name="文本框 17"/>
           <p:cNvSpPr txBox="1"/>
-          <p:nvPr>
-            <p:custDataLst>
-              <p:tags r:id="rId22"/>
-            </p:custDataLst>
-          </p:nvPr>
+          <p:nvPr/>
         </p:nvSpPr>
         <p:spPr>
           <a:xfrm>
-            <a:off x="8914130" y="4855845"/>
-            <a:ext cx="2799715" cy="575310"/>
+            <a:off x="405130" y="1272540"/>
+            <a:ext cx="3695700" cy="368300"/>
           </a:xfrm>
           <a:prstGeom prst="rect">
             <a:avLst/>
@@ -7318,17 +9080,188 @@
         </p:spPr>
         <p:txBody>
           <a:bodyPr wrap="square" rtlCol="0">
+            <a:spAutoFit/>
+          </a:bodyPr>
+          <a:p>
+            <a:pPr algn="ctr"/>
+            <a:r>
+              <a:rPr lang="zh-CN" altLang="en-US" b="1">
+                <a:latin typeface="微软雅黑" charset="0"/>
+                <a:ea typeface="微软雅黑" charset="0"/>
+              </a:rPr>
+              <a:t>单模态攻击</a:t>
+            </a:r>
+            <a:endParaRPr lang="zh-CN" altLang="en-US" b="1">
+              <a:latin typeface="微软雅黑" charset="0"/>
+              <a:ea typeface="微软雅黑" charset="0"/>
+            </a:endParaRPr>
+          </a:p>
+        </p:txBody>
+      </p:sp>
+      <p:sp>
+        <p:nvSpPr>
+          <p:cNvPr id="19" name="文本框 18"/>
+          <p:cNvSpPr txBox="1"/>
+          <p:nvPr>
+            <p:custDataLst>
+              <p:tags r:id="rId17"/>
+            </p:custDataLst>
+          </p:nvPr>
+        </p:nvSpPr>
+        <p:spPr>
+          <a:xfrm>
+            <a:off x="7517130" y="1272540"/>
+            <a:ext cx="3695700" cy="368300"/>
+          </a:xfrm>
+          <a:prstGeom prst="rect">
+            <a:avLst/>
+          </a:prstGeom>
+          <a:noFill/>
+        </p:spPr>
+        <p:txBody>
+          <a:bodyPr wrap="square" rtlCol="0">
+            <a:spAutoFit/>
+          </a:bodyPr>
+          <a:p>
+            <a:pPr algn="ctr"/>
+            <a:r>
+              <a:rPr lang="zh-CN" altLang="en-US" b="1">
+                <a:latin typeface="微软雅黑" charset="0"/>
+                <a:ea typeface="微软雅黑" charset="0"/>
+              </a:rPr>
+              <a:t>混合模态攻击</a:t>
+            </a:r>
+            <a:endParaRPr lang="zh-CN" altLang="en-US" b="1">
+              <a:latin typeface="微软雅黑" charset="0"/>
+              <a:ea typeface="微软雅黑" charset="0"/>
+            </a:endParaRPr>
+          </a:p>
+        </p:txBody>
+      </p:sp>
+      <p:sp>
+        <p:nvSpPr>
+          <p:cNvPr id="20" name="矩形: 圆角 36"/>
+          <p:cNvSpPr/>
+          <p:nvPr>
+            <p:custDataLst>
+              <p:tags r:id="rId18"/>
+            </p:custDataLst>
+          </p:nvPr>
+        </p:nvSpPr>
+        <p:spPr>
+          <a:xfrm rot="10800000" flipV="1">
+            <a:off x="6767195" y="253365"/>
+            <a:ext cx="5059680" cy="2548255"/>
+          </a:xfrm>
+          <a:prstGeom prst="roundRect">
+            <a:avLst>
+              <a:gd name="adj" fmla="val 10039"/>
+            </a:avLst>
+          </a:prstGeom>
+          <a:noFill/>
+          <a:ln w="38100">
+            <a:solidFill>
+              <a:schemeClr val="tx1"/>
+            </a:solidFill>
+            <a:prstDash val="lgDash"/>
+          </a:ln>
+        </p:spPr>
+        <p:style>
+          <a:lnRef idx="2">
+            <a:schemeClr val="accent1">
+              <a:shade val="15000"/>
+            </a:schemeClr>
+          </a:lnRef>
+          <a:fillRef idx="1">
+            <a:schemeClr val="accent1"/>
+          </a:fillRef>
+          <a:effectRef idx="0">
+            <a:schemeClr val="accent1"/>
+          </a:effectRef>
+          <a:fontRef idx="minor">
+            <a:schemeClr val="lt1"/>
+          </a:fontRef>
+        </p:style>
+        <p:txBody>
+          <a:bodyPr rtlCol="0" anchor="ctr"/>
+          <a:p>
+            <a:pPr algn="ctr"/>
+            <a:endParaRPr lang="zh-CN" altLang="en-US"/>
+          </a:p>
+        </p:txBody>
+      </p:sp>
+      <p:sp>
+        <p:nvSpPr>
+          <p:cNvPr id="21" name="文本框 20"/>
+          <p:cNvSpPr txBox="1"/>
+          <p:nvPr>
+            <p:custDataLst>
+              <p:tags r:id="rId19"/>
+            </p:custDataLst>
+          </p:nvPr>
+        </p:nvSpPr>
+        <p:spPr>
+          <a:xfrm>
+            <a:off x="3435350" y="5046345"/>
+            <a:ext cx="3509010" cy="1005205"/>
+          </a:xfrm>
+          <a:prstGeom prst="rect">
+            <a:avLst/>
+          </a:prstGeom>
+          <a:noFill/>
+        </p:spPr>
+        <p:txBody>
+          <a:bodyPr wrap="square" rtlCol="0">
             <a:noAutofit/>
           </a:bodyPr>
           <a:p>
             <a:pPr algn="ctr"/>
             <a:r>
+              <a:rPr lang="zh-CN" altLang="en-US" sz="1200" b="1">
+                <a:latin typeface="微软雅黑" charset="0"/>
+                <a:ea typeface="微软雅黑" charset="0"/>
+                <a:cs typeface="微软雅黑" charset="0"/>
+              </a:rPr>
+              <a:t>单双流在面对混合模态攻击的鲁棒性差不多</a:t>
+            </a:r>
+            <a:br>
+              <a:rPr lang="zh-CN" altLang="en-US" sz="1200" b="1">
+                <a:latin typeface="微软雅黑" charset="0"/>
+                <a:ea typeface="微软雅黑" charset="0"/>
+                <a:cs typeface="微软雅黑" charset="0"/>
+              </a:rPr>
+            </a:br>
+            <a:r>
+              <a:rPr lang="zh-CN" altLang="en-US" sz="1200" b="1">
+                <a:latin typeface="微软雅黑" charset="0"/>
+                <a:ea typeface="微软雅黑" charset="0"/>
+                <a:cs typeface="微软雅黑" charset="0"/>
+              </a:rPr>
+              <a:t>在视觉模态中</a:t>
+            </a:r>
+            <a:r>
               <a:rPr lang="en-US" altLang="zh-CN" sz="1200" b="1">
                 <a:latin typeface="微软雅黑" charset="0"/>
                 <a:ea typeface="微软雅黑" charset="0"/>
                 <a:cs typeface="微软雅黑" charset="0"/>
               </a:rPr>
-              <a:t>MF-tt</a:t>
+              <a:t>CLIP_vit</a:t>
+            </a:r>
+            <a:r>
+              <a:rPr lang="zh-CN" altLang="en-US" sz="1200" b="1">
+                <a:latin typeface="微软雅黑" charset="0"/>
+                <a:ea typeface="微软雅黑" charset="0"/>
+                <a:cs typeface="微软雅黑" charset="0"/>
+              </a:rPr>
+              <a:t>的鲁棒性</a:t>
+            </a:r>
+            <a:r>
+              <a:rPr lang="en-US" altLang="zh-CN" sz="1200" b="1">
+                <a:latin typeface="微软雅黑" charset="0"/>
+                <a:ea typeface="微软雅黑" charset="0"/>
+                <a:cs typeface="微软雅黑" charset="0"/>
+              </a:rPr>
+              <a:t>&gt;CLIP_cnn</a:t>
             </a:r>
             <a:endParaRPr lang="en-US" altLang="zh-CN" sz="1200" b="1">
               <a:latin typeface="微软雅黑" charset="0"/>
@@ -7340,18 +9273,70 @@
       </p:sp>
       <p:sp>
         <p:nvSpPr>
+          <p:cNvPr id="22" name="矩形: 圆角 36"/>
+          <p:cNvSpPr/>
+          <p:nvPr>
+            <p:custDataLst>
+              <p:tags r:id="rId20"/>
+            </p:custDataLst>
+          </p:nvPr>
+        </p:nvSpPr>
+        <p:spPr>
+          <a:xfrm rot="10800000" flipV="1">
+            <a:off x="3326130" y="3307715"/>
+            <a:ext cx="3695700" cy="2673985"/>
+          </a:xfrm>
+          <a:prstGeom prst="roundRect">
+            <a:avLst>
+              <a:gd name="adj" fmla="val 10039"/>
+            </a:avLst>
+          </a:prstGeom>
+          <a:noFill/>
+          <a:ln w="38100">
+            <a:solidFill>
+              <a:schemeClr val="tx1"/>
+            </a:solidFill>
+            <a:prstDash val="lgDash"/>
+          </a:ln>
+        </p:spPr>
+        <p:style>
+          <a:lnRef idx="2">
+            <a:schemeClr val="accent1">
+              <a:shade val="15000"/>
+            </a:schemeClr>
+          </a:lnRef>
+          <a:fillRef idx="1">
+            <a:schemeClr val="accent1"/>
+          </a:fillRef>
+          <a:effectRef idx="0">
+            <a:schemeClr val="accent1"/>
+          </a:effectRef>
+          <a:fontRef idx="minor">
+            <a:schemeClr val="lt1"/>
+          </a:fontRef>
+        </p:style>
+        <p:txBody>
+          <a:bodyPr rtlCol="0" anchor="ctr"/>
+          <a:p>
+            <a:pPr algn="ctr"/>
+            <a:endParaRPr lang="zh-CN" altLang="en-US"/>
+          </a:p>
+        </p:txBody>
+      </p:sp>
+      <p:sp>
+        <p:nvSpPr>
           <p:cNvPr id="23" name="文本框 22"/>
           <p:cNvSpPr txBox="1"/>
           <p:nvPr>
             <p:custDataLst>
-              <p:tags r:id="rId23"/>
+              <p:tags r:id="rId21"/>
             </p:custDataLst>
           </p:nvPr>
         </p:nvSpPr>
         <p:spPr>
           <a:xfrm>
-            <a:off x="659130" y="5490845"/>
-            <a:ext cx="2799715" cy="575310"/>
+            <a:off x="3326130" y="4574540"/>
+            <a:ext cx="3695700" cy="368300"/>
           </a:xfrm>
           <a:prstGeom prst="rect">
             <a:avLst/>
@@ -7360,287 +9345,27 @@
         </p:spPr>
         <p:txBody>
           <a:bodyPr wrap="square" rtlCol="0">
-            <a:noAutofit/>
+            <a:spAutoFit/>
           </a:bodyPr>
           <a:p>
             <a:pPr algn="ctr"/>
             <a:r>
-              <a:rPr lang="zh-CN" altLang="en-US" sz="1200" b="1">
-                <a:latin typeface="微软雅黑" charset="0"/>
-                <a:ea typeface="微软雅黑" charset="0"/>
-                <a:cs typeface="微软雅黑" charset="0"/>
-              </a:rPr>
-              <a:t>第一种</a:t>
-            </a:r>
-            <a:r>
-              <a:rPr lang="en-US" altLang="zh-CN" sz="1200" b="1">
-                <a:latin typeface="微软雅黑" charset="0"/>
-                <a:ea typeface="微软雅黑" charset="0"/>
-                <a:cs typeface="微软雅黑" charset="0"/>
-              </a:rPr>
-              <a:t> </a:t>
-            </a:r>
-            <a:r>
-              <a:rPr lang="zh-CN" altLang="en-US" sz="1200" b="1">
-                <a:latin typeface="微软雅黑" charset="0"/>
-                <a:ea typeface="微软雅黑" charset="0"/>
-                <a:cs typeface="微软雅黑" charset="0"/>
-              </a:rPr>
-              <a:t>第一步</a:t>
-            </a:r>
-            <a:r>
-              <a:rPr lang="en-US" altLang="zh-CN" sz="1200" b="1">
-                <a:latin typeface="微软雅黑" charset="0"/>
-                <a:ea typeface="微软雅黑" charset="0"/>
-                <a:cs typeface="微软雅黑" charset="0"/>
-              </a:rPr>
-              <a:t> </a:t>
-            </a:r>
-            <a:r>
-              <a:rPr lang="zh-CN" altLang="en-US" sz="1200" b="1">
-                <a:latin typeface="微软雅黑" charset="0"/>
-                <a:ea typeface="微软雅黑" charset="0"/>
-                <a:cs typeface="微软雅黑" charset="0"/>
-              </a:rPr>
-              <a:t>图像左侧</a:t>
-            </a:r>
-            <a:br>
-              <a:rPr lang="zh-CN" altLang="en-US" sz="1200" b="1">
-                <a:latin typeface="微软雅黑" charset="0"/>
-                <a:ea typeface="微软雅黑" charset="0"/>
-                <a:cs typeface="微软雅黑" charset="0"/>
-              </a:rPr>
-            </a:br>
-            <a:r>
-              <a:rPr lang="zh-CN" altLang="en-US" sz="1200" b="1">
-                <a:latin typeface="微软雅黑" charset="0"/>
-                <a:ea typeface="微软雅黑" charset="0"/>
-                <a:cs typeface="微软雅黑" charset="0"/>
-              </a:rPr>
-              <a:t>让锚点文本和扰动图像特征内积</a:t>
-            </a:r>
-            <a:r>
-              <a:rPr lang="zh-CN" altLang="en-US" sz="1200" b="1">
-                <a:latin typeface="微软雅黑" charset="0"/>
-                <a:ea typeface="微软雅黑" charset="0"/>
-                <a:cs typeface="微软雅黑" charset="0"/>
-              </a:rPr>
-              <a:t>最大化</a:t>
-            </a:r>
-            <a:endParaRPr lang="zh-CN" altLang="en-US" sz="1200" b="1">
+              <a:rPr lang="zh-CN" altLang="en-US" b="1">
+                <a:latin typeface="微软雅黑" charset="0"/>
+                <a:ea typeface="微软雅黑" charset="0"/>
+              </a:rPr>
+              <a:t>观察</a:t>
+            </a:r>
+            <a:r>
+              <a:rPr lang="zh-CN" altLang="en-US" b="1">
+                <a:latin typeface="微软雅黑" charset="0"/>
+                <a:ea typeface="微软雅黑" charset="0"/>
+              </a:rPr>
+              <a:t>结论</a:t>
+            </a:r>
+            <a:endParaRPr lang="zh-CN" altLang="en-US" b="1">
               <a:latin typeface="微软雅黑" charset="0"/>
               <a:ea typeface="微软雅黑" charset="0"/>
-              <a:cs typeface="微软雅黑" charset="0"/>
-            </a:endParaRPr>
-          </a:p>
-        </p:txBody>
-      </p:sp>
-      <p:sp>
-        <p:nvSpPr>
-          <p:cNvPr id="24" name="文本框 23"/>
-          <p:cNvSpPr txBox="1"/>
-          <p:nvPr>
-            <p:custDataLst>
-              <p:tags r:id="rId24"/>
-            </p:custDataLst>
-          </p:nvPr>
-        </p:nvSpPr>
-        <p:spPr>
-          <a:xfrm>
-            <a:off x="4518660" y="5490845"/>
-            <a:ext cx="3463290" cy="575310"/>
-          </a:xfrm>
-          <a:prstGeom prst="rect">
-            <a:avLst/>
-          </a:prstGeom>
-          <a:noFill/>
-        </p:spPr>
-        <p:txBody>
-          <a:bodyPr wrap="square" rtlCol="0">
-            <a:noAutofit/>
-          </a:bodyPr>
-          <a:p>
-            <a:pPr algn="ctr"/>
-            <a:r>
-              <a:rPr lang="zh-CN" altLang="en-US" sz="1200" b="1">
-                <a:latin typeface="微软雅黑" charset="0"/>
-                <a:ea typeface="微软雅黑" charset="0"/>
-                <a:cs typeface="微软雅黑" charset="0"/>
-              </a:rPr>
-              <a:t>第二种</a:t>
-            </a:r>
-            <a:r>
-              <a:rPr lang="en-US" altLang="zh-CN" sz="1200" b="1">
-                <a:latin typeface="微软雅黑" charset="0"/>
-                <a:ea typeface="微软雅黑" charset="0"/>
-                <a:cs typeface="微软雅黑" charset="0"/>
-              </a:rPr>
-              <a:t> </a:t>
-            </a:r>
-            <a:r>
-              <a:rPr lang="zh-CN" altLang="en-US" sz="1200" b="1">
-                <a:latin typeface="微软雅黑" charset="0"/>
-                <a:ea typeface="微软雅黑" charset="0"/>
-                <a:cs typeface="微软雅黑" charset="0"/>
-              </a:rPr>
-              <a:t>第一步</a:t>
-            </a:r>
-            <a:r>
-              <a:rPr lang="en-US" altLang="zh-CN" sz="1200" b="1">
-                <a:latin typeface="微软雅黑" charset="0"/>
-                <a:ea typeface="微软雅黑" charset="0"/>
-                <a:cs typeface="微软雅黑" charset="0"/>
-              </a:rPr>
-              <a:t> </a:t>
-            </a:r>
-            <a:r>
-              <a:rPr lang="zh-CN" altLang="en-US" sz="1200" b="1">
-                <a:latin typeface="微软雅黑" charset="0"/>
-                <a:ea typeface="微软雅黑" charset="0"/>
-                <a:cs typeface="微软雅黑" charset="0"/>
-              </a:rPr>
-              <a:t>图像左侧</a:t>
-            </a:r>
-            <a:br>
-              <a:rPr lang="zh-CN" altLang="en-US" sz="1200" b="1">
-                <a:latin typeface="微软雅黑" charset="0"/>
-                <a:ea typeface="微软雅黑" charset="0"/>
-                <a:cs typeface="微软雅黑" charset="0"/>
-              </a:rPr>
-            </a:br>
-            <a:r>
-              <a:rPr lang="zh-CN" altLang="en-US" sz="1200" b="1">
-                <a:latin typeface="微软雅黑" charset="0"/>
-                <a:ea typeface="微软雅黑" charset="0"/>
-                <a:cs typeface="微软雅黑" charset="0"/>
-              </a:rPr>
-              <a:t>让锚点文本生成的图像和扰动图像内积最大</a:t>
-            </a:r>
-            <a:r>
-              <a:rPr lang="zh-CN" altLang="en-US" sz="1200" b="1">
-                <a:latin typeface="微软雅黑" charset="0"/>
-                <a:ea typeface="微软雅黑" charset="0"/>
-                <a:cs typeface="微软雅黑" charset="0"/>
-              </a:rPr>
-              <a:t>化</a:t>
-            </a:r>
-            <a:endParaRPr lang="zh-CN" altLang="en-US" sz="1200" b="1">
-              <a:latin typeface="微软雅黑" charset="0"/>
-              <a:ea typeface="微软雅黑" charset="0"/>
-              <a:cs typeface="微软雅黑" charset="0"/>
-            </a:endParaRPr>
-          </a:p>
-        </p:txBody>
-      </p:sp>
-      <p:sp>
-        <p:nvSpPr>
-          <p:cNvPr id="25" name="文本框 24"/>
-          <p:cNvSpPr txBox="1"/>
-          <p:nvPr>
-            <p:custDataLst>
-              <p:tags r:id="rId25"/>
-            </p:custDataLst>
-          </p:nvPr>
-        </p:nvSpPr>
-        <p:spPr>
-          <a:xfrm>
-            <a:off x="8582660" y="5490845"/>
-            <a:ext cx="3463290" cy="575310"/>
-          </a:xfrm>
-          <a:prstGeom prst="rect">
-            <a:avLst/>
-          </a:prstGeom>
-          <a:noFill/>
-        </p:spPr>
-        <p:txBody>
-          <a:bodyPr wrap="square" rtlCol="0">
-            <a:noAutofit/>
-          </a:bodyPr>
-          <a:p>
-            <a:pPr algn="ctr"/>
-            <a:r>
-              <a:rPr lang="zh-CN" altLang="en-US" sz="1200" b="1">
-                <a:latin typeface="微软雅黑" charset="0"/>
-                <a:ea typeface="微软雅黑" charset="0"/>
-                <a:cs typeface="微软雅黑" charset="0"/>
-              </a:rPr>
-              <a:t>第二步</a:t>
-            </a:r>
-            <a:r>
-              <a:rPr lang="en-US" altLang="zh-CN" sz="1200" b="1">
-                <a:latin typeface="微软雅黑" charset="0"/>
-                <a:ea typeface="微软雅黑" charset="0"/>
-                <a:cs typeface="微软雅黑" charset="0"/>
-              </a:rPr>
-              <a:t> </a:t>
-            </a:r>
-            <a:r>
-              <a:rPr lang="zh-CN" altLang="en-US" sz="1200" b="1">
-                <a:latin typeface="微软雅黑" charset="0"/>
-                <a:ea typeface="微软雅黑" charset="0"/>
-                <a:cs typeface="微软雅黑" charset="0"/>
-              </a:rPr>
-              <a:t>图像右侧</a:t>
-            </a:r>
-            <a:br>
-              <a:rPr lang="zh-CN" altLang="en-US" sz="1200" b="1">
-                <a:latin typeface="微软雅黑" charset="0"/>
-                <a:ea typeface="微软雅黑" charset="0"/>
-                <a:cs typeface="微软雅黑" charset="0"/>
-              </a:rPr>
-            </a:br>
-            <a:r>
-              <a:rPr lang="zh-CN" altLang="en-US" sz="1200" b="1">
-                <a:latin typeface="微软雅黑" charset="0"/>
-                <a:ea typeface="微软雅黑" charset="0"/>
-                <a:cs typeface="微软雅黑" charset="0"/>
-              </a:rPr>
-              <a:t>让输入</a:t>
-            </a:r>
-            <a:r>
-              <a:rPr lang="en-US" altLang="zh-CN" sz="1200" b="1">
-                <a:latin typeface="微软雅黑" charset="0"/>
-                <a:ea typeface="微软雅黑" charset="0"/>
-                <a:cs typeface="微软雅黑" charset="0"/>
-              </a:rPr>
-              <a:t>VLM</a:t>
-            </a:r>
-            <a:r>
-              <a:rPr lang="zh-CN" altLang="en-US" sz="1200" b="1">
-                <a:latin typeface="微软雅黑" charset="0"/>
-                <a:ea typeface="微软雅黑" charset="0"/>
-                <a:cs typeface="微软雅黑" charset="0"/>
-              </a:rPr>
-              <a:t>的由第一步生成的扰动图像和文本生成的</a:t>
-            </a:r>
-            <a:r>
-              <a:rPr lang="en-US" altLang="zh-CN" sz="1200" b="1">
-                <a:latin typeface="微软雅黑" charset="0"/>
-                <a:ea typeface="微软雅黑" charset="0"/>
-                <a:cs typeface="微软雅黑" charset="0"/>
-              </a:rPr>
-              <a:t>LLM</a:t>
-            </a:r>
-            <a:r>
-              <a:rPr lang="zh-CN" altLang="en-US" sz="1200" b="1">
-                <a:latin typeface="微软雅黑" charset="0"/>
-                <a:ea typeface="微软雅黑" charset="0"/>
-                <a:cs typeface="微软雅黑" charset="0"/>
-              </a:rPr>
-              <a:t>和锚点文本的特征内积</a:t>
-            </a:r>
-            <a:r>
-              <a:rPr lang="zh-CN" altLang="en-US" sz="1200" b="1">
-                <a:latin typeface="微软雅黑" charset="0"/>
-                <a:ea typeface="微软雅黑" charset="0"/>
-                <a:cs typeface="微软雅黑" charset="0"/>
-              </a:rPr>
-              <a:t>最大化</a:t>
-            </a:r>
-            <a:endParaRPr lang="zh-CN" altLang="en-US" sz="1200" b="1">
-              <a:latin typeface="微软雅黑" charset="0"/>
-              <a:ea typeface="微软雅黑" charset="0"/>
-              <a:cs typeface="微软雅黑" charset="0"/>
             </a:endParaRPr>
           </a:p>
         </p:txBody>
@@ -7953,7 +9678,97 @@
 </p:tagLst>
 </file>
 
+<file path=ppt/tags/tag55.xml><?xml version="1.0" encoding="utf-8"?>
+<p:tagLst xmlns:p="http://schemas.openxmlformats.org/presentationml/2006/main">
+  <p:tag name="KSO_WM_BEAUTIFY_FLAG" val=""/>
+</p:tagLst>
+</file>
+
+<file path=ppt/tags/tag56.xml><?xml version="1.0" encoding="utf-8"?>
+<p:tagLst xmlns:p="http://schemas.openxmlformats.org/presentationml/2006/main">
+  <p:tag name="KSO_WM_BEAUTIFY_FLAG" val=""/>
+</p:tagLst>
+</file>
+
+<file path=ppt/tags/tag57.xml><?xml version="1.0" encoding="utf-8"?>
+<p:tagLst xmlns:p="http://schemas.openxmlformats.org/presentationml/2006/main">
+  <p:tag name="KSO_WM_BEAUTIFY_FLAG" val=""/>
+</p:tagLst>
+</file>
+
+<file path=ppt/tags/tag58.xml><?xml version="1.0" encoding="utf-8"?>
+<p:tagLst xmlns:p="http://schemas.openxmlformats.org/presentationml/2006/main">
+  <p:tag name="KSO_WM_BEAUTIFY_FLAG" val=""/>
+</p:tagLst>
+</file>
+
+<file path=ppt/tags/tag59.xml><?xml version="1.0" encoding="utf-8"?>
+<p:tagLst xmlns:p="http://schemas.openxmlformats.org/presentationml/2006/main">
+  <p:tag name="KSO_WM_BEAUTIFY_FLAG" val=""/>
+</p:tagLst>
+</file>
+
 <file path=ppt/tags/tag6.xml><?xml version="1.0" encoding="utf-8"?>
+<p:tagLst xmlns:p="http://schemas.openxmlformats.org/presentationml/2006/main">
+  <p:tag name="KSO_WM_BEAUTIFY_FLAG" val=""/>
+</p:tagLst>
+</file>
+
+<file path=ppt/tags/tag60.xml><?xml version="1.0" encoding="utf-8"?>
+<p:tagLst xmlns:p="http://schemas.openxmlformats.org/presentationml/2006/main">
+  <p:tag name="KSO_WM_BEAUTIFY_FLAG" val=""/>
+</p:tagLst>
+</file>
+
+<file path=ppt/tags/tag61.xml><?xml version="1.0" encoding="utf-8"?>
+<p:tagLst xmlns:p="http://schemas.openxmlformats.org/presentationml/2006/main">
+  <p:tag name="KSO_WM_BEAUTIFY_FLAG" val=""/>
+</p:tagLst>
+</file>
+
+<file path=ppt/tags/tag62.xml><?xml version="1.0" encoding="utf-8"?>
+<p:tagLst xmlns:p="http://schemas.openxmlformats.org/presentationml/2006/main">
+  <p:tag name="KSO_WM_BEAUTIFY_FLAG" val=""/>
+</p:tagLst>
+</file>
+
+<file path=ppt/tags/tag63.xml><?xml version="1.0" encoding="utf-8"?>
+<p:tagLst xmlns:p="http://schemas.openxmlformats.org/presentationml/2006/main">
+  <p:tag name="KSO_WM_BEAUTIFY_FLAG" val=""/>
+</p:tagLst>
+</file>
+
+<file path=ppt/tags/tag64.xml><?xml version="1.0" encoding="utf-8"?>
+<p:tagLst xmlns:p="http://schemas.openxmlformats.org/presentationml/2006/main">
+  <p:tag name="KSO_WM_BEAUTIFY_FLAG" val=""/>
+</p:tagLst>
+</file>
+
+<file path=ppt/tags/tag65.xml><?xml version="1.0" encoding="utf-8"?>
+<p:tagLst xmlns:p="http://schemas.openxmlformats.org/presentationml/2006/main">
+  <p:tag name="KSO_WM_BEAUTIFY_FLAG" val=""/>
+</p:tagLst>
+</file>
+
+<file path=ppt/tags/tag66.xml><?xml version="1.0" encoding="utf-8"?>
+<p:tagLst xmlns:p="http://schemas.openxmlformats.org/presentationml/2006/main">
+  <p:tag name="KSO_WM_BEAUTIFY_FLAG" val=""/>
+</p:tagLst>
+</file>
+
+<file path=ppt/tags/tag67.xml><?xml version="1.0" encoding="utf-8"?>
+<p:tagLst xmlns:p="http://schemas.openxmlformats.org/presentationml/2006/main">
+  <p:tag name="KSO_WM_BEAUTIFY_FLAG" val=""/>
+</p:tagLst>
+</file>
+
+<file path=ppt/tags/tag68.xml><?xml version="1.0" encoding="utf-8"?>
+<p:tagLst xmlns:p="http://schemas.openxmlformats.org/presentationml/2006/main">
+  <p:tag name="KSO_WM_BEAUTIFY_FLAG" val=""/>
+</p:tagLst>
+</file>
+
+<file path=ppt/tags/tag69.xml><?xml version="1.0" encoding="utf-8"?>
 <p:tagLst xmlns:p="http://schemas.openxmlformats.org/presentationml/2006/main">
   <p:tag name="KSO_WM_BEAUTIFY_FLAG" val=""/>
 </p:tagLst>
@@ -7965,7 +9780,73 @@
 </p:tagLst>
 </file>
 
+<file path=ppt/tags/tag70.xml><?xml version="1.0" encoding="utf-8"?>
+<p:tagLst xmlns:p="http://schemas.openxmlformats.org/presentationml/2006/main">
+  <p:tag name="KSO_WM_BEAUTIFY_FLAG" val=""/>
+</p:tagLst>
+</file>
+
+<file path=ppt/tags/tag71.xml><?xml version="1.0" encoding="utf-8"?>
+<p:tagLst xmlns:p="http://schemas.openxmlformats.org/presentationml/2006/main">
+  <p:tag name="KSO_WM_BEAUTIFY_FLAG" val=""/>
+</p:tagLst>
+</file>
+
+<file path=ppt/tags/tag72.xml><?xml version="1.0" encoding="utf-8"?>
+<p:tagLst xmlns:p="http://schemas.openxmlformats.org/presentationml/2006/main">
+  <p:tag name="KSO_WM_BEAUTIFY_FLAG" val=""/>
+</p:tagLst>
+</file>
+
+<file path=ppt/tags/tag73.xml><?xml version="1.0" encoding="utf-8"?>
+<p:tagLst xmlns:p="http://schemas.openxmlformats.org/presentationml/2006/main">
+  <p:tag name="KSO_WM_BEAUTIFY_FLAG" val=""/>
+</p:tagLst>
+</file>
+
+<file path=ppt/tags/tag74.xml><?xml version="1.0" encoding="utf-8"?>
+<p:tagLst xmlns:p="http://schemas.openxmlformats.org/presentationml/2006/main">
+  <p:tag name="KSO_WM_BEAUTIFY_FLAG" val=""/>
+</p:tagLst>
+</file>
+
+<file path=ppt/tags/tag75.xml><?xml version="1.0" encoding="utf-8"?>
+<p:tagLst xmlns:p="http://schemas.openxmlformats.org/presentationml/2006/main">
+  <p:tag name="KSO_WM_BEAUTIFY_FLAG" val=""/>
+</p:tagLst>
+</file>
+
+<file path=ppt/tags/tag76.xml><?xml version="1.0" encoding="utf-8"?>
+<p:tagLst xmlns:p="http://schemas.openxmlformats.org/presentationml/2006/main">
+  <p:tag name="KSO_WM_BEAUTIFY_FLAG" val=""/>
+</p:tagLst>
+</file>
+
+<file path=ppt/tags/tag77.xml><?xml version="1.0" encoding="utf-8"?>
+<p:tagLst xmlns:p="http://schemas.openxmlformats.org/presentationml/2006/main">
+  <p:tag name="KSO_WM_BEAUTIFY_FLAG" val=""/>
+</p:tagLst>
+</file>
+
+<file path=ppt/tags/tag78.xml><?xml version="1.0" encoding="utf-8"?>
+<p:tagLst xmlns:p="http://schemas.openxmlformats.org/presentationml/2006/main">
+  <p:tag name="KSO_WM_BEAUTIFY_FLAG" val=""/>
+</p:tagLst>
+</file>
+
+<file path=ppt/tags/tag79.xml><?xml version="1.0" encoding="utf-8"?>
+<p:tagLst xmlns:p="http://schemas.openxmlformats.org/presentationml/2006/main">
+  <p:tag name="KSO_WM_BEAUTIFY_FLAG" val=""/>
+</p:tagLst>
+</file>
+
 <file path=ppt/tags/tag8.xml><?xml version="1.0" encoding="utf-8"?>
+<p:tagLst xmlns:p="http://schemas.openxmlformats.org/presentationml/2006/main">
+  <p:tag name="KSO_WM_BEAUTIFY_FLAG" val=""/>
+</p:tagLst>
+</file>
+
+<file path=ppt/tags/tag80.xml><?xml version="1.0" encoding="utf-8"?>
 <p:tagLst xmlns:p="http://schemas.openxmlformats.org/presentationml/2006/main">
   <p:tag name="KSO_WM_BEAUTIFY_FLAG" val=""/>
 </p:tagLst>

</xml_diff>

<commit_message>
update_Set-level Guidance Attack: Boosting Adversarial Transferability of Vision-Language Pre-training Models
</commit_message>
<xml_diff>
--- a/Attack/Adversarial_Attack/VLP/论文作图.pptx
+++ b/Attack/Adversarial_Attack/VLP/论文作图.pptx
@@ -8,7 +8,7 @@
     <p:notesMasterId r:id="rId5"/>
   </p:notesMasterIdLst>
   <p:handoutMasterIdLst>
-    <p:handoutMasterId r:id="rId9"/>
+    <p:handoutMasterId r:id="rId11"/>
   </p:handoutMasterIdLst>
   <p:sldIdLst>
     <p:sldId id="258" r:id="rId3"/>
@@ -16,6 +16,8 @@
     <p:sldId id="257" r:id="rId6"/>
     <p:sldId id="259" r:id="rId7"/>
     <p:sldId id="260" r:id="rId8"/>
+    <p:sldId id="261" r:id="rId9"/>
+    <p:sldId id="262" r:id="rId10"/>
   </p:sldIdLst>
   <p:sldSz cx="12192000" cy="6858000"/>
   <p:notesSz cx="7103745" cy="10234295"/>
@@ -117,12 +119,12 @@
   <p:extLst>
     <p:ext uri="{EFAFB233-063F-42B5-8137-9DF3F51BA10A}">
       <p15:sldGuideLst xmlns:p15="http://schemas.microsoft.com/office/powerpoint/2012/main">
-        <p15:guide id="1" orient="horz" pos="2160" userDrawn="1">
+        <p15:guide id="1" orient="horz" pos="2204" userDrawn="1">
           <p15:clr>
             <a:srgbClr val="A4A3A4"/>
           </p15:clr>
         </p15:guide>
-        <p15:guide id="2" pos="3840" userDrawn="1">
+        <p15:guide id="2" pos="3870" userDrawn="1">
           <p15:clr>
             <a:srgbClr val="A4A3A4"/>
           </p15:clr>
@@ -9378,6 +9380,1585 @@
 </p:sld>
 </file>
 
+<file path=ppt/slides/slide6.xml><?xml version="1.0" encoding="utf-8"?>
+<p:sld xmlns:a="http://schemas.openxmlformats.org/drawingml/2006/main" xmlns:r="http://schemas.openxmlformats.org/officeDocument/2006/relationships" xmlns:p="http://schemas.openxmlformats.org/presentationml/2006/main">
+  <p:cSld>
+    <p:spTree>
+      <p:nvGrpSpPr>
+        <p:cNvPr id="1" name=""/>
+        <p:cNvGrpSpPr/>
+        <p:nvPr/>
+      </p:nvGrpSpPr>
+      <p:grpSpPr/>
+      <p:sp>
+        <p:nvSpPr>
+          <p:cNvPr id="2" name="标题 1"/>
+          <p:cNvSpPr>
+            <a:spLocks noGrp="1"/>
+          </p:cNvSpPr>
+          <p:nvPr>
+            <p:ph type="ctrTitle"/>
+          </p:nvPr>
+        </p:nvSpPr>
+        <p:spPr/>
+        <p:txBody>
+          <a:bodyPr/>
+          <a:p>
+            <a:r>
+              <a:rPr lang="en-US" altLang="zh-CN"/>
+              <a:t>SGA</a:t>
+            </a:r>
+            <a:endParaRPr lang="en-US" altLang="zh-CN"/>
+          </a:p>
+        </p:txBody>
+      </p:sp>
+      <p:sp>
+        <p:nvSpPr>
+          <p:cNvPr id="3" name="副标题 2"/>
+          <p:cNvSpPr>
+            <a:spLocks noGrp="1"/>
+          </p:cNvSpPr>
+          <p:nvPr>
+            <p:ph type="subTitle" idx="1"/>
+          </p:nvPr>
+        </p:nvSpPr>
+        <p:spPr/>
+        <p:txBody>
+          <a:bodyPr/>
+          <a:p>
+            <a:endParaRPr lang="zh-CN" altLang="en-US"/>
+          </a:p>
+        </p:txBody>
+      </p:sp>
+    </p:spTree>
+  </p:cSld>
+  <p:clrMapOvr>
+    <a:masterClrMapping/>
+  </p:clrMapOvr>
+</p:sld>
+</file>
+
+<file path=ppt/slides/slide7.xml><?xml version="1.0" encoding="utf-8"?>
+<p:sld xmlns:a="http://schemas.openxmlformats.org/drawingml/2006/main" xmlns:r="http://schemas.openxmlformats.org/officeDocument/2006/relationships" xmlns:p="http://schemas.openxmlformats.org/presentationml/2006/main">
+  <p:cSld>
+    <p:spTree>
+      <p:nvGrpSpPr>
+        <p:cNvPr id="1" name=""/>
+        <p:cNvGrpSpPr/>
+        <p:nvPr/>
+      </p:nvGrpSpPr>
+      <p:grpSpPr/>
+      <p:pic>
+        <p:nvPicPr>
+          <p:cNvPr id="5" name="图片 4"/>
+          <p:cNvPicPr>
+            <a:picLocks noChangeAspect="1"/>
+          </p:cNvPicPr>
+          <p:nvPr>
+            <p:custDataLst>
+              <p:tags r:id="rId1"/>
+            </p:custDataLst>
+          </p:nvPr>
+        </p:nvPicPr>
+        <p:blipFill>
+          <a:blip r:embed="rId2"/>
+          <a:stretch>
+            <a:fillRect/>
+          </a:stretch>
+        </p:blipFill>
+        <p:spPr>
+          <a:xfrm>
+            <a:off x="1604010" y="553720"/>
+            <a:ext cx="698500" cy="685800"/>
+          </a:xfrm>
+          <a:prstGeom prst="rect">
+            <a:avLst/>
+          </a:prstGeom>
+        </p:spPr>
+      </p:pic>
+      <p:pic>
+        <p:nvPicPr>
+          <p:cNvPr id="6" name="图片 5"/>
+          <p:cNvPicPr>
+            <a:picLocks noChangeAspect="1"/>
+          </p:cNvPicPr>
+          <p:nvPr>
+            <p:custDataLst>
+              <p:tags r:id="rId3"/>
+            </p:custDataLst>
+          </p:nvPr>
+        </p:nvPicPr>
+        <p:blipFill>
+          <a:blip r:embed="rId2"/>
+          <a:stretch>
+            <a:fillRect/>
+          </a:stretch>
+        </p:blipFill>
+        <p:spPr>
+          <a:xfrm>
+            <a:off x="1604010" y="1861185"/>
+            <a:ext cx="698500" cy="685800"/>
+          </a:xfrm>
+          <a:prstGeom prst="rect">
+            <a:avLst/>
+          </a:prstGeom>
+        </p:spPr>
+      </p:pic>
+      <p:pic>
+        <p:nvPicPr>
+          <p:cNvPr id="10" name="图片 9"/>
+          <p:cNvPicPr>
+            <a:picLocks noChangeAspect="1"/>
+          </p:cNvPicPr>
+          <p:nvPr>
+            <p:custDataLst>
+              <p:tags r:id="rId4"/>
+            </p:custDataLst>
+          </p:nvPr>
+        </p:nvPicPr>
+        <p:blipFill>
+          <a:blip r:embed="rId2"/>
+          <a:stretch>
+            <a:fillRect/>
+          </a:stretch>
+        </p:blipFill>
+        <p:spPr>
+          <a:xfrm flipH="1">
+            <a:off x="2752090" y="1861185"/>
+            <a:ext cx="698500" cy="685800"/>
+          </a:xfrm>
+          <a:prstGeom prst="rect">
+            <a:avLst/>
+          </a:prstGeom>
+        </p:spPr>
+      </p:pic>
+      <p:sp>
+        <p:nvSpPr>
+          <p:cNvPr id="16" name="右箭头 15"/>
+          <p:cNvSpPr/>
+          <p:nvPr>
+            <p:custDataLst>
+              <p:tags r:id="rId5"/>
+            </p:custDataLst>
+          </p:nvPr>
+        </p:nvSpPr>
+        <p:spPr>
+          <a:xfrm rot="5400000">
+            <a:off x="1751330" y="1439545"/>
+            <a:ext cx="403860" cy="220980"/>
+          </a:xfrm>
+          <a:prstGeom prst="rightArrow">
+            <a:avLst/>
+          </a:prstGeom>
+        </p:spPr>
+        <p:style>
+          <a:lnRef idx="2">
+            <a:schemeClr val="accent1">
+              <a:lumMod val="75000"/>
+            </a:schemeClr>
+          </a:lnRef>
+          <a:fillRef idx="1">
+            <a:schemeClr val="accent1"/>
+          </a:fillRef>
+          <a:effectRef idx="0">
+            <a:srgbClr val="FFFFFF"/>
+          </a:effectRef>
+          <a:fontRef idx="minor">
+            <a:schemeClr val="lt1"/>
+          </a:fontRef>
+        </p:style>
+        <p:txBody>
+          <a:bodyPr rtlCol="0" anchor="ctr"/>
+          <a:p>
+            <a:pPr algn="ctr"/>
+            <a:endParaRPr lang="zh-CN" altLang="en-US"/>
+          </a:p>
+        </p:txBody>
+      </p:sp>
+      <p:sp>
+        <p:nvSpPr>
+          <p:cNvPr id="11" name="文本框 10"/>
+          <p:cNvSpPr txBox="1"/>
+          <p:nvPr>
+            <p:custDataLst>
+              <p:tags r:id="rId6"/>
+            </p:custDataLst>
+          </p:nvPr>
+        </p:nvSpPr>
+        <p:spPr>
+          <a:xfrm>
+            <a:off x="2216150" y="1249045"/>
+            <a:ext cx="2610485" cy="575310"/>
+          </a:xfrm>
+          <a:prstGeom prst="rect">
+            <a:avLst/>
+          </a:prstGeom>
+          <a:noFill/>
+        </p:spPr>
+        <p:txBody>
+          <a:bodyPr wrap="square" rtlCol="0">
+            <a:noAutofit/>
+          </a:bodyPr>
+          <a:p>
+            <a:pPr algn="ctr"/>
+            <a:r>
+              <a:rPr lang="zh-CN" altLang="en-US" sz="1200" b="1">
+                <a:latin typeface="微软雅黑" charset="0"/>
+                <a:ea typeface="微软雅黑" charset="0"/>
+                <a:cs typeface="微软雅黑" charset="0"/>
+              </a:rPr>
+              <a:t>将一张图进行预处理变成一个集合</a:t>
+            </a:r>
+            <a:br>
+              <a:rPr lang="zh-CN" altLang="en-US" sz="1200" b="1">
+                <a:latin typeface="微软雅黑" charset="0"/>
+                <a:ea typeface="微软雅黑" charset="0"/>
+                <a:cs typeface="微软雅黑" charset="0"/>
+              </a:rPr>
+            </a:br>
+            <a:r>
+              <a:rPr lang="zh-CN" altLang="en-US" sz="1200" b="1">
+                <a:latin typeface="微软雅黑" charset="0"/>
+                <a:ea typeface="微软雅黑" charset="0"/>
+                <a:cs typeface="微软雅黑" charset="0"/>
+              </a:rPr>
+              <a:t>缩放、加噪</a:t>
+            </a:r>
+            <a:r>
+              <a:rPr lang="zh-CN" altLang="en-US" sz="1200" b="1">
+                <a:latin typeface="微软雅黑" charset="0"/>
+                <a:ea typeface="微软雅黑" charset="0"/>
+                <a:cs typeface="微软雅黑" charset="0"/>
+              </a:rPr>
+              <a:t>等</a:t>
+            </a:r>
+            <a:endParaRPr lang="zh-CN" altLang="en-US" sz="1200" b="1">
+              <a:latin typeface="微软雅黑" charset="0"/>
+              <a:ea typeface="微软雅黑" charset="0"/>
+              <a:cs typeface="微软雅黑" charset="0"/>
+            </a:endParaRPr>
+          </a:p>
+        </p:txBody>
+      </p:sp>
+      <p:sp>
+        <p:nvSpPr>
+          <p:cNvPr id="12" name="文本框 11"/>
+          <p:cNvSpPr txBox="1"/>
+          <p:nvPr>
+            <p:custDataLst>
+              <p:tags r:id="rId7"/>
+            </p:custDataLst>
+          </p:nvPr>
+        </p:nvSpPr>
+        <p:spPr>
+          <a:xfrm>
+            <a:off x="5895340" y="765175"/>
+            <a:ext cx="497840" cy="305435"/>
+          </a:xfrm>
+          <a:prstGeom prst="rect">
+            <a:avLst/>
+          </a:prstGeom>
+          <a:noFill/>
+        </p:spPr>
+        <p:txBody>
+          <a:bodyPr wrap="square" rtlCol="0">
+            <a:noAutofit/>
+          </a:bodyPr>
+          <a:p>
+            <a:pPr algn="ctr"/>
+            <a:r>
+              <a:rPr lang="en-US" altLang="zh-CN" sz="1200" b="1">
+                <a:latin typeface="微软雅黑" charset="0"/>
+                <a:ea typeface="微软雅黑" charset="0"/>
+                <a:cs typeface="微软雅黑" charset="0"/>
+              </a:rPr>
+              <a:t>text</a:t>
+            </a:r>
+            <a:endParaRPr lang="en-US" altLang="zh-CN" sz="1200" b="1">
+              <a:latin typeface="微软雅黑" charset="0"/>
+              <a:ea typeface="微软雅黑" charset="0"/>
+              <a:cs typeface="微软雅黑" charset="0"/>
+            </a:endParaRPr>
+          </a:p>
+        </p:txBody>
+      </p:sp>
+      <p:sp>
+        <p:nvSpPr>
+          <p:cNvPr id="13" name="文本框 12"/>
+          <p:cNvSpPr txBox="1"/>
+          <p:nvPr>
+            <p:custDataLst>
+              <p:tags r:id="rId8"/>
+            </p:custDataLst>
+          </p:nvPr>
+        </p:nvSpPr>
+        <p:spPr>
+          <a:xfrm>
+            <a:off x="5085080" y="1950720"/>
+            <a:ext cx="594995" cy="305435"/>
+          </a:xfrm>
+          <a:prstGeom prst="rect">
+            <a:avLst/>
+          </a:prstGeom>
+          <a:noFill/>
+        </p:spPr>
+        <p:txBody>
+          <a:bodyPr wrap="square" rtlCol="0">
+            <a:noAutofit/>
+          </a:bodyPr>
+          <a:p>
+            <a:pPr algn="ctr"/>
+            <a:r>
+              <a:rPr lang="en-US" altLang="zh-CN" sz="1200" b="1">
+                <a:latin typeface="微软雅黑" charset="0"/>
+                <a:ea typeface="微软雅黑" charset="0"/>
+                <a:cs typeface="微软雅黑" charset="0"/>
+              </a:rPr>
+              <a:t>text1</a:t>
+            </a:r>
+            <a:endParaRPr lang="en-US" altLang="zh-CN" sz="1200" b="1">
+              <a:latin typeface="微软雅黑" charset="0"/>
+              <a:ea typeface="微软雅黑" charset="0"/>
+              <a:cs typeface="微软雅黑" charset="0"/>
+            </a:endParaRPr>
+          </a:p>
+        </p:txBody>
+      </p:sp>
+      <p:sp>
+        <p:nvSpPr>
+          <p:cNvPr id="14" name="文本框 13"/>
+          <p:cNvSpPr txBox="1"/>
+          <p:nvPr>
+            <p:custDataLst>
+              <p:tags r:id="rId9"/>
+            </p:custDataLst>
+          </p:nvPr>
+        </p:nvSpPr>
+        <p:spPr>
+          <a:xfrm>
+            <a:off x="5847080" y="1950720"/>
+            <a:ext cx="594995" cy="305435"/>
+          </a:xfrm>
+          <a:prstGeom prst="rect">
+            <a:avLst/>
+          </a:prstGeom>
+          <a:noFill/>
+        </p:spPr>
+        <p:txBody>
+          <a:bodyPr wrap="square" rtlCol="0">
+            <a:noAutofit/>
+          </a:bodyPr>
+          <a:p>
+            <a:pPr algn="ctr"/>
+            <a:r>
+              <a:rPr lang="en-US" altLang="zh-CN" sz="1200" b="1">
+                <a:latin typeface="微软雅黑" charset="0"/>
+                <a:ea typeface="微软雅黑" charset="0"/>
+                <a:cs typeface="微软雅黑" charset="0"/>
+              </a:rPr>
+              <a:t>text2</a:t>
+            </a:r>
+            <a:endParaRPr lang="en-US" altLang="zh-CN" sz="1200" b="1">
+              <a:latin typeface="微软雅黑" charset="0"/>
+              <a:ea typeface="微软雅黑" charset="0"/>
+              <a:cs typeface="微软雅黑" charset="0"/>
+            </a:endParaRPr>
+          </a:p>
+        </p:txBody>
+      </p:sp>
+      <p:sp>
+        <p:nvSpPr>
+          <p:cNvPr id="15" name="文本框 14"/>
+          <p:cNvSpPr txBox="1"/>
+          <p:nvPr>
+            <p:custDataLst>
+              <p:tags r:id="rId10"/>
+            </p:custDataLst>
+          </p:nvPr>
+        </p:nvSpPr>
+        <p:spPr>
+          <a:xfrm>
+            <a:off x="6736080" y="1950720"/>
+            <a:ext cx="594995" cy="305435"/>
+          </a:xfrm>
+          <a:prstGeom prst="rect">
+            <a:avLst/>
+          </a:prstGeom>
+          <a:noFill/>
+        </p:spPr>
+        <p:txBody>
+          <a:bodyPr wrap="square" rtlCol="0">
+            <a:noAutofit/>
+          </a:bodyPr>
+          <a:p>
+            <a:pPr algn="ctr"/>
+            <a:r>
+              <a:rPr lang="en-US" altLang="zh-CN" sz="1200" b="1">
+                <a:latin typeface="微软雅黑" charset="0"/>
+                <a:ea typeface="微软雅黑" charset="0"/>
+                <a:cs typeface="微软雅黑" charset="0"/>
+              </a:rPr>
+              <a:t>text3</a:t>
+            </a:r>
+            <a:endParaRPr lang="en-US" altLang="zh-CN" sz="1200" b="1">
+              <a:latin typeface="微软雅黑" charset="0"/>
+              <a:ea typeface="微软雅黑" charset="0"/>
+              <a:cs typeface="微软雅黑" charset="0"/>
+            </a:endParaRPr>
+          </a:p>
+        </p:txBody>
+      </p:sp>
+      <p:sp>
+        <p:nvSpPr>
+          <p:cNvPr id="17" name="右箭头 16"/>
+          <p:cNvSpPr/>
+          <p:nvPr>
+            <p:custDataLst>
+              <p:tags r:id="rId11"/>
+            </p:custDataLst>
+          </p:nvPr>
+        </p:nvSpPr>
+        <p:spPr>
+          <a:xfrm rot="5400000">
+            <a:off x="5942330" y="1439545"/>
+            <a:ext cx="403860" cy="220980"/>
+          </a:xfrm>
+          <a:prstGeom prst="rightArrow">
+            <a:avLst/>
+          </a:prstGeom>
+        </p:spPr>
+        <p:style>
+          <a:lnRef idx="2">
+            <a:schemeClr val="accent1">
+              <a:lumMod val="75000"/>
+            </a:schemeClr>
+          </a:lnRef>
+          <a:fillRef idx="1">
+            <a:schemeClr val="accent1"/>
+          </a:fillRef>
+          <a:effectRef idx="0">
+            <a:srgbClr val="FFFFFF"/>
+          </a:effectRef>
+          <a:fontRef idx="minor">
+            <a:schemeClr val="lt1"/>
+          </a:fontRef>
+        </p:style>
+        <p:txBody>
+          <a:bodyPr rtlCol="0" anchor="ctr"/>
+          <a:p>
+            <a:pPr algn="ctr"/>
+            <a:endParaRPr lang="zh-CN" altLang="en-US"/>
+          </a:p>
+        </p:txBody>
+      </p:sp>
+      <p:sp>
+        <p:nvSpPr>
+          <p:cNvPr id="18" name="文本框 17"/>
+          <p:cNvSpPr txBox="1"/>
+          <p:nvPr>
+            <p:custDataLst>
+              <p:tags r:id="rId12"/>
+            </p:custDataLst>
+          </p:nvPr>
+        </p:nvSpPr>
+        <p:spPr>
+          <a:xfrm>
+            <a:off x="6407150" y="1285875"/>
+            <a:ext cx="2941320" cy="575310"/>
+          </a:xfrm>
+          <a:prstGeom prst="rect">
+            <a:avLst/>
+          </a:prstGeom>
+          <a:noFill/>
+        </p:spPr>
+        <p:txBody>
+          <a:bodyPr wrap="square" rtlCol="0">
+            <a:noAutofit/>
+          </a:bodyPr>
+          <a:p>
+            <a:pPr algn="ctr"/>
+            <a:r>
+              <a:rPr lang="zh-CN" altLang="en-US" sz="1200" b="1">
+                <a:latin typeface="微软雅黑" charset="0"/>
+                <a:ea typeface="微软雅黑" charset="0"/>
+                <a:cs typeface="微软雅黑" charset="0"/>
+              </a:rPr>
+              <a:t>选取一张图像的多个描述变成一个</a:t>
+            </a:r>
+            <a:r>
+              <a:rPr lang="zh-CN" altLang="en-US" sz="1200" b="1">
+                <a:latin typeface="微软雅黑" charset="0"/>
+                <a:ea typeface="微软雅黑" charset="0"/>
+                <a:cs typeface="微软雅黑" charset="0"/>
+              </a:rPr>
+              <a:t>集合</a:t>
+            </a:r>
+            <a:endParaRPr lang="zh-CN" altLang="en-US" sz="1200" b="1">
+              <a:latin typeface="微软雅黑" charset="0"/>
+              <a:ea typeface="微软雅黑" charset="0"/>
+              <a:cs typeface="微软雅黑" charset="0"/>
+            </a:endParaRPr>
+          </a:p>
+        </p:txBody>
+      </p:sp>
+      <p:sp>
+        <p:nvSpPr>
+          <p:cNvPr id="19" name="右箭头 18"/>
+          <p:cNvSpPr/>
+          <p:nvPr>
+            <p:custDataLst>
+              <p:tags r:id="rId13"/>
+            </p:custDataLst>
+          </p:nvPr>
+        </p:nvSpPr>
+        <p:spPr>
+          <a:xfrm>
+            <a:off x="4291330" y="804545"/>
+            <a:ext cx="403860" cy="220980"/>
+          </a:xfrm>
+          <a:prstGeom prst="rightArrow">
+            <a:avLst/>
+          </a:prstGeom>
+        </p:spPr>
+        <p:style>
+          <a:lnRef idx="2">
+            <a:schemeClr val="accent1">
+              <a:lumMod val="75000"/>
+            </a:schemeClr>
+          </a:lnRef>
+          <a:fillRef idx="1">
+            <a:schemeClr val="accent1"/>
+          </a:fillRef>
+          <a:effectRef idx="0">
+            <a:srgbClr val="FFFFFF"/>
+          </a:effectRef>
+          <a:fontRef idx="minor">
+            <a:schemeClr val="lt1"/>
+          </a:fontRef>
+        </p:style>
+        <p:txBody>
+          <a:bodyPr rtlCol="0" anchor="ctr"/>
+          <a:p>
+            <a:pPr algn="ctr"/>
+            <a:endParaRPr lang="zh-CN" altLang="en-US"/>
+          </a:p>
+        </p:txBody>
+      </p:sp>
+      <p:pic>
+        <p:nvPicPr>
+          <p:cNvPr id="20" name="图片 19"/>
+          <p:cNvPicPr>
+            <a:picLocks noChangeAspect="1"/>
+          </p:cNvPicPr>
+          <p:nvPr>
+            <p:custDataLst>
+              <p:tags r:id="rId14"/>
+            </p:custDataLst>
+          </p:nvPr>
+        </p:nvPicPr>
+        <p:blipFill>
+          <a:blip r:embed="rId15"/>
+          <a:stretch>
+            <a:fillRect/>
+          </a:stretch>
+        </p:blipFill>
+        <p:spPr>
+          <a:xfrm>
+            <a:off x="8098155" y="3176905"/>
+            <a:ext cx="2523490" cy="537210"/>
+          </a:xfrm>
+          <a:prstGeom prst="rect">
+            <a:avLst/>
+          </a:prstGeom>
+        </p:spPr>
+      </p:pic>
+      <p:pic>
+        <p:nvPicPr>
+          <p:cNvPr id="21" name="图片 20"/>
+          <p:cNvPicPr>
+            <a:picLocks noChangeAspect="1"/>
+          </p:cNvPicPr>
+          <p:nvPr>
+            <p:custDataLst>
+              <p:tags r:id="rId16"/>
+            </p:custDataLst>
+          </p:nvPr>
+        </p:nvPicPr>
+        <p:blipFill>
+          <a:blip r:embed="rId2"/>
+          <a:stretch>
+            <a:fillRect/>
+          </a:stretch>
+        </p:blipFill>
+        <p:spPr>
+          <a:xfrm>
+            <a:off x="11112500" y="2491105"/>
+            <a:ext cx="698500" cy="685800"/>
+          </a:xfrm>
+          <a:prstGeom prst="rect">
+            <a:avLst/>
+          </a:prstGeom>
+        </p:spPr>
+      </p:pic>
+      <p:sp>
+        <p:nvSpPr>
+          <p:cNvPr id="22" name="文本框 21"/>
+          <p:cNvSpPr txBox="1"/>
+          <p:nvPr>
+            <p:custDataLst>
+              <p:tags r:id="rId17"/>
+            </p:custDataLst>
+          </p:nvPr>
+        </p:nvSpPr>
+        <p:spPr>
+          <a:xfrm>
+            <a:off x="4981575" y="3347720"/>
+            <a:ext cx="865505" cy="305435"/>
+          </a:xfrm>
+          <a:prstGeom prst="rect">
+            <a:avLst/>
+          </a:prstGeom>
+          <a:noFill/>
+        </p:spPr>
+        <p:txBody>
+          <a:bodyPr wrap="square" rtlCol="0">
+            <a:noAutofit/>
+          </a:bodyPr>
+          <a:p>
+            <a:pPr algn="ctr"/>
+            <a:r>
+              <a:rPr lang="en-US" altLang="zh-CN" sz="1200" b="1">
+                <a:latin typeface="微软雅黑" charset="0"/>
+                <a:ea typeface="微软雅黑" charset="0"/>
+                <a:cs typeface="微软雅黑" charset="0"/>
+              </a:rPr>
+              <a:t>a_text1</a:t>
+            </a:r>
+            <a:endParaRPr lang="en-US" altLang="zh-CN" sz="1200" b="1">
+              <a:latin typeface="微软雅黑" charset="0"/>
+              <a:ea typeface="微软雅黑" charset="0"/>
+              <a:cs typeface="微软雅黑" charset="0"/>
+            </a:endParaRPr>
+          </a:p>
+        </p:txBody>
+      </p:sp>
+      <p:sp>
+        <p:nvSpPr>
+          <p:cNvPr id="23" name="文本框 22"/>
+          <p:cNvSpPr txBox="1"/>
+          <p:nvPr>
+            <p:custDataLst>
+              <p:tags r:id="rId18"/>
+            </p:custDataLst>
+          </p:nvPr>
+        </p:nvSpPr>
+        <p:spPr>
+          <a:xfrm>
+            <a:off x="5847080" y="3347720"/>
+            <a:ext cx="865505" cy="305435"/>
+          </a:xfrm>
+          <a:prstGeom prst="rect">
+            <a:avLst/>
+          </a:prstGeom>
+          <a:noFill/>
+        </p:spPr>
+        <p:txBody>
+          <a:bodyPr wrap="square" rtlCol="0">
+            <a:noAutofit/>
+          </a:bodyPr>
+          <a:p>
+            <a:pPr algn="ctr"/>
+            <a:r>
+              <a:rPr lang="en-US" altLang="zh-CN" sz="1200" b="1">
+                <a:latin typeface="微软雅黑" charset="0"/>
+                <a:ea typeface="微软雅黑" charset="0"/>
+                <a:cs typeface="微软雅黑" charset="0"/>
+              </a:rPr>
+              <a:t>a_text2</a:t>
+            </a:r>
+            <a:endParaRPr lang="en-US" altLang="zh-CN" sz="1200" b="1">
+              <a:latin typeface="微软雅黑" charset="0"/>
+              <a:ea typeface="微软雅黑" charset="0"/>
+              <a:cs typeface="微软雅黑" charset="0"/>
+            </a:endParaRPr>
+          </a:p>
+        </p:txBody>
+      </p:sp>
+      <p:sp>
+        <p:nvSpPr>
+          <p:cNvPr id="24" name="文本框 23"/>
+          <p:cNvSpPr txBox="1"/>
+          <p:nvPr>
+            <p:custDataLst>
+              <p:tags r:id="rId19"/>
+            </p:custDataLst>
+          </p:nvPr>
+        </p:nvSpPr>
+        <p:spPr>
+          <a:xfrm>
+            <a:off x="6736080" y="3347720"/>
+            <a:ext cx="768350" cy="305435"/>
+          </a:xfrm>
+          <a:prstGeom prst="rect">
+            <a:avLst/>
+          </a:prstGeom>
+          <a:noFill/>
+        </p:spPr>
+        <p:txBody>
+          <a:bodyPr wrap="square" rtlCol="0">
+            <a:noAutofit/>
+          </a:bodyPr>
+          <a:p>
+            <a:pPr algn="ctr"/>
+            <a:r>
+              <a:rPr lang="en-US" altLang="zh-CN" sz="1200" b="1">
+                <a:latin typeface="微软雅黑" charset="0"/>
+                <a:ea typeface="微软雅黑" charset="0"/>
+                <a:cs typeface="微软雅黑" charset="0"/>
+              </a:rPr>
+              <a:t>atext3</a:t>
+            </a:r>
+            <a:endParaRPr lang="en-US" altLang="zh-CN" sz="1200" b="1">
+              <a:latin typeface="微软雅黑" charset="0"/>
+              <a:ea typeface="微软雅黑" charset="0"/>
+              <a:cs typeface="微软雅黑" charset="0"/>
+            </a:endParaRPr>
+          </a:p>
+        </p:txBody>
+      </p:sp>
+      <p:sp>
+        <p:nvSpPr>
+          <p:cNvPr id="25" name="右箭头 24"/>
+          <p:cNvSpPr/>
+          <p:nvPr>
+            <p:custDataLst>
+              <p:tags r:id="rId20"/>
+            </p:custDataLst>
+          </p:nvPr>
+        </p:nvSpPr>
+        <p:spPr>
+          <a:xfrm rot="10800000">
+            <a:off x="9157970" y="2673985"/>
+            <a:ext cx="403860" cy="220980"/>
+          </a:xfrm>
+          <a:prstGeom prst="rightArrow">
+            <a:avLst/>
+          </a:prstGeom>
+        </p:spPr>
+        <p:style>
+          <a:lnRef idx="2">
+            <a:schemeClr val="accent1">
+              <a:lumMod val="75000"/>
+            </a:schemeClr>
+          </a:lnRef>
+          <a:fillRef idx="1">
+            <a:schemeClr val="accent1"/>
+          </a:fillRef>
+          <a:effectRef idx="0">
+            <a:srgbClr val="FFFFFF"/>
+          </a:effectRef>
+          <a:fontRef idx="minor">
+            <a:schemeClr val="lt1"/>
+          </a:fontRef>
+        </p:style>
+        <p:txBody>
+          <a:bodyPr rtlCol="0" anchor="ctr"/>
+          <a:p>
+            <a:pPr algn="ctr"/>
+            <a:endParaRPr lang="zh-CN" altLang="en-US"/>
+          </a:p>
+        </p:txBody>
+      </p:sp>
+      <p:sp>
+        <p:nvSpPr>
+          <p:cNvPr id="26" name="右箭头 25"/>
+          <p:cNvSpPr/>
+          <p:nvPr>
+            <p:custDataLst>
+              <p:tags r:id="rId21"/>
+            </p:custDataLst>
+          </p:nvPr>
+        </p:nvSpPr>
+        <p:spPr>
+          <a:xfrm rot="5400000">
+            <a:off x="5942330" y="2582545"/>
+            <a:ext cx="403860" cy="220980"/>
+          </a:xfrm>
+          <a:prstGeom prst="rightArrow">
+            <a:avLst/>
+          </a:prstGeom>
+        </p:spPr>
+        <p:style>
+          <a:lnRef idx="2">
+            <a:schemeClr val="accent1">
+              <a:lumMod val="75000"/>
+            </a:schemeClr>
+          </a:lnRef>
+          <a:fillRef idx="1">
+            <a:schemeClr val="accent1"/>
+          </a:fillRef>
+          <a:effectRef idx="0">
+            <a:srgbClr val="FFFFFF"/>
+          </a:effectRef>
+          <a:fontRef idx="minor">
+            <a:schemeClr val="lt1"/>
+          </a:fontRef>
+        </p:style>
+        <p:txBody>
+          <a:bodyPr rtlCol="0" anchor="ctr"/>
+          <a:p>
+            <a:pPr algn="ctr"/>
+            <a:endParaRPr lang="zh-CN" altLang="en-US"/>
+          </a:p>
+        </p:txBody>
+      </p:sp>
+      <p:sp>
+        <p:nvSpPr>
+          <p:cNvPr id="27" name="文本框 26"/>
+          <p:cNvSpPr txBox="1"/>
+          <p:nvPr>
+            <p:custDataLst>
+              <p:tags r:id="rId22"/>
+            </p:custDataLst>
+          </p:nvPr>
+        </p:nvSpPr>
+        <p:spPr>
+          <a:xfrm>
+            <a:off x="7735570" y="3871595"/>
+            <a:ext cx="3644265" cy="1005205"/>
+          </a:xfrm>
+          <a:prstGeom prst="rect">
+            <a:avLst/>
+          </a:prstGeom>
+          <a:noFill/>
+        </p:spPr>
+        <p:txBody>
+          <a:bodyPr wrap="square" rtlCol="0">
+            <a:noAutofit/>
+          </a:bodyPr>
+          <a:p>
+            <a:pPr algn="ctr"/>
+            <a:r>
+              <a:rPr lang="zh-CN" altLang="en-US" sz="1200" b="1">
+                <a:latin typeface="微软雅黑" charset="0"/>
+                <a:ea typeface="微软雅黑" charset="0"/>
+                <a:cs typeface="微软雅黑" charset="0"/>
+              </a:rPr>
+              <a:t>第一步</a:t>
+            </a:r>
+            <a:r>
+              <a:rPr lang="en-US" altLang="zh-CN" sz="1200" b="1">
+                <a:latin typeface="微软雅黑" charset="0"/>
+                <a:ea typeface="微软雅黑" charset="0"/>
+                <a:cs typeface="微软雅黑" charset="0"/>
+              </a:rPr>
+              <a:t> </a:t>
+            </a:r>
+            <a:r>
+              <a:rPr lang="zh-CN" altLang="en-US" sz="1200" b="1">
+                <a:latin typeface="微软雅黑" charset="0"/>
+                <a:ea typeface="微软雅黑" charset="0"/>
+                <a:cs typeface="微软雅黑" charset="0"/>
+              </a:rPr>
+              <a:t>根据干净</a:t>
+            </a:r>
+            <a:r>
+              <a:rPr lang="zh-CN" altLang="en-US" sz="1200" b="1">
+                <a:latin typeface="微软雅黑" charset="0"/>
+                <a:ea typeface="微软雅黑" charset="0"/>
+                <a:cs typeface="微软雅黑" charset="0"/>
+              </a:rPr>
+              <a:t>初始生成对抗文本</a:t>
+            </a:r>
+            <a:br>
+              <a:rPr lang="zh-CN" altLang="en-US" sz="1200" b="1">
+                <a:latin typeface="微软雅黑" charset="0"/>
+                <a:ea typeface="微软雅黑" charset="0"/>
+                <a:cs typeface="微软雅黑" charset="0"/>
+              </a:rPr>
+            </a:br>
+            <a:r>
+              <a:rPr lang="zh-CN" altLang="en-US" sz="1200" b="1">
+                <a:latin typeface="微软雅黑" charset="0"/>
+                <a:ea typeface="微软雅黑" charset="0"/>
+                <a:cs typeface="微软雅黑" charset="0"/>
+              </a:rPr>
+              <a:t>在允许的扰动幅度</a:t>
+            </a:r>
+            <a:r>
+              <a:rPr lang="zh-CN" altLang="en-US" sz="1200" b="1">
+                <a:latin typeface="微软雅黑" charset="0"/>
+                <a:ea typeface="微软雅黑" charset="0"/>
+                <a:cs typeface="微软雅黑" charset="0"/>
+              </a:rPr>
+              <a:t>之下，最大化初始图像和每一个文本在特征空间下的余弦相似度来生成</a:t>
+            </a:r>
+            <a:r>
+              <a:rPr lang="zh-CN" altLang="en-US" sz="1200" b="1">
+                <a:latin typeface="微软雅黑" charset="0"/>
+                <a:ea typeface="微软雅黑" charset="0"/>
+                <a:cs typeface="微软雅黑" charset="0"/>
+              </a:rPr>
+              <a:t>对抗文本</a:t>
+            </a:r>
+            <a:endParaRPr lang="zh-CN" altLang="en-US" sz="1200" b="1">
+              <a:latin typeface="微软雅黑" charset="0"/>
+              <a:ea typeface="微软雅黑" charset="0"/>
+              <a:cs typeface="微软雅黑" charset="0"/>
+            </a:endParaRPr>
+          </a:p>
+        </p:txBody>
+      </p:sp>
+      <p:pic>
+        <p:nvPicPr>
+          <p:cNvPr id="28" name="图片 27"/>
+          <p:cNvPicPr>
+            <a:picLocks noChangeAspect="1"/>
+          </p:cNvPicPr>
+          <p:nvPr>
+            <p:custDataLst>
+              <p:tags r:id="rId23"/>
+            </p:custDataLst>
+          </p:nvPr>
+        </p:nvPicPr>
+        <p:blipFill>
+          <a:blip r:embed="rId2"/>
+          <a:stretch>
+            <a:fillRect/>
+          </a:stretch>
+        </p:blipFill>
+        <p:spPr>
+          <a:xfrm>
+            <a:off x="243840" y="1595120"/>
+            <a:ext cx="1165860" cy="1144905"/>
+          </a:xfrm>
+          <a:prstGeom prst="rect">
+            <a:avLst/>
+          </a:prstGeom>
+        </p:spPr>
+      </p:pic>
+      <p:sp>
+        <p:nvSpPr>
+          <p:cNvPr id="29" name="右箭头 28"/>
+          <p:cNvSpPr/>
+          <p:nvPr>
+            <p:custDataLst>
+              <p:tags r:id="rId24"/>
+            </p:custDataLst>
+          </p:nvPr>
+        </p:nvSpPr>
+        <p:spPr>
+          <a:xfrm rot="12600000">
+            <a:off x="3978910" y="2870200"/>
+            <a:ext cx="403860" cy="220980"/>
+          </a:xfrm>
+          <a:prstGeom prst="rightArrow">
+            <a:avLst/>
+          </a:prstGeom>
+        </p:spPr>
+        <p:style>
+          <a:lnRef idx="2">
+            <a:schemeClr val="accent1">
+              <a:lumMod val="75000"/>
+            </a:schemeClr>
+          </a:lnRef>
+          <a:fillRef idx="1">
+            <a:schemeClr val="accent1"/>
+          </a:fillRef>
+          <a:effectRef idx="0">
+            <a:srgbClr val="FFFFFF"/>
+          </a:effectRef>
+          <a:fontRef idx="minor">
+            <a:schemeClr val="lt1"/>
+          </a:fontRef>
+        </p:style>
+        <p:txBody>
+          <a:bodyPr rtlCol="0" anchor="ctr"/>
+          <a:p>
+            <a:pPr algn="ctr"/>
+            <a:endParaRPr lang="zh-CN" altLang="en-US"/>
+          </a:p>
+        </p:txBody>
+      </p:sp>
+      <p:pic>
+        <p:nvPicPr>
+          <p:cNvPr id="30" name="图片 29"/>
+          <p:cNvPicPr>
+            <a:picLocks noChangeAspect="1"/>
+          </p:cNvPicPr>
+          <p:nvPr>
+            <p:custDataLst>
+              <p:tags r:id="rId25"/>
+            </p:custDataLst>
+          </p:nvPr>
+        </p:nvPicPr>
+        <p:blipFill>
+          <a:blip r:embed="rId26"/>
+          <a:stretch>
+            <a:fillRect/>
+          </a:stretch>
+        </p:blipFill>
+        <p:spPr>
+          <a:xfrm>
+            <a:off x="50800" y="3228975"/>
+            <a:ext cx="4356100" cy="769620"/>
+          </a:xfrm>
+          <a:prstGeom prst="rect">
+            <a:avLst/>
+          </a:prstGeom>
+        </p:spPr>
+      </p:pic>
+      <p:sp>
+        <p:nvSpPr>
+          <p:cNvPr id="32" name="文本框 31"/>
+          <p:cNvSpPr txBox="1"/>
+          <p:nvPr>
+            <p:custDataLst>
+              <p:tags r:id="rId27"/>
+            </p:custDataLst>
+          </p:nvPr>
+        </p:nvSpPr>
+        <p:spPr>
+          <a:xfrm>
+            <a:off x="369570" y="3871595"/>
+            <a:ext cx="3644265" cy="1005205"/>
+          </a:xfrm>
+          <a:prstGeom prst="rect">
+            <a:avLst/>
+          </a:prstGeom>
+          <a:noFill/>
+        </p:spPr>
+        <p:txBody>
+          <a:bodyPr wrap="square" rtlCol="0">
+            <a:noAutofit/>
+          </a:bodyPr>
+          <a:p>
+            <a:pPr algn="ctr"/>
+            <a:r>
+              <a:rPr lang="zh-CN" altLang="en-US" sz="1200" b="1">
+                <a:latin typeface="微软雅黑" charset="0"/>
+                <a:ea typeface="微软雅黑" charset="0"/>
+                <a:cs typeface="微软雅黑" charset="0"/>
+              </a:rPr>
+              <a:t>第二步</a:t>
+            </a:r>
+            <a:r>
+              <a:rPr lang="en-US" altLang="zh-CN" sz="1200" b="1">
+                <a:latin typeface="微软雅黑" charset="0"/>
+                <a:ea typeface="微软雅黑" charset="0"/>
+                <a:cs typeface="微软雅黑" charset="0"/>
+              </a:rPr>
+              <a:t> </a:t>
+            </a:r>
+            <a:r>
+              <a:rPr lang="zh-CN" altLang="en-US" sz="1200" b="1">
+                <a:latin typeface="微软雅黑" charset="0"/>
+                <a:ea typeface="微软雅黑" charset="0"/>
+                <a:cs typeface="微软雅黑" charset="0"/>
+              </a:rPr>
+              <a:t>根据对抗文本生成对抗图像</a:t>
+            </a:r>
+            <a:br>
+              <a:rPr lang="zh-CN" altLang="en-US" sz="1200" b="1">
+                <a:latin typeface="微软雅黑" charset="0"/>
+                <a:ea typeface="微软雅黑" charset="0"/>
+                <a:cs typeface="微软雅黑" charset="0"/>
+              </a:rPr>
+            </a:br>
+            <a:r>
+              <a:rPr lang="zh-CN" altLang="en-US" sz="1200" b="1">
+                <a:latin typeface="微软雅黑" charset="0"/>
+                <a:ea typeface="微软雅黑" charset="0"/>
+                <a:cs typeface="微软雅黑" charset="0"/>
+              </a:rPr>
+              <a:t>在允许的扰动幅度之下，最大化第一步生成的扰动文本和每一个缩放图像在特征空间下的余弦相似度来生成对抗</a:t>
+            </a:r>
+            <a:r>
+              <a:rPr lang="zh-CN" altLang="en-US" sz="1200" b="1">
+                <a:latin typeface="微软雅黑" charset="0"/>
+                <a:ea typeface="微软雅黑" charset="0"/>
+                <a:cs typeface="微软雅黑" charset="0"/>
+              </a:rPr>
+              <a:t>图像</a:t>
+            </a:r>
+            <a:endParaRPr lang="zh-CN" altLang="en-US" sz="1200" b="1">
+              <a:latin typeface="微软雅黑" charset="0"/>
+              <a:ea typeface="微软雅黑" charset="0"/>
+              <a:cs typeface="微软雅黑" charset="0"/>
+            </a:endParaRPr>
+          </a:p>
+        </p:txBody>
+      </p:sp>
+      <p:pic>
+        <p:nvPicPr>
+          <p:cNvPr id="33" name="图片 32"/>
+          <p:cNvPicPr>
+            <a:picLocks noChangeAspect="1"/>
+          </p:cNvPicPr>
+          <p:nvPr>
+            <p:custDataLst>
+              <p:tags r:id="rId28"/>
+            </p:custDataLst>
+          </p:nvPr>
+        </p:nvPicPr>
+        <p:blipFill>
+          <a:blip r:embed="rId2"/>
+          <a:stretch>
+            <a:fillRect/>
+          </a:stretch>
+        </p:blipFill>
+        <p:spPr>
+          <a:xfrm>
+            <a:off x="1985010" y="5798185"/>
+            <a:ext cx="698500" cy="685800"/>
+          </a:xfrm>
+          <a:prstGeom prst="rect">
+            <a:avLst/>
+          </a:prstGeom>
+        </p:spPr>
+      </p:pic>
+      <p:pic>
+        <p:nvPicPr>
+          <p:cNvPr id="34" name="图片 33"/>
+          <p:cNvPicPr>
+            <a:picLocks noChangeAspect="1"/>
+          </p:cNvPicPr>
+          <p:nvPr>
+            <p:custDataLst>
+              <p:tags r:id="rId29"/>
+            </p:custDataLst>
+          </p:nvPr>
+        </p:nvPicPr>
+        <p:blipFill>
+          <a:blip r:embed="rId2"/>
+          <a:stretch>
+            <a:fillRect/>
+          </a:stretch>
+        </p:blipFill>
+        <p:spPr>
+          <a:xfrm flipH="1">
+            <a:off x="3133090" y="5798185"/>
+            <a:ext cx="698500" cy="685800"/>
+          </a:xfrm>
+          <a:prstGeom prst="rect">
+            <a:avLst/>
+          </a:prstGeom>
+        </p:spPr>
+      </p:pic>
+      <p:pic>
+        <p:nvPicPr>
+          <p:cNvPr id="35" name="图片 34"/>
+          <p:cNvPicPr>
+            <a:picLocks noChangeAspect="1"/>
+          </p:cNvPicPr>
+          <p:nvPr>
+            <p:custDataLst>
+              <p:tags r:id="rId30"/>
+            </p:custDataLst>
+          </p:nvPr>
+        </p:nvPicPr>
+        <p:blipFill>
+          <a:blip r:embed="rId2"/>
+          <a:stretch>
+            <a:fillRect/>
+          </a:stretch>
+        </p:blipFill>
+        <p:spPr>
+          <a:xfrm>
+            <a:off x="624840" y="5532120"/>
+            <a:ext cx="1165860" cy="1144905"/>
+          </a:xfrm>
+          <a:prstGeom prst="rect">
+            <a:avLst/>
+          </a:prstGeom>
+        </p:spPr>
+      </p:pic>
+      <p:sp>
+        <p:nvSpPr>
+          <p:cNvPr id="36" name="右箭头 35"/>
+          <p:cNvSpPr/>
+          <p:nvPr>
+            <p:custDataLst>
+              <p:tags r:id="rId31"/>
+            </p:custDataLst>
+          </p:nvPr>
+        </p:nvSpPr>
+        <p:spPr>
+          <a:xfrm rot="5400000">
+            <a:off x="1751330" y="2963545"/>
+            <a:ext cx="403860" cy="220980"/>
+          </a:xfrm>
+          <a:prstGeom prst="rightArrow">
+            <a:avLst/>
+          </a:prstGeom>
+        </p:spPr>
+        <p:style>
+          <a:lnRef idx="2">
+            <a:schemeClr val="accent1">
+              <a:lumMod val="75000"/>
+            </a:schemeClr>
+          </a:lnRef>
+          <a:fillRef idx="1">
+            <a:schemeClr val="accent1"/>
+          </a:fillRef>
+          <a:effectRef idx="0">
+            <a:srgbClr val="FFFFFF"/>
+          </a:effectRef>
+          <a:fontRef idx="minor">
+            <a:schemeClr val="lt1"/>
+          </a:fontRef>
+        </p:style>
+        <p:txBody>
+          <a:bodyPr rtlCol="0" anchor="ctr"/>
+          <a:p>
+            <a:pPr algn="ctr"/>
+            <a:endParaRPr lang="zh-CN" altLang="en-US"/>
+          </a:p>
+        </p:txBody>
+      </p:sp>
+      <p:sp>
+        <p:nvSpPr>
+          <p:cNvPr id="37" name="右箭头 36"/>
+          <p:cNvSpPr/>
+          <p:nvPr>
+            <p:custDataLst>
+              <p:tags r:id="rId32"/>
+            </p:custDataLst>
+          </p:nvPr>
+        </p:nvSpPr>
+        <p:spPr>
+          <a:xfrm rot="5400000">
+            <a:off x="1751330" y="4868545"/>
+            <a:ext cx="403860" cy="220980"/>
+          </a:xfrm>
+          <a:prstGeom prst="rightArrow">
+            <a:avLst/>
+          </a:prstGeom>
+        </p:spPr>
+        <p:style>
+          <a:lnRef idx="2">
+            <a:schemeClr val="accent1">
+              <a:lumMod val="75000"/>
+            </a:schemeClr>
+          </a:lnRef>
+          <a:fillRef idx="1">
+            <a:schemeClr val="accent1"/>
+          </a:fillRef>
+          <a:effectRef idx="0">
+            <a:srgbClr val="FFFFFF"/>
+          </a:effectRef>
+          <a:fontRef idx="minor">
+            <a:schemeClr val="lt1"/>
+          </a:fontRef>
+        </p:style>
+        <p:txBody>
+          <a:bodyPr rtlCol="0" anchor="ctr"/>
+          <a:p>
+            <a:pPr algn="ctr"/>
+            <a:endParaRPr lang="zh-CN" altLang="en-US"/>
+          </a:p>
+        </p:txBody>
+      </p:sp>
+      <p:sp>
+        <p:nvSpPr>
+          <p:cNvPr id="38" name="文本框 37"/>
+          <p:cNvSpPr txBox="1"/>
+          <p:nvPr>
+            <p:custDataLst>
+              <p:tags r:id="rId33"/>
+            </p:custDataLst>
+          </p:nvPr>
+        </p:nvSpPr>
+        <p:spPr>
+          <a:xfrm>
+            <a:off x="651510" y="5141595"/>
+            <a:ext cx="2604135" cy="537210"/>
+          </a:xfrm>
+          <a:prstGeom prst="rect">
+            <a:avLst/>
+          </a:prstGeom>
+          <a:noFill/>
+        </p:spPr>
+        <p:txBody>
+          <a:bodyPr wrap="square" rtlCol="0">
+            <a:noAutofit/>
+          </a:bodyPr>
+          <a:p>
+            <a:pPr algn="ctr"/>
+            <a:r>
+              <a:rPr lang="zh-CN" altLang="en-US" sz="1200" b="1">
+                <a:latin typeface="微软雅黑" charset="0"/>
+                <a:ea typeface="微软雅黑" charset="0"/>
+                <a:cs typeface="微软雅黑" charset="0"/>
+              </a:rPr>
+              <a:t>扰动</a:t>
+            </a:r>
+            <a:r>
+              <a:rPr lang="zh-CN" altLang="en-US" sz="1200" b="1">
+                <a:latin typeface="微软雅黑" charset="0"/>
+                <a:ea typeface="微软雅黑" charset="0"/>
+                <a:cs typeface="微软雅黑" charset="0"/>
+              </a:rPr>
+              <a:t>图像</a:t>
+            </a:r>
+            <a:endParaRPr lang="zh-CN" altLang="en-US" sz="1200" b="1">
+              <a:latin typeface="微软雅黑" charset="0"/>
+              <a:ea typeface="微软雅黑" charset="0"/>
+              <a:cs typeface="微软雅黑" charset="0"/>
+            </a:endParaRPr>
+          </a:p>
+        </p:txBody>
+      </p:sp>
+      <p:sp>
+        <p:nvSpPr>
+          <p:cNvPr id="39" name="文本框 38"/>
+          <p:cNvSpPr txBox="1"/>
+          <p:nvPr>
+            <p:custDataLst>
+              <p:tags r:id="rId34"/>
+            </p:custDataLst>
+          </p:nvPr>
+        </p:nvSpPr>
+        <p:spPr>
+          <a:xfrm>
+            <a:off x="651510" y="188595"/>
+            <a:ext cx="2604135" cy="537210"/>
+          </a:xfrm>
+          <a:prstGeom prst="rect">
+            <a:avLst/>
+          </a:prstGeom>
+          <a:noFill/>
+        </p:spPr>
+        <p:txBody>
+          <a:bodyPr wrap="square" rtlCol="0">
+            <a:noAutofit/>
+          </a:bodyPr>
+          <a:p>
+            <a:pPr algn="ctr"/>
+            <a:r>
+              <a:rPr lang="zh-CN" altLang="en-US" sz="1200" b="1">
+                <a:latin typeface="微软雅黑" charset="0"/>
+                <a:ea typeface="微软雅黑" charset="0"/>
+                <a:cs typeface="微软雅黑" charset="0"/>
+              </a:rPr>
+              <a:t>干净</a:t>
+            </a:r>
+            <a:r>
+              <a:rPr lang="zh-CN" altLang="en-US" sz="1200" b="1">
+                <a:latin typeface="微软雅黑" charset="0"/>
+                <a:ea typeface="微软雅黑" charset="0"/>
+                <a:cs typeface="微软雅黑" charset="0"/>
+              </a:rPr>
+              <a:t>图像</a:t>
+            </a:r>
+            <a:endParaRPr lang="zh-CN" altLang="en-US" sz="1200" b="1">
+              <a:latin typeface="微软雅黑" charset="0"/>
+              <a:ea typeface="微软雅黑" charset="0"/>
+              <a:cs typeface="微软雅黑" charset="0"/>
+            </a:endParaRPr>
+          </a:p>
+        </p:txBody>
+      </p:sp>
+      <p:sp>
+        <p:nvSpPr>
+          <p:cNvPr id="40" name="文本框 39"/>
+          <p:cNvSpPr txBox="1"/>
+          <p:nvPr>
+            <p:custDataLst>
+              <p:tags r:id="rId35"/>
+            </p:custDataLst>
+          </p:nvPr>
+        </p:nvSpPr>
+        <p:spPr>
+          <a:xfrm>
+            <a:off x="651510" y="2601595"/>
+            <a:ext cx="2604135" cy="537210"/>
+          </a:xfrm>
+          <a:prstGeom prst="rect">
+            <a:avLst/>
+          </a:prstGeom>
+          <a:noFill/>
+        </p:spPr>
+        <p:txBody>
+          <a:bodyPr wrap="square" rtlCol="0">
+            <a:noAutofit/>
+          </a:bodyPr>
+          <a:p>
+            <a:pPr algn="ctr"/>
+            <a:r>
+              <a:rPr lang="zh-CN" altLang="en-US" sz="1200" b="1">
+                <a:latin typeface="微软雅黑" charset="0"/>
+                <a:ea typeface="微软雅黑" charset="0"/>
+                <a:cs typeface="微软雅黑" charset="0"/>
+              </a:rPr>
+              <a:t>预处理</a:t>
+            </a:r>
+            <a:r>
+              <a:rPr lang="zh-CN" altLang="en-US" sz="1200" b="1">
+                <a:latin typeface="微软雅黑" charset="0"/>
+                <a:ea typeface="微软雅黑" charset="0"/>
+                <a:cs typeface="微软雅黑" charset="0"/>
+              </a:rPr>
+              <a:t>图像</a:t>
+            </a:r>
+            <a:endParaRPr lang="zh-CN" altLang="en-US" sz="1200" b="1">
+              <a:latin typeface="微软雅黑" charset="0"/>
+              <a:ea typeface="微软雅黑" charset="0"/>
+              <a:cs typeface="微软雅黑" charset="0"/>
+            </a:endParaRPr>
+          </a:p>
+        </p:txBody>
+      </p:sp>
+      <p:sp>
+        <p:nvSpPr>
+          <p:cNvPr id="41" name="文本框 40"/>
+          <p:cNvSpPr txBox="1"/>
+          <p:nvPr>
+            <p:custDataLst>
+              <p:tags r:id="rId36"/>
+            </p:custDataLst>
+          </p:nvPr>
+        </p:nvSpPr>
+        <p:spPr>
+          <a:xfrm>
+            <a:off x="4842510" y="442595"/>
+            <a:ext cx="2604135" cy="537210"/>
+          </a:xfrm>
+          <a:prstGeom prst="rect">
+            <a:avLst/>
+          </a:prstGeom>
+          <a:noFill/>
+        </p:spPr>
+        <p:txBody>
+          <a:bodyPr wrap="square" rtlCol="0">
+            <a:noAutofit/>
+          </a:bodyPr>
+          <a:p>
+            <a:pPr algn="ctr"/>
+            <a:r>
+              <a:rPr lang="zh-CN" altLang="en-US" sz="1200" b="1">
+                <a:latin typeface="微软雅黑" charset="0"/>
+                <a:ea typeface="微软雅黑" charset="0"/>
+                <a:cs typeface="微软雅黑" charset="0"/>
+              </a:rPr>
+              <a:t>干净文本</a:t>
+            </a:r>
+            <a:endParaRPr lang="zh-CN" altLang="en-US" sz="1200" b="1">
+              <a:latin typeface="微软雅黑" charset="0"/>
+              <a:ea typeface="微软雅黑" charset="0"/>
+              <a:cs typeface="微软雅黑" charset="0"/>
+            </a:endParaRPr>
+          </a:p>
+        </p:txBody>
+      </p:sp>
+      <p:sp>
+        <p:nvSpPr>
+          <p:cNvPr id="42" name="文本框 41"/>
+          <p:cNvSpPr txBox="1"/>
+          <p:nvPr>
+            <p:custDataLst>
+              <p:tags r:id="rId37"/>
+            </p:custDataLst>
+          </p:nvPr>
+        </p:nvSpPr>
+        <p:spPr>
+          <a:xfrm>
+            <a:off x="4842510" y="1712595"/>
+            <a:ext cx="2604135" cy="537210"/>
+          </a:xfrm>
+          <a:prstGeom prst="rect">
+            <a:avLst/>
+          </a:prstGeom>
+          <a:noFill/>
+        </p:spPr>
+        <p:txBody>
+          <a:bodyPr wrap="square" rtlCol="0">
+            <a:noAutofit/>
+          </a:bodyPr>
+          <a:p>
+            <a:pPr algn="ctr"/>
+            <a:r>
+              <a:rPr lang="zh-CN" altLang="en-US" sz="1200" b="1">
+                <a:latin typeface="微软雅黑" charset="0"/>
+                <a:ea typeface="微软雅黑" charset="0"/>
+                <a:cs typeface="微软雅黑" charset="0"/>
+              </a:rPr>
+              <a:t>干净文本</a:t>
+            </a:r>
+            <a:r>
+              <a:rPr lang="zh-CN" altLang="en-US" sz="1200" b="1">
+                <a:latin typeface="微软雅黑" charset="0"/>
+                <a:ea typeface="微软雅黑" charset="0"/>
+                <a:cs typeface="微软雅黑" charset="0"/>
+              </a:rPr>
+              <a:t>集</a:t>
+            </a:r>
+            <a:endParaRPr lang="zh-CN" altLang="en-US" sz="1200" b="1">
+              <a:latin typeface="微软雅黑" charset="0"/>
+              <a:ea typeface="微软雅黑" charset="0"/>
+              <a:cs typeface="微软雅黑" charset="0"/>
+            </a:endParaRPr>
+          </a:p>
+        </p:txBody>
+      </p:sp>
+      <p:sp>
+        <p:nvSpPr>
+          <p:cNvPr id="43" name="文本框 42"/>
+          <p:cNvSpPr txBox="1"/>
+          <p:nvPr>
+            <p:custDataLst>
+              <p:tags r:id="rId38"/>
+            </p:custDataLst>
+          </p:nvPr>
+        </p:nvSpPr>
+        <p:spPr>
+          <a:xfrm>
+            <a:off x="4842510" y="2982595"/>
+            <a:ext cx="2604135" cy="537210"/>
+          </a:xfrm>
+          <a:prstGeom prst="rect">
+            <a:avLst/>
+          </a:prstGeom>
+          <a:noFill/>
+        </p:spPr>
+        <p:txBody>
+          <a:bodyPr wrap="square" rtlCol="0">
+            <a:noAutofit/>
+          </a:bodyPr>
+          <a:p>
+            <a:pPr algn="ctr"/>
+            <a:r>
+              <a:rPr lang="zh-CN" altLang="en-US" sz="1200" b="1">
+                <a:latin typeface="微软雅黑" charset="0"/>
+                <a:ea typeface="微软雅黑" charset="0"/>
+                <a:cs typeface="微软雅黑" charset="0"/>
+              </a:rPr>
+              <a:t>扰动文本</a:t>
+            </a:r>
+            <a:r>
+              <a:rPr lang="zh-CN" altLang="en-US" sz="1200" b="1">
+                <a:latin typeface="微软雅黑" charset="0"/>
+                <a:ea typeface="微软雅黑" charset="0"/>
+                <a:cs typeface="微软雅黑" charset="0"/>
+              </a:rPr>
+              <a:t>集</a:t>
+            </a:r>
+            <a:endParaRPr lang="zh-CN" altLang="en-US" sz="1200" b="1">
+              <a:latin typeface="微软雅黑" charset="0"/>
+              <a:ea typeface="微软雅黑" charset="0"/>
+              <a:cs typeface="微软雅黑" charset="0"/>
+            </a:endParaRPr>
+          </a:p>
+        </p:txBody>
+      </p:sp>
+    </p:spTree>
+  </p:cSld>
+  <p:clrMapOvr>
+    <a:masterClrMapping/>
+  </p:clrMapOvr>
+</p:sld>
+</file>
+
 <file path=ppt/tags/tag1.xml><?xml version="1.0" encoding="utf-8"?>
 <p:tagLst xmlns:p="http://schemas.openxmlformats.org/presentationml/2006/main">
   <p:tag name="KSO_WM_BEAUTIFY_FLAG" val=""/>
@@ -9390,12 +10971,108 @@
 </p:tagLst>
 </file>
 
+<file path=ppt/tags/tag100.xml><?xml version="1.0" encoding="utf-8"?>
+<p:tagLst xmlns:p="http://schemas.openxmlformats.org/presentationml/2006/main">
+  <p:tag name="KSO_WM_BEAUTIFY_FLAG" val=""/>
+</p:tagLst>
+</file>
+
+<file path=ppt/tags/tag101.xml><?xml version="1.0" encoding="utf-8"?>
+<p:tagLst xmlns:p="http://schemas.openxmlformats.org/presentationml/2006/main">
+  <p:tag name="KSO_WM_BEAUTIFY_FLAG" val=""/>
+</p:tagLst>
+</file>
+
+<file path=ppt/tags/tag102.xml><?xml version="1.0" encoding="utf-8"?>
+<p:tagLst xmlns:p="http://schemas.openxmlformats.org/presentationml/2006/main">
+  <p:tag name="KSO_WM_BEAUTIFY_FLAG" val=""/>
+</p:tagLst>
+</file>
+
+<file path=ppt/tags/tag103.xml><?xml version="1.0" encoding="utf-8"?>
+<p:tagLst xmlns:p="http://schemas.openxmlformats.org/presentationml/2006/main">
+  <p:tag name="KSO_WM_BEAUTIFY_FLAG" val=""/>
+</p:tagLst>
+</file>
+
+<file path=ppt/tags/tag104.xml><?xml version="1.0" encoding="utf-8"?>
+<p:tagLst xmlns:p="http://schemas.openxmlformats.org/presentationml/2006/main">
+  <p:tag name="KSO_WM_BEAUTIFY_FLAG" val=""/>
+</p:tagLst>
+</file>
+
+<file path=ppt/tags/tag105.xml><?xml version="1.0" encoding="utf-8"?>
+<p:tagLst xmlns:p="http://schemas.openxmlformats.org/presentationml/2006/main">
+  <p:tag name="KSO_WM_BEAUTIFY_FLAG" val=""/>
+</p:tagLst>
+</file>
+
+<file path=ppt/tags/tag106.xml><?xml version="1.0" encoding="utf-8"?>
+<p:tagLst xmlns:p="http://schemas.openxmlformats.org/presentationml/2006/main">
+  <p:tag name="KSO_WM_BEAUTIFY_FLAG" val=""/>
+</p:tagLst>
+</file>
+
+<file path=ppt/tags/tag107.xml><?xml version="1.0" encoding="utf-8"?>
+<p:tagLst xmlns:p="http://schemas.openxmlformats.org/presentationml/2006/main">
+  <p:tag name="KSO_WM_BEAUTIFY_FLAG" val=""/>
+</p:tagLst>
+</file>
+
+<file path=ppt/tags/tag108.xml><?xml version="1.0" encoding="utf-8"?>
+<p:tagLst xmlns:p="http://schemas.openxmlformats.org/presentationml/2006/main">
+  <p:tag name="KSO_WM_BEAUTIFY_FLAG" val=""/>
+</p:tagLst>
+</file>
+
+<file path=ppt/tags/tag109.xml><?xml version="1.0" encoding="utf-8"?>
+<p:tagLst xmlns:p="http://schemas.openxmlformats.org/presentationml/2006/main">
+  <p:tag name="KSO_WM_BEAUTIFY_FLAG" val=""/>
+</p:tagLst>
+</file>
+
 <file path=ppt/tags/tag11.xml><?xml version="1.0" encoding="utf-8"?>
 <p:tagLst xmlns:p="http://schemas.openxmlformats.org/presentationml/2006/main">
   <p:tag name="KSO_WM_BEAUTIFY_FLAG" val=""/>
 </p:tagLst>
 </file>
 
+<file path=ppt/tags/tag110.xml><?xml version="1.0" encoding="utf-8"?>
+<p:tagLst xmlns:p="http://schemas.openxmlformats.org/presentationml/2006/main">
+  <p:tag name="KSO_WM_BEAUTIFY_FLAG" val=""/>
+</p:tagLst>
+</file>
+
+<file path=ppt/tags/tag111.xml><?xml version="1.0" encoding="utf-8"?>
+<p:tagLst xmlns:p="http://schemas.openxmlformats.org/presentationml/2006/main">
+  <p:tag name="KSO_WM_BEAUTIFY_FLAG" val=""/>
+</p:tagLst>
+</file>
+
+<file path=ppt/tags/tag112.xml><?xml version="1.0" encoding="utf-8"?>
+<p:tagLst xmlns:p="http://schemas.openxmlformats.org/presentationml/2006/main">
+  <p:tag name="KSO_WM_BEAUTIFY_FLAG" val=""/>
+</p:tagLst>
+</file>
+
+<file path=ppt/tags/tag113.xml><?xml version="1.0" encoding="utf-8"?>
+<p:tagLst xmlns:p="http://schemas.openxmlformats.org/presentationml/2006/main">
+  <p:tag name="KSO_WM_BEAUTIFY_FLAG" val=""/>
+</p:tagLst>
+</file>
+
+<file path=ppt/tags/tag114.xml><?xml version="1.0" encoding="utf-8"?>
+<p:tagLst xmlns:p="http://schemas.openxmlformats.org/presentationml/2006/main">
+  <p:tag name="KSO_WM_BEAUTIFY_FLAG" val=""/>
+</p:tagLst>
+</file>
+
+<file path=ppt/tags/tag115.xml><?xml version="1.0" encoding="utf-8"?>
+<p:tagLst xmlns:p="http://schemas.openxmlformats.org/presentationml/2006/main">
+  <p:tag name="KSO_WM_BEAUTIFY_FLAG" val=""/>
+</p:tagLst>
+</file>
+
 <file path=ppt/tags/tag12.xml><?xml version="1.0" encoding="utf-8"?>
 <p:tagLst xmlns:p="http://schemas.openxmlformats.org/presentationml/2006/main">
   <p:tag name="KSO_WM_BEAUTIFY_FLAG" val=""/>
@@ -9852,7 +11529,121 @@
 </p:tagLst>
 </file>
 
+<file path=ppt/tags/tag81.xml><?xml version="1.0" encoding="utf-8"?>
+<p:tagLst xmlns:p="http://schemas.openxmlformats.org/presentationml/2006/main">
+  <p:tag name="KSO_WM_BEAUTIFY_FLAG" val=""/>
+</p:tagLst>
+</file>
+
+<file path=ppt/tags/tag82.xml><?xml version="1.0" encoding="utf-8"?>
+<p:tagLst xmlns:p="http://schemas.openxmlformats.org/presentationml/2006/main">
+  <p:tag name="KSO_WM_BEAUTIFY_FLAG" val=""/>
+</p:tagLst>
+</file>
+
+<file path=ppt/tags/tag83.xml><?xml version="1.0" encoding="utf-8"?>
+<p:tagLst xmlns:p="http://schemas.openxmlformats.org/presentationml/2006/main">
+  <p:tag name="KSO_WM_BEAUTIFY_FLAG" val=""/>
+</p:tagLst>
+</file>
+
+<file path=ppt/tags/tag84.xml><?xml version="1.0" encoding="utf-8"?>
+<p:tagLst xmlns:p="http://schemas.openxmlformats.org/presentationml/2006/main">
+  <p:tag name="KSO_WM_BEAUTIFY_FLAG" val=""/>
+</p:tagLst>
+</file>
+
+<file path=ppt/tags/tag85.xml><?xml version="1.0" encoding="utf-8"?>
+<p:tagLst xmlns:p="http://schemas.openxmlformats.org/presentationml/2006/main">
+  <p:tag name="KSO_WM_BEAUTIFY_FLAG" val=""/>
+</p:tagLst>
+</file>
+
+<file path=ppt/tags/tag86.xml><?xml version="1.0" encoding="utf-8"?>
+<p:tagLst xmlns:p="http://schemas.openxmlformats.org/presentationml/2006/main">
+  <p:tag name="KSO_WM_BEAUTIFY_FLAG" val=""/>
+</p:tagLst>
+</file>
+
+<file path=ppt/tags/tag87.xml><?xml version="1.0" encoding="utf-8"?>
+<p:tagLst xmlns:p="http://schemas.openxmlformats.org/presentationml/2006/main">
+  <p:tag name="KSO_WM_BEAUTIFY_FLAG" val=""/>
+</p:tagLst>
+</file>
+
+<file path=ppt/tags/tag88.xml><?xml version="1.0" encoding="utf-8"?>
+<p:tagLst xmlns:p="http://schemas.openxmlformats.org/presentationml/2006/main">
+  <p:tag name="KSO_WM_BEAUTIFY_FLAG" val=""/>
+</p:tagLst>
+</file>
+
+<file path=ppt/tags/tag89.xml><?xml version="1.0" encoding="utf-8"?>
+<p:tagLst xmlns:p="http://schemas.openxmlformats.org/presentationml/2006/main">
+  <p:tag name="KSO_WM_BEAUTIFY_FLAG" val=""/>
+</p:tagLst>
+</file>
+
 <file path=ppt/tags/tag9.xml><?xml version="1.0" encoding="utf-8"?>
+<p:tagLst xmlns:p="http://schemas.openxmlformats.org/presentationml/2006/main">
+  <p:tag name="KSO_WM_BEAUTIFY_FLAG" val=""/>
+</p:tagLst>
+</file>
+
+<file path=ppt/tags/tag90.xml><?xml version="1.0" encoding="utf-8"?>
+<p:tagLst xmlns:p="http://schemas.openxmlformats.org/presentationml/2006/main">
+  <p:tag name="KSO_WM_BEAUTIFY_FLAG" val=""/>
+</p:tagLst>
+</file>
+
+<file path=ppt/tags/tag91.xml><?xml version="1.0" encoding="utf-8"?>
+<p:tagLst xmlns:p="http://schemas.openxmlformats.org/presentationml/2006/main">
+  <p:tag name="KSO_WM_BEAUTIFY_FLAG" val=""/>
+</p:tagLst>
+</file>
+
+<file path=ppt/tags/tag92.xml><?xml version="1.0" encoding="utf-8"?>
+<p:tagLst xmlns:p="http://schemas.openxmlformats.org/presentationml/2006/main">
+  <p:tag name="KSO_WM_BEAUTIFY_FLAG" val=""/>
+</p:tagLst>
+</file>
+
+<file path=ppt/tags/tag93.xml><?xml version="1.0" encoding="utf-8"?>
+<p:tagLst xmlns:p="http://schemas.openxmlformats.org/presentationml/2006/main">
+  <p:tag name="KSO_WM_BEAUTIFY_FLAG" val=""/>
+</p:tagLst>
+</file>
+
+<file path=ppt/tags/tag94.xml><?xml version="1.0" encoding="utf-8"?>
+<p:tagLst xmlns:p="http://schemas.openxmlformats.org/presentationml/2006/main">
+  <p:tag name="KSO_WM_BEAUTIFY_FLAG" val=""/>
+</p:tagLst>
+</file>
+
+<file path=ppt/tags/tag95.xml><?xml version="1.0" encoding="utf-8"?>
+<p:tagLst xmlns:p="http://schemas.openxmlformats.org/presentationml/2006/main">
+  <p:tag name="KSO_WM_BEAUTIFY_FLAG" val=""/>
+</p:tagLst>
+</file>
+
+<file path=ppt/tags/tag96.xml><?xml version="1.0" encoding="utf-8"?>
+<p:tagLst xmlns:p="http://schemas.openxmlformats.org/presentationml/2006/main">
+  <p:tag name="KSO_WM_BEAUTIFY_FLAG" val=""/>
+</p:tagLst>
+</file>
+
+<file path=ppt/tags/tag97.xml><?xml version="1.0" encoding="utf-8"?>
+<p:tagLst xmlns:p="http://schemas.openxmlformats.org/presentationml/2006/main">
+  <p:tag name="KSO_WM_BEAUTIFY_FLAG" val=""/>
+</p:tagLst>
+</file>
+
+<file path=ppt/tags/tag98.xml><?xml version="1.0" encoding="utf-8"?>
+<p:tagLst xmlns:p="http://schemas.openxmlformats.org/presentationml/2006/main">
+  <p:tag name="KSO_WM_BEAUTIFY_FLAG" val=""/>
+</p:tagLst>
+</file>
+
+<file path=ppt/tags/tag99.xml><?xml version="1.0" encoding="utf-8"?>
 <p:tagLst xmlns:p="http://schemas.openxmlformats.org/presentationml/2006/main">
   <p:tag name="KSO_WM_BEAUTIFY_FLAG" val=""/>
 </p:tagLst>

</xml_diff>

<commit_message>
update_Transferable Multimodal Attack on Vision-Language Pre-training Models
</commit_message>
<xml_diff>
--- a/Attack/Adversarial_Attack/VLP/论文作图.pptx
+++ b/Attack/Adversarial_Attack/VLP/论文作图.pptx
@@ -8,7 +8,7 @@
     <p:notesMasterId r:id="rId5"/>
   </p:notesMasterIdLst>
   <p:handoutMasterIdLst>
-    <p:handoutMasterId r:id="rId11"/>
+    <p:handoutMasterId r:id="rId13"/>
   </p:handoutMasterIdLst>
   <p:sldIdLst>
     <p:sldId id="258" r:id="rId3"/>
@@ -18,6 +18,8 @@
     <p:sldId id="260" r:id="rId8"/>
     <p:sldId id="261" r:id="rId9"/>
     <p:sldId id="262" r:id="rId10"/>
+    <p:sldId id="263" r:id="rId11"/>
+    <p:sldId id="264" r:id="rId12"/>
   </p:sldIdLst>
   <p:sldSz cx="12192000" cy="6858000"/>
   <p:notesSz cx="7103745" cy="10234295"/>
@@ -10691,15 +10693,15 @@
                 <a:ea typeface="微软雅黑" charset="0"/>
                 <a:cs typeface="微软雅黑" charset="0"/>
               </a:rPr>
-              <a:t>扰动</a:t>
-            </a:r>
-            <a:r>
-              <a:rPr lang="zh-CN" altLang="en-US" sz="1200" b="1">
-                <a:latin typeface="微软雅黑" charset="0"/>
-                <a:ea typeface="微软雅黑" charset="0"/>
-                <a:cs typeface="微软雅黑" charset="0"/>
-              </a:rPr>
-              <a:t>图像</a:t>
+              <a:t>扰动图像</a:t>
+            </a:r>
+            <a:r>
+              <a:rPr lang="zh-CN" altLang="en-US" sz="1200" b="1">
+                <a:latin typeface="微软雅黑" charset="0"/>
+                <a:ea typeface="微软雅黑" charset="0"/>
+                <a:cs typeface="微软雅黑" charset="0"/>
+              </a:rPr>
+              <a:t>集</a:t>
             </a:r>
             <a:endParaRPr lang="zh-CN" altLang="en-US" sz="1200" b="1">
               <a:latin typeface="微软雅黑" charset="0"/>
@@ -10791,15 +10793,15 @@
                 <a:ea typeface="微软雅黑" charset="0"/>
                 <a:cs typeface="微软雅黑" charset="0"/>
               </a:rPr>
-              <a:t>预处理</a:t>
-            </a:r>
-            <a:r>
-              <a:rPr lang="zh-CN" altLang="en-US" sz="1200" b="1">
-                <a:latin typeface="微软雅黑" charset="0"/>
-                <a:ea typeface="微软雅黑" charset="0"/>
-                <a:cs typeface="微软雅黑" charset="0"/>
-              </a:rPr>
-              <a:t>图像</a:t>
+              <a:t>预处理图像</a:t>
+            </a:r>
+            <a:r>
+              <a:rPr lang="zh-CN" altLang="en-US" sz="1200" b="1">
+                <a:latin typeface="微软雅黑" charset="0"/>
+                <a:ea typeface="微软雅黑" charset="0"/>
+                <a:cs typeface="微软雅黑" charset="0"/>
+              </a:rPr>
+              <a:t>集</a:t>
             </a:r>
             <a:endParaRPr lang="zh-CN" altLang="en-US" sz="1200" b="1">
               <a:latin typeface="微软雅黑" charset="0"/>
@@ -10942,6 +10944,384 @@
                 <a:cs typeface="微软雅黑" charset="0"/>
               </a:rPr>
               <a:t>集</a:t>
+            </a:r>
+            <a:endParaRPr lang="zh-CN" altLang="en-US" sz="1200" b="1">
+              <a:latin typeface="微软雅黑" charset="0"/>
+              <a:ea typeface="微软雅黑" charset="0"/>
+              <a:cs typeface="微软雅黑" charset="0"/>
+            </a:endParaRPr>
+          </a:p>
+        </p:txBody>
+      </p:sp>
+      <p:sp>
+        <p:nvSpPr>
+          <p:cNvPr id="44" name="文本框 43"/>
+          <p:cNvSpPr txBox="1"/>
+          <p:nvPr>
+            <p:custDataLst>
+              <p:tags r:id="rId39"/>
+            </p:custDataLst>
+          </p:nvPr>
+        </p:nvSpPr>
+        <p:spPr>
+          <a:xfrm>
+            <a:off x="10176510" y="2220595"/>
+            <a:ext cx="2604135" cy="537210"/>
+          </a:xfrm>
+          <a:prstGeom prst="rect">
+            <a:avLst/>
+          </a:prstGeom>
+          <a:noFill/>
+        </p:spPr>
+        <p:txBody>
+          <a:bodyPr wrap="square" rtlCol="0">
+            <a:noAutofit/>
+          </a:bodyPr>
+          <a:p>
+            <a:pPr algn="ctr"/>
+            <a:r>
+              <a:rPr lang="zh-CN" altLang="en-US" sz="1200" b="1">
+                <a:latin typeface="微软雅黑" charset="0"/>
+                <a:ea typeface="微软雅黑" charset="0"/>
+                <a:cs typeface="微软雅黑" charset="0"/>
+              </a:rPr>
+              <a:t>干净</a:t>
+            </a:r>
+            <a:r>
+              <a:rPr lang="zh-CN" altLang="en-US" sz="1200" b="1">
+                <a:latin typeface="微软雅黑" charset="0"/>
+                <a:ea typeface="微软雅黑" charset="0"/>
+                <a:cs typeface="微软雅黑" charset="0"/>
+              </a:rPr>
+              <a:t>图像</a:t>
+            </a:r>
+            <a:endParaRPr lang="zh-CN" altLang="en-US" sz="1200" b="1">
+              <a:latin typeface="微软雅黑" charset="0"/>
+              <a:ea typeface="微软雅黑" charset="0"/>
+              <a:cs typeface="微软雅黑" charset="0"/>
+            </a:endParaRPr>
+          </a:p>
+        </p:txBody>
+      </p:sp>
+      <p:pic>
+        <p:nvPicPr>
+          <p:cNvPr id="45" name="图片 44"/>
+          <p:cNvPicPr>
+            <a:picLocks noChangeAspect="1"/>
+          </p:cNvPicPr>
+          <p:nvPr>
+            <p:custDataLst>
+              <p:tags r:id="rId40"/>
+            </p:custDataLst>
+          </p:nvPr>
+        </p:nvPicPr>
+        <p:blipFill>
+          <a:blip r:embed="rId41"/>
+          <a:stretch>
+            <a:fillRect/>
+          </a:stretch>
+        </p:blipFill>
+        <p:spPr>
+          <a:xfrm>
+            <a:off x="4159250" y="5316220"/>
+            <a:ext cx="3111500" cy="723900"/>
+          </a:xfrm>
+          <a:prstGeom prst="rect">
+            <a:avLst/>
+          </a:prstGeom>
+        </p:spPr>
+      </p:pic>
+      <p:sp>
+        <p:nvSpPr>
+          <p:cNvPr id="46" name="文本框 45"/>
+          <p:cNvSpPr txBox="1"/>
+          <p:nvPr>
+            <p:custDataLst>
+              <p:tags r:id="rId42"/>
+            </p:custDataLst>
+          </p:nvPr>
+        </p:nvSpPr>
+        <p:spPr>
+          <a:xfrm>
+            <a:off x="7140575" y="6141720"/>
+            <a:ext cx="865505" cy="305435"/>
+          </a:xfrm>
+          <a:prstGeom prst="rect">
+            <a:avLst/>
+          </a:prstGeom>
+          <a:noFill/>
+        </p:spPr>
+        <p:txBody>
+          <a:bodyPr wrap="square" rtlCol="0">
+            <a:noAutofit/>
+          </a:bodyPr>
+          <a:p>
+            <a:pPr algn="ctr"/>
+            <a:r>
+              <a:rPr lang="en-US" altLang="zh-CN" sz="1200" b="1">
+                <a:latin typeface="微软雅黑" charset="0"/>
+                <a:ea typeface="微软雅黑" charset="0"/>
+                <a:cs typeface="微软雅黑" charset="0"/>
+              </a:rPr>
+              <a:t>a_text1</a:t>
+            </a:r>
+            <a:endParaRPr lang="en-US" altLang="zh-CN" sz="1200" b="1">
+              <a:latin typeface="微软雅黑" charset="0"/>
+              <a:ea typeface="微软雅黑" charset="0"/>
+              <a:cs typeface="微软雅黑" charset="0"/>
+            </a:endParaRPr>
+          </a:p>
+        </p:txBody>
+      </p:sp>
+      <p:sp>
+        <p:nvSpPr>
+          <p:cNvPr id="47" name="文本框 46"/>
+          <p:cNvSpPr txBox="1"/>
+          <p:nvPr>
+            <p:custDataLst>
+              <p:tags r:id="rId43"/>
+            </p:custDataLst>
+          </p:nvPr>
+        </p:nvSpPr>
+        <p:spPr>
+          <a:xfrm>
+            <a:off x="8006080" y="6141720"/>
+            <a:ext cx="865505" cy="305435"/>
+          </a:xfrm>
+          <a:prstGeom prst="rect">
+            <a:avLst/>
+          </a:prstGeom>
+          <a:noFill/>
+        </p:spPr>
+        <p:txBody>
+          <a:bodyPr wrap="square" rtlCol="0">
+            <a:noAutofit/>
+          </a:bodyPr>
+          <a:p>
+            <a:pPr algn="ctr"/>
+            <a:r>
+              <a:rPr lang="en-US" altLang="zh-CN" sz="1200" b="1">
+                <a:latin typeface="微软雅黑" charset="0"/>
+                <a:ea typeface="微软雅黑" charset="0"/>
+                <a:cs typeface="微软雅黑" charset="0"/>
+              </a:rPr>
+              <a:t>a_text2</a:t>
+            </a:r>
+            <a:endParaRPr lang="en-US" altLang="zh-CN" sz="1200" b="1">
+              <a:latin typeface="微软雅黑" charset="0"/>
+              <a:ea typeface="微软雅黑" charset="0"/>
+              <a:cs typeface="微软雅黑" charset="0"/>
+            </a:endParaRPr>
+          </a:p>
+        </p:txBody>
+      </p:sp>
+      <p:sp>
+        <p:nvSpPr>
+          <p:cNvPr id="48" name="文本框 47"/>
+          <p:cNvSpPr txBox="1"/>
+          <p:nvPr>
+            <p:custDataLst>
+              <p:tags r:id="rId44"/>
+            </p:custDataLst>
+          </p:nvPr>
+        </p:nvSpPr>
+        <p:spPr>
+          <a:xfrm>
+            <a:off x="8895080" y="6141720"/>
+            <a:ext cx="768350" cy="305435"/>
+          </a:xfrm>
+          <a:prstGeom prst="rect">
+            <a:avLst/>
+          </a:prstGeom>
+          <a:noFill/>
+        </p:spPr>
+        <p:txBody>
+          <a:bodyPr wrap="square" rtlCol="0">
+            <a:noAutofit/>
+          </a:bodyPr>
+          <a:p>
+            <a:pPr algn="ctr"/>
+            <a:r>
+              <a:rPr lang="en-US" altLang="zh-CN" sz="1200" b="1">
+                <a:latin typeface="微软雅黑" charset="0"/>
+                <a:ea typeface="微软雅黑" charset="0"/>
+                <a:cs typeface="微软雅黑" charset="0"/>
+              </a:rPr>
+              <a:t>atext3</a:t>
+            </a:r>
+            <a:endParaRPr lang="en-US" altLang="zh-CN" sz="1200" b="1">
+              <a:latin typeface="微软雅黑" charset="0"/>
+              <a:ea typeface="微软雅黑" charset="0"/>
+              <a:cs typeface="微软雅黑" charset="0"/>
+            </a:endParaRPr>
+          </a:p>
+        </p:txBody>
+      </p:sp>
+      <p:sp>
+        <p:nvSpPr>
+          <p:cNvPr id="49" name="文本框 48"/>
+          <p:cNvSpPr txBox="1"/>
+          <p:nvPr>
+            <p:custDataLst>
+              <p:tags r:id="rId45"/>
+            </p:custDataLst>
+          </p:nvPr>
+        </p:nvSpPr>
+        <p:spPr>
+          <a:xfrm>
+            <a:off x="7001510" y="5776595"/>
+            <a:ext cx="2604135" cy="537210"/>
+          </a:xfrm>
+          <a:prstGeom prst="rect">
+            <a:avLst/>
+          </a:prstGeom>
+          <a:noFill/>
+        </p:spPr>
+        <p:txBody>
+          <a:bodyPr wrap="square" rtlCol="0">
+            <a:noAutofit/>
+          </a:bodyPr>
+          <a:p>
+            <a:pPr algn="ctr"/>
+            <a:r>
+              <a:rPr lang="zh-CN" altLang="en-US" sz="1200" b="1">
+                <a:latin typeface="微软雅黑" charset="0"/>
+                <a:ea typeface="微软雅黑" charset="0"/>
+                <a:cs typeface="微软雅黑" charset="0"/>
+              </a:rPr>
+              <a:t>二次扰动文本</a:t>
+            </a:r>
+            <a:r>
+              <a:rPr lang="zh-CN" altLang="en-US" sz="1200" b="1">
+                <a:latin typeface="微软雅黑" charset="0"/>
+                <a:ea typeface="微软雅黑" charset="0"/>
+                <a:cs typeface="微软雅黑" charset="0"/>
+              </a:rPr>
+              <a:t>集</a:t>
+            </a:r>
+            <a:endParaRPr lang="zh-CN" altLang="en-US" sz="1200" b="1">
+              <a:latin typeface="微软雅黑" charset="0"/>
+              <a:ea typeface="微软雅黑" charset="0"/>
+              <a:cs typeface="微软雅黑" charset="0"/>
+            </a:endParaRPr>
+          </a:p>
+        </p:txBody>
+      </p:sp>
+      <p:sp>
+        <p:nvSpPr>
+          <p:cNvPr id="50" name="右箭头 49"/>
+          <p:cNvSpPr/>
+          <p:nvPr>
+            <p:custDataLst>
+              <p:tags r:id="rId46"/>
+            </p:custDataLst>
+          </p:nvPr>
+        </p:nvSpPr>
+        <p:spPr>
+          <a:xfrm>
+            <a:off x="5561330" y="6011545"/>
+            <a:ext cx="403860" cy="220980"/>
+          </a:xfrm>
+          <a:prstGeom prst="rightArrow">
+            <a:avLst/>
+          </a:prstGeom>
+        </p:spPr>
+        <p:style>
+          <a:lnRef idx="2">
+            <a:schemeClr val="accent1">
+              <a:lumMod val="75000"/>
+            </a:schemeClr>
+          </a:lnRef>
+          <a:fillRef idx="1">
+            <a:schemeClr val="accent1"/>
+          </a:fillRef>
+          <a:effectRef idx="0">
+            <a:srgbClr val="FFFFFF"/>
+          </a:effectRef>
+          <a:fontRef idx="minor">
+            <a:schemeClr val="lt1"/>
+          </a:fontRef>
+        </p:style>
+        <p:txBody>
+          <a:bodyPr rtlCol="0" anchor="ctr"/>
+          <a:p>
+            <a:pPr algn="ctr"/>
+            <a:endParaRPr lang="zh-CN" altLang="en-US"/>
+          </a:p>
+        </p:txBody>
+      </p:sp>
+      <p:sp>
+        <p:nvSpPr>
+          <p:cNvPr id="51" name="文本框 50"/>
+          <p:cNvSpPr txBox="1"/>
+          <p:nvPr>
+            <p:custDataLst>
+              <p:tags r:id="rId47"/>
+            </p:custDataLst>
+          </p:nvPr>
+        </p:nvSpPr>
+        <p:spPr>
+          <a:xfrm>
+            <a:off x="3925570" y="4760595"/>
+            <a:ext cx="3644265" cy="1005205"/>
+          </a:xfrm>
+          <a:prstGeom prst="rect">
+            <a:avLst/>
+          </a:prstGeom>
+          <a:noFill/>
+        </p:spPr>
+        <p:txBody>
+          <a:bodyPr wrap="square" rtlCol="0">
+            <a:noAutofit/>
+          </a:bodyPr>
+          <a:p>
+            <a:pPr algn="ctr"/>
+            <a:r>
+              <a:rPr lang="zh-CN" altLang="en-US" sz="1200" b="1">
+                <a:latin typeface="微软雅黑" charset="0"/>
+                <a:ea typeface="微软雅黑" charset="0"/>
+                <a:cs typeface="微软雅黑" charset="0"/>
+              </a:rPr>
+              <a:t>第三步</a:t>
+            </a:r>
+            <a:r>
+              <a:rPr lang="en-US" altLang="zh-CN" sz="1200" b="1">
+                <a:latin typeface="微软雅黑" charset="0"/>
+                <a:ea typeface="微软雅黑" charset="0"/>
+                <a:cs typeface="微软雅黑" charset="0"/>
+              </a:rPr>
+              <a:t> </a:t>
+            </a:r>
+            <a:r>
+              <a:rPr lang="zh-CN" altLang="en-US" sz="1200" b="1">
+                <a:latin typeface="微软雅黑" charset="0"/>
+                <a:ea typeface="微软雅黑" charset="0"/>
+                <a:cs typeface="微软雅黑" charset="0"/>
+              </a:rPr>
+              <a:t>根据对抗图像集生成新的对抗文本</a:t>
+            </a:r>
+            <a:br>
+              <a:rPr lang="zh-CN" altLang="en-US" sz="1200" b="1">
+                <a:latin typeface="微软雅黑" charset="0"/>
+                <a:ea typeface="微软雅黑" charset="0"/>
+                <a:cs typeface="微软雅黑" charset="0"/>
+              </a:rPr>
+            </a:br>
+            <a:r>
+              <a:rPr lang="zh-CN" altLang="en-US" sz="1200" b="1">
+                <a:latin typeface="微软雅黑" charset="0"/>
+                <a:ea typeface="微软雅黑" charset="0"/>
+                <a:cs typeface="微软雅黑" charset="0"/>
+              </a:rPr>
+              <a:t>在允许的扰动幅度下最大化扰动图像集和新的扰动文本集的余弦</a:t>
+            </a:r>
+            <a:r>
+              <a:rPr lang="zh-CN" altLang="en-US" sz="1200" b="1">
+                <a:latin typeface="微软雅黑" charset="0"/>
+                <a:ea typeface="微软雅黑" charset="0"/>
+                <a:cs typeface="微软雅黑" charset="0"/>
+              </a:rPr>
+              <a:t>相似度</a:t>
             </a:r>
             <a:endParaRPr lang="zh-CN" altLang="en-US" sz="1200" b="1">
               <a:latin typeface="微软雅黑" charset="0"/>
@@ -10959,6 +11339,704 @@
 </p:sld>
 </file>
 
+<file path=ppt/slides/slide8.xml><?xml version="1.0" encoding="utf-8"?>
+<p:sld xmlns:a="http://schemas.openxmlformats.org/drawingml/2006/main" xmlns:r="http://schemas.openxmlformats.org/officeDocument/2006/relationships" xmlns:p="http://schemas.openxmlformats.org/presentationml/2006/main">
+  <p:cSld>
+    <p:spTree>
+      <p:nvGrpSpPr>
+        <p:cNvPr id="1" name=""/>
+        <p:cNvGrpSpPr/>
+        <p:nvPr/>
+      </p:nvGrpSpPr>
+      <p:grpSpPr/>
+      <p:sp>
+        <p:nvSpPr>
+          <p:cNvPr id="2" name="标题 1"/>
+          <p:cNvSpPr>
+            <a:spLocks noGrp="1"/>
+          </p:cNvSpPr>
+          <p:nvPr>
+            <p:ph type="ctrTitle"/>
+          </p:nvPr>
+        </p:nvSpPr>
+        <p:spPr/>
+        <p:txBody>
+          <a:bodyPr/>
+          <a:p>
+            <a:r>
+              <a:rPr lang="en-US" altLang="zh-CN"/>
+              <a:t>TMM</a:t>
+            </a:r>
+            <a:endParaRPr lang="en-US" altLang="zh-CN"/>
+          </a:p>
+        </p:txBody>
+      </p:sp>
+      <p:sp>
+        <p:nvSpPr>
+          <p:cNvPr id="3" name="副标题 2"/>
+          <p:cNvSpPr>
+            <a:spLocks noGrp="1"/>
+          </p:cNvSpPr>
+          <p:nvPr>
+            <p:ph type="subTitle" idx="1"/>
+          </p:nvPr>
+        </p:nvSpPr>
+        <p:spPr/>
+        <p:txBody>
+          <a:bodyPr/>
+          <a:p>
+            <a:endParaRPr lang="zh-CN" altLang="en-US"/>
+          </a:p>
+        </p:txBody>
+      </p:sp>
+    </p:spTree>
+  </p:cSld>
+  <p:clrMapOvr>
+    <a:masterClrMapping/>
+  </p:clrMapOvr>
+</p:sld>
+</file>
+
+<file path=ppt/slides/slide9.xml><?xml version="1.0" encoding="utf-8"?>
+<p:sld xmlns:a="http://schemas.openxmlformats.org/drawingml/2006/main" xmlns:r="http://schemas.openxmlformats.org/officeDocument/2006/relationships" xmlns:p="http://schemas.openxmlformats.org/presentationml/2006/main">
+  <p:cSld>
+    <p:spTree>
+      <p:nvGrpSpPr>
+        <p:cNvPr id="1" name=""/>
+        <p:cNvGrpSpPr/>
+        <p:nvPr/>
+      </p:nvGrpSpPr>
+      <p:grpSpPr/>
+      <p:pic>
+        <p:nvPicPr>
+          <p:cNvPr id="4" name="图片 3"/>
+          <p:cNvPicPr>
+            <a:picLocks noChangeAspect="1"/>
+          </p:cNvPicPr>
+          <p:nvPr>
+            <p:custDataLst>
+              <p:tags r:id="rId1"/>
+            </p:custDataLst>
+          </p:nvPr>
+        </p:nvPicPr>
+        <p:blipFill>
+          <a:blip r:embed="rId2"/>
+          <a:stretch>
+            <a:fillRect/>
+          </a:stretch>
+        </p:blipFill>
+        <p:spPr>
+          <a:xfrm>
+            <a:off x="1369060" y="2323465"/>
+            <a:ext cx="9342755" cy="3785235"/>
+          </a:xfrm>
+          <a:prstGeom prst="rect">
+            <a:avLst/>
+          </a:prstGeom>
+        </p:spPr>
+      </p:pic>
+      <p:sp>
+        <p:nvSpPr>
+          <p:cNvPr id="26" name="文本框 25"/>
+          <p:cNvSpPr txBox="1"/>
+          <p:nvPr>
+            <p:custDataLst>
+              <p:tags r:id="rId3"/>
+            </p:custDataLst>
+          </p:nvPr>
+        </p:nvSpPr>
+        <p:spPr>
+          <a:xfrm>
+            <a:off x="1369060" y="6040120"/>
+            <a:ext cx="3463290" cy="575310"/>
+          </a:xfrm>
+          <a:prstGeom prst="rect">
+            <a:avLst/>
+          </a:prstGeom>
+          <a:noFill/>
+        </p:spPr>
+        <p:txBody>
+          <a:bodyPr wrap="square" rtlCol="0">
+            <a:noAutofit/>
+          </a:bodyPr>
+          <a:p>
+            <a:pPr algn="ctr"/>
+            <a:r>
+              <a:rPr lang="zh-CN" altLang="en-US" sz="1200" b="1">
+                <a:latin typeface="微软雅黑" charset="0"/>
+                <a:ea typeface="微软雅黑" charset="0"/>
+                <a:cs typeface="微软雅黑" charset="0"/>
+              </a:rPr>
+              <a:t>结合所有头</a:t>
+            </a:r>
+            <a:r>
+              <a:rPr lang="zh-CN" altLang="en-US" sz="1200" b="1">
+                <a:latin typeface="微软雅黑" charset="0"/>
+                <a:ea typeface="微软雅黑" charset="0"/>
+                <a:cs typeface="微软雅黑" charset="0"/>
+              </a:rPr>
+              <a:t>的注意力</a:t>
+            </a:r>
+            <a:br>
+              <a:rPr lang="zh-CN" altLang="en-US" sz="1200" b="1">
+                <a:latin typeface="微软雅黑" charset="0"/>
+                <a:ea typeface="微软雅黑" charset="0"/>
+                <a:cs typeface="微软雅黑" charset="0"/>
+              </a:rPr>
+            </a:br>
+            <a:r>
+              <a:rPr lang="zh-CN" altLang="en-US" sz="1200" b="1">
+                <a:latin typeface="微软雅黑" charset="0"/>
+                <a:ea typeface="微软雅黑" charset="0"/>
+                <a:cs typeface="微软雅黑" charset="0"/>
+              </a:rPr>
+              <a:t>分别得到图像还有文本的注意力</a:t>
+            </a:r>
+            <a:r>
+              <a:rPr lang="zh-CN" altLang="en-US" sz="1200" b="1">
+                <a:latin typeface="微软雅黑" charset="0"/>
+                <a:ea typeface="微软雅黑" charset="0"/>
+                <a:cs typeface="微软雅黑" charset="0"/>
+              </a:rPr>
+              <a:t>得分</a:t>
+            </a:r>
+            <a:endParaRPr lang="zh-CN" altLang="en-US" sz="1200" b="1">
+              <a:latin typeface="微软雅黑" charset="0"/>
+              <a:ea typeface="微软雅黑" charset="0"/>
+              <a:cs typeface="微软雅黑" charset="0"/>
+            </a:endParaRPr>
+          </a:p>
+        </p:txBody>
+      </p:sp>
+      <p:sp>
+        <p:nvSpPr>
+          <p:cNvPr id="5" name="文本框 4"/>
+          <p:cNvSpPr txBox="1"/>
+          <p:nvPr>
+            <p:custDataLst>
+              <p:tags r:id="rId4"/>
+            </p:custDataLst>
+          </p:nvPr>
+        </p:nvSpPr>
+        <p:spPr>
+          <a:xfrm>
+            <a:off x="332105" y="1114425"/>
+            <a:ext cx="4521200" cy="575310"/>
+          </a:xfrm>
+          <a:prstGeom prst="rect">
+            <a:avLst/>
+          </a:prstGeom>
+          <a:noFill/>
+        </p:spPr>
+        <p:txBody>
+          <a:bodyPr wrap="square" rtlCol="0">
+            <a:noAutofit/>
+          </a:bodyPr>
+          <a:p>
+            <a:pPr algn="ctr"/>
+            <a:r>
+              <a:rPr lang="zh-CN" altLang="en-US" sz="1200" b="1">
+                <a:latin typeface="微软雅黑" charset="0"/>
+                <a:ea typeface="微软雅黑" charset="0"/>
+                <a:cs typeface="微软雅黑" charset="0"/>
+              </a:rPr>
+              <a:t>对于文本部分</a:t>
+            </a:r>
+            <a:br>
+              <a:rPr lang="zh-CN" altLang="en-US" sz="1200" b="1">
+                <a:latin typeface="微软雅黑" charset="0"/>
+                <a:ea typeface="微软雅黑" charset="0"/>
+                <a:cs typeface="微软雅黑" charset="0"/>
+              </a:rPr>
+            </a:br>
+            <a:r>
+              <a:rPr lang="zh-CN" altLang="en-US" sz="1200" b="1">
+                <a:latin typeface="微软雅黑" charset="0"/>
+                <a:ea typeface="微软雅黑" charset="0"/>
+                <a:cs typeface="微软雅黑" charset="0"/>
+              </a:rPr>
+              <a:t>提取最高注意力得分的前</a:t>
+            </a:r>
+            <a:r>
+              <a:rPr lang="en-US" altLang="zh-CN" sz="1200" b="1">
+                <a:latin typeface="微软雅黑" charset="0"/>
+                <a:ea typeface="微软雅黑" charset="0"/>
+                <a:cs typeface="微软雅黑" charset="0"/>
+              </a:rPr>
+              <a:t>n</a:t>
+            </a:r>
+            <a:r>
+              <a:rPr lang="zh-CN" altLang="en-US" sz="1200" b="1">
+                <a:latin typeface="微软雅黑" charset="0"/>
+                <a:ea typeface="微软雅黑" charset="0"/>
+                <a:cs typeface="微软雅黑" charset="0"/>
+              </a:rPr>
+              <a:t>个词</a:t>
+            </a:r>
+            <a:br>
+              <a:rPr lang="zh-CN" altLang="en-US" sz="1200" b="1">
+                <a:latin typeface="微软雅黑" charset="0"/>
+                <a:ea typeface="微软雅黑" charset="0"/>
+                <a:cs typeface="微软雅黑" charset="0"/>
+              </a:rPr>
+            </a:br>
+            <a:r>
+              <a:rPr lang="zh-CN" altLang="en-US" sz="1200" b="1">
+                <a:latin typeface="微软雅黑" charset="0"/>
+                <a:ea typeface="微软雅黑" charset="0"/>
+                <a:cs typeface="微软雅黑" charset="0"/>
+              </a:rPr>
+              <a:t>使用使用 BertForMaskedLM 模型生成代替</a:t>
+            </a:r>
+            <a:r>
+              <a:rPr lang="zh-CN" altLang="en-US" sz="1200" b="1">
+                <a:latin typeface="微软雅黑" charset="0"/>
+                <a:ea typeface="微软雅黑" charset="0"/>
+                <a:cs typeface="微软雅黑" charset="0"/>
+              </a:rPr>
+              <a:t>词</a:t>
+            </a:r>
+            <a:endParaRPr lang="zh-CN" altLang="en-US" sz="1200" b="1">
+              <a:latin typeface="微软雅黑" charset="0"/>
+              <a:ea typeface="微软雅黑" charset="0"/>
+              <a:cs typeface="微软雅黑" charset="0"/>
+            </a:endParaRPr>
+          </a:p>
+        </p:txBody>
+      </p:sp>
+      <p:sp>
+        <p:nvSpPr>
+          <p:cNvPr id="6" name="文本框 5"/>
+          <p:cNvSpPr txBox="1"/>
+          <p:nvPr>
+            <p:custDataLst>
+              <p:tags r:id="rId5"/>
+            </p:custDataLst>
+          </p:nvPr>
+        </p:nvSpPr>
+        <p:spPr>
+          <a:xfrm>
+            <a:off x="6301105" y="98425"/>
+            <a:ext cx="4521200" cy="575310"/>
+          </a:xfrm>
+          <a:prstGeom prst="rect">
+            <a:avLst/>
+          </a:prstGeom>
+          <a:noFill/>
+        </p:spPr>
+        <p:txBody>
+          <a:bodyPr wrap="square" rtlCol="0">
+            <a:noAutofit/>
+          </a:bodyPr>
+          <a:p>
+            <a:pPr algn="ctr"/>
+            <a:r>
+              <a:rPr lang="zh-CN" altLang="en-US" sz="1200" b="1">
+                <a:latin typeface="微软雅黑" charset="0"/>
+                <a:ea typeface="微软雅黑" charset="0"/>
+                <a:cs typeface="微软雅黑" charset="0"/>
+              </a:rPr>
+              <a:t>对于图像部分</a:t>
+            </a:r>
+            <a:br>
+              <a:rPr lang="zh-CN" altLang="en-US" sz="1200" b="1">
+                <a:latin typeface="微软雅黑" charset="0"/>
+                <a:ea typeface="微软雅黑" charset="0"/>
+                <a:cs typeface="微软雅黑" charset="0"/>
+              </a:rPr>
+            </a:br>
+            <a:r>
+              <a:rPr lang="zh-CN" altLang="en-US" sz="1200" b="1">
+                <a:latin typeface="微软雅黑" charset="0"/>
+                <a:ea typeface="微软雅黑" charset="0"/>
+                <a:cs typeface="微软雅黑" charset="0"/>
+              </a:rPr>
+              <a:t>对注意力得分高的区域添加更强的扰动</a:t>
+            </a:r>
+            <a:br>
+              <a:rPr lang="zh-CN" altLang="en-US" sz="1200" b="1">
+                <a:latin typeface="微软雅黑" charset="0"/>
+                <a:ea typeface="微软雅黑" charset="0"/>
+                <a:cs typeface="微软雅黑" charset="0"/>
+              </a:rPr>
+            </a:br>
+            <a:r>
+              <a:rPr lang="zh-CN" altLang="en-US" sz="1200" b="1">
+                <a:latin typeface="微软雅黑" charset="0"/>
+                <a:ea typeface="微软雅黑" charset="0"/>
+                <a:cs typeface="微软雅黑" charset="0"/>
+              </a:rPr>
+              <a:t>并引入</a:t>
+            </a:r>
+            <a:r>
+              <a:rPr lang="en-US" altLang="zh-CN" sz="1200" b="1">
+                <a:latin typeface="微软雅黑" charset="0"/>
+                <a:ea typeface="微软雅黑" charset="0"/>
+                <a:cs typeface="微软雅黑" charset="0"/>
+              </a:rPr>
+              <a:t>SSIM</a:t>
+            </a:r>
+            <a:r>
+              <a:rPr lang="zh-CN" altLang="en-US" sz="1200" b="1">
+                <a:latin typeface="微软雅黑" charset="0"/>
+                <a:ea typeface="微软雅黑" charset="0"/>
+                <a:cs typeface="微软雅黑" charset="0"/>
+              </a:rPr>
+              <a:t>损失来最小化结构</a:t>
+            </a:r>
+            <a:r>
+              <a:rPr lang="zh-CN" altLang="en-US" sz="1200" b="1">
+                <a:latin typeface="微软雅黑" charset="0"/>
+                <a:ea typeface="微软雅黑" charset="0"/>
+                <a:cs typeface="微软雅黑" charset="0"/>
+              </a:rPr>
+              <a:t>相似度</a:t>
+            </a:r>
+            <a:endParaRPr lang="zh-CN" altLang="en-US" sz="1200" b="1">
+              <a:latin typeface="微软雅黑" charset="0"/>
+              <a:ea typeface="微软雅黑" charset="0"/>
+              <a:cs typeface="微软雅黑" charset="0"/>
+            </a:endParaRPr>
+          </a:p>
+        </p:txBody>
+      </p:sp>
+      <p:pic>
+        <p:nvPicPr>
+          <p:cNvPr id="7" name="图片 6"/>
+          <p:cNvPicPr>
+            <a:picLocks noChangeAspect="1"/>
+          </p:cNvPicPr>
+          <p:nvPr>
+            <p:custDataLst>
+              <p:tags r:id="rId6"/>
+            </p:custDataLst>
+          </p:nvPr>
+        </p:nvPicPr>
+        <p:blipFill>
+          <a:blip r:embed="rId7"/>
+          <a:stretch>
+            <a:fillRect/>
+          </a:stretch>
+        </p:blipFill>
+        <p:spPr>
+          <a:xfrm>
+            <a:off x="8363585" y="923925"/>
+            <a:ext cx="3505200" cy="584200"/>
+          </a:xfrm>
+          <a:prstGeom prst="rect">
+            <a:avLst/>
+          </a:prstGeom>
+        </p:spPr>
+      </p:pic>
+      <p:pic>
+        <p:nvPicPr>
+          <p:cNvPr id="8" name="图片 7"/>
+          <p:cNvPicPr>
+            <a:picLocks noChangeAspect="1"/>
+          </p:cNvPicPr>
+          <p:nvPr>
+            <p:custDataLst>
+              <p:tags r:id="rId8"/>
+            </p:custDataLst>
+          </p:nvPr>
+        </p:nvPicPr>
+        <p:blipFill>
+          <a:blip r:embed="rId9"/>
+          <a:stretch>
+            <a:fillRect/>
+          </a:stretch>
+        </p:blipFill>
+        <p:spPr>
+          <a:xfrm>
+            <a:off x="9925685" y="1544320"/>
+            <a:ext cx="1943100" cy="279400"/>
+          </a:xfrm>
+          <a:prstGeom prst="rect">
+            <a:avLst/>
+          </a:prstGeom>
+        </p:spPr>
+      </p:pic>
+      <p:pic>
+        <p:nvPicPr>
+          <p:cNvPr id="9" name="图片 8"/>
+          <p:cNvPicPr>
+            <a:picLocks noChangeAspect="1"/>
+          </p:cNvPicPr>
+          <p:nvPr>
+            <p:custDataLst>
+              <p:tags r:id="rId10"/>
+            </p:custDataLst>
+          </p:nvPr>
+        </p:nvPicPr>
+        <p:blipFill>
+          <a:blip r:embed="rId11"/>
+          <a:stretch>
+            <a:fillRect/>
+          </a:stretch>
+        </p:blipFill>
+        <p:spPr>
+          <a:xfrm>
+            <a:off x="8659495" y="1558925"/>
+            <a:ext cx="1117600" cy="228600"/>
+          </a:xfrm>
+          <a:prstGeom prst="rect">
+            <a:avLst/>
+          </a:prstGeom>
+        </p:spPr>
+      </p:pic>
+      <p:sp>
+        <p:nvSpPr>
+          <p:cNvPr id="10" name="文本框 9"/>
+          <p:cNvSpPr txBox="1"/>
+          <p:nvPr>
+            <p:custDataLst>
+              <p:tags r:id="rId12"/>
+            </p:custDataLst>
+          </p:nvPr>
+        </p:nvSpPr>
+        <p:spPr>
+          <a:xfrm>
+            <a:off x="7698105" y="1797685"/>
+            <a:ext cx="4521200" cy="575310"/>
+          </a:xfrm>
+          <a:prstGeom prst="rect">
+            <a:avLst/>
+          </a:prstGeom>
+          <a:noFill/>
+        </p:spPr>
+        <p:txBody>
+          <a:bodyPr wrap="square" rtlCol="0">
+            <a:noAutofit/>
+          </a:bodyPr>
+          <a:p>
+            <a:pPr algn="ctr"/>
+            <a:r>
+              <a:rPr lang="en-US" altLang="zh-CN" sz="1200" b="1">
+                <a:latin typeface="微软雅黑" charset="0"/>
+                <a:ea typeface="微软雅黑" charset="0"/>
+                <a:cs typeface="微软雅黑" charset="0"/>
+              </a:rPr>
+              <a:t>r(0~1)</a:t>
+            </a:r>
+            <a:r>
+              <a:rPr lang="zh-CN" altLang="en-US" sz="1200" b="1">
+                <a:latin typeface="微软雅黑" charset="0"/>
+                <a:ea typeface="微软雅黑" charset="0"/>
+                <a:cs typeface="微软雅黑" charset="0"/>
+              </a:rPr>
+              <a:t>代表扰动的分配权重</a:t>
+            </a:r>
+            <a:br>
+              <a:rPr lang="zh-CN" altLang="en-US" sz="1200" b="1">
+                <a:latin typeface="微软雅黑" charset="0"/>
+                <a:ea typeface="微软雅黑" charset="0"/>
+                <a:cs typeface="微软雅黑" charset="0"/>
+              </a:rPr>
+            </a:br>
+            <a:r>
+              <a:rPr lang="zh-CN" altLang="en-US" sz="1200" b="1">
+                <a:latin typeface="微软雅黑" charset="0"/>
+                <a:ea typeface="微软雅黑" charset="0"/>
+                <a:cs typeface="微软雅黑" charset="0"/>
+              </a:rPr>
+              <a:t>关键区域添加</a:t>
+            </a:r>
+            <a:r>
+              <a:rPr lang="en-US" altLang="zh-CN" sz="1200" b="1">
+                <a:latin typeface="微软雅黑" charset="0"/>
+                <a:ea typeface="微软雅黑" charset="0"/>
+                <a:cs typeface="微软雅黑" charset="0"/>
+              </a:rPr>
+              <a:t>(1-r)*</a:t>
+            </a:r>
+            <a:r>
+              <a:rPr lang="zh-CN" altLang="en-US" sz="1200" b="1">
+                <a:latin typeface="微软雅黑" charset="0"/>
+                <a:ea typeface="微软雅黑" charset="0"/>
+                <a:cs typeface="微软雅黑" charset="0"/>
+              </a:rPr>
+              <a:t>关键区域像素所占</a:t>
+            </a:r>
+            <a:r>
+              <a:rPr lang="zh-CN" altLang="en-US" sz="1200" b="1">
+                <a:latin typeface="微软雅黑" charset="0"/>
+                <a:ea typeface="微软雅黑" charset="0"/>
+                <a:cs typeface="微软雅黑" charset="0"/>
+              </a:rPr>
+              <a:t>比例的扰动</a:t>
+            </a:r>
+            <a:br>
+              <a:rPr lang="zh-CN" altLang="en-US" sz="1200" b="1">
+                <a:latin typeface="微软雅黑" charset="0"/>
+                <a:ea typeface="微软雅黑" charset="0"/>
+                <a:cs typeface="微软雅黑" charset="0"/>
+              </a:rPr>
+            </a:br>
+            <a:r>
+              <a:rPr lang="zh-CN" altLang="en-US" sz="1200" b="1">
+                <a:latin typeface="微软雅黑" charset="0"/>
+                <a:ea typeface="微软雅黑" charset="0"/>
+                <a:cs typeface="微软雅黑" charset="0"/>
+              </a:rPr>
+              <a:t>非关键区域添加</a:t>
+            </a:r>
+            <a:r>
+              <a:rPr lang="en-US" altLang="zh-CN" sz="1200" b="1">
+                <a:latin typeface="微软雅黑" charset="0"/>
+                <a:ea typeface="微软雅黑" charset="0"/>
+                <a:cs typeface="微软雅黑" charset="0"/>
+              </a:rPr>
+              <a:t>r</a:t>
+            </a:r>
+            <a:r>
+              <a:rPr lang="zh-CN" altLang="en-US" sz="1200" b="1">
+                <a:latin typeface="微软雅黑" charset="0"/>
+                <a:ea typeface="微软雅黑" charset="0"/>
+                <a:cs typeface="微软雅黑" charset="0"/>
+              </a:rPr>
+              <a:t>的</a:t>
+            </a:r>
+            <a:r>
+              <a:rPr lang="zh-CN" altLang="en-US" sz="1200" b="1">
+                <a:latin typeface="微软雅黑" charset="0"/>
+                <a:ea typeface="微软雅黑" charset="0"/>
+                <a:cs typeface="微软雅黑" charset="0"/>
+              </a:rPr>
+              <a:t>扰动</a:t>
+            </a:r>
+            <a:endParaRPr lang="zh-CN" altLang="en-US" sz="1200" b="1">
+              <a:latin typeface="微软雅黑" charset="0"/>
+              <a:ea typeface="微软雅黑" charset="0"/>
+              <a:cs typeface="微软雅黑" charset="0"/>
+            </a:endParaRPr>
+          </a:p>
+          <a:p>
+            <a:pPr algn="ctr"/>
+            <a:endParaRPr lang="zh-CN" altLang="en-US" sz="1200" b="1">
+              <a:latin typeface="微软雅黑" charset="0"/>
+              <a:ea typeface="微软雅黑" charset="0"/>
+              <a:cs typeface="微软雅黑" charset="0"/>
+            </a:endParaRPr>
+          </a:p>
+        </p:txBody>
+      </p:sp>
+      <p:pic>
+        <p:nvPicPr>
+          <p:cNvPr id="11" name="图片 10"/>
+          <p:cNvPicPr>
+            <a:picLocks noChangeAspect="1"/>
+          </p:cNvPicPr>
+          <p:nvPr>
+            <p:custDataLst>
+              <p:tags r:id="rId13"/>
+            </p:custDataLst>
+          </p:nvPr>
+        </p:nvPicPr>
+        <p:blipFill>
+          <a:blip r:embed="rId14"/>
+          <a:stretch>
+            <a:fillRect/>
+          </a:stretch>
+        </p:blipFill>
+        <p:spPr>
+          <a:xfrm>
+            <a:off x="4688205" y="960755"/>
+            <a:ext cx="3822700" cy="749300"/>
+          </a:xfrm>
+          <a:prstGeom prst="rect">
+            <a:avLst/>
+          </a:prstGeom>
+        </p:spPr>
+      </p:pic>
+      <p:sp>
+        <p:nvSpPr>
+          <p:cNvPr id="12" name="文本框 11"/>
+          <p:cNvSpPr txBox="1"/>
+          <p:nvPr>
+            <p:custDataLst>
+              <p:tags r:id="rId15"/>
+            </p:custDataLst>
+          </p:nvPr>
+        </p:nvSpPr>
+        <p:spPr>
+          <a:xfrm>
+            <a:off x="4396105" y="1797685"/>
+            <a:ext cx="4521200" cy="575310"/>
+          </a:xfrm>
+          <a:prstGeom prst="rect">
+            <a:avLst/>
+          </a:prstGeom>
+          <a:noFill/>
+        </p:spPr>
+        <p:txBody>
+          <a:bodyPr wrap="square" rtlCol="0">
+            <a:noAutofit/>
+          </a:bodyPr>
+          <a:p>
+            <a:pPr algn="ctr"/>
+            <a:r>
+              <a:rPr lang="zh-CN" altLang="en-US" sz="1200" b="1">
+                <a:latin typeface="微软雅黑" charset="0"/>
+                <a:ea typeface="微软雅黑" charset="0"/>
+                <a:cs typeface="微软雅黑" charset="0"/>
+              </a:rPr>
+              <a:t>最大化</a:t>
+            </a:r>
+            <a:r>
+              <a:rPr lang="en-US" altLang="zh-CN" sz="1200" b="1">
+                <a:latin typeface="微软雅黑" charset="0"/>
+                <a:ea typeface="微软雅黑" charset="0"/>
+                <a:cs typeface="微软雅黑" charset="0"/>
+              </a:rPr>
+              <a:t>SSIM</a:t>
+            </a:r>
+            <a:r>
+              <a:rPr lang="zh-CN" altLang="en-US" sz="1200" b="1">
+                <a:latin typeface="微软雅黑" charset="0"/>
+                <a:ea typeface="微软雅黑" charset="0"/>
+                <a:cs typeface="微软雅黑" charset="0"/>
+              </a:rPr>
+              <a:t>损失</a:t>
+            </a:r>
+            <a:br>
+              <a:rPr lang="zh-CN" altLang="en-US" sz="1200" b="1">
+                <a:latin typeface="微软雅黑" charset="0"/>
+                <a:ea typeface="微软雅黑" charset="0"/>
+                <a:cs typeface="微软雅黑" charset="0"/>
+              </a:rPr>
+            </a:br>
+            <a:r>
+              <a:rPr lang="zh-CN" altLang="en-US" sz="1200" b="1">
+                <a:latin typeface="微软雅黑" charset="0"/>
+                <a:ea typeface="微软雅黑" charset="0"/>
+                <a:cs typeface="微软雅黑" charset="0"/>
+              </a:rPr>
+              <a:t>来最小化结构</a:t>
+            </a:r>
+            <a:r>
+              <a:rPr lang="zh-CN" altLang="en-US" sz="1200" b="1">
+                <a:latin typeface="微软雅黑" charset="0"/>
+                <a:ea typeface="微软雅黑" charset="0"/>
+                <a:cs typeface="微软雅黑" charset="0"/>
+              </a:rPr>
+              <a:t>相似度</a:t>
+            </a:r>
+            <a:endParaRPr lang="zh-CN" altLang="en-US" sz="1200" b="1">
+              <a:latin typeface="微软雅黑" charset="0"/>
+              <a:ea typeface="微软雅黑" charset="0"/>
+              <a:cs typeface="微软雅黑" charset="0"/>
+            </a:endParaRPr>
+          </a:p>
+        </p:txBody>
+      </p:sp>
+    </p:spTree>
+  </p:cSld>
+  <p:clrMapOvr>
+    <a:masterClrMapping/>
+  </p:clrMapOvr>
+</p:sld>
+</file>
+
 <file path=ppt/tags/tag1.xml><?xml version="1.0" encoding="utf-8"?>
 <p:tagLst xmlns:p="http://schemas.openxmlformats.org/presentationml/2006/main">
   <p:tag name="KSO_WM_BEAUTIFY_FLAG" val=""/>
@@ -11073,13 +12151,121 @@
 </p:tagLst>
 </file>
 
+<file path=ppt/tags/tag116.xml><?xml version="1.0" encoding="utf-8"?>
+<p:tagLst xmlns:p="http://schemas.openxmlformats.org/presentationml/2006/main">
+  <p:tag name="KSO_WM_BEAUTIFY_FLAG" val=""/>
+</p:tagLst>
+</file>
+
+<file path=ppt/tags/tag117.xml><?xml version="1.0" encoding="utf-8"?>
+<p:tagLst xmlns:p="http://schemas.openxmlformats.org/presentationml/2006/main">
+  <p:tag name="KSO_WM_BEAUTIFY_FLAG" val=""/>
+</p:tagLst>
+</file>
+
+<file path=ppt/tags/tag118.xml><?xml version="1.0" encoding="utf-8"?>
+<p:tagLst xmlns:p="http://schemas.openxmlformats.org/presentationml/2006/main">
+  <p:tag name="KSO_WM_BEAUTIFY_FLAG" val=""/>
+</p:tagLst>
+</file>
+
+<file path=ppt/tags/tag119.xml><?xml version="1.0" encoding="utf-8"?>
+<p:tagLst xmlns:p="http://schemas.openxmlformats.org/presentationml/2006/main">
+  <p:tag name="KSO_WM_BEAUTIFY_FLAG" val=""/>
+</p:tagLst>
+</file>
+
 <file path=ppt/tags/tag12.xml><?xml version="1.0" encoding="utf-8"?>
 <p:tagLst xmlns:p="http://schemas.openxmlformats.org/presentationml/2006/main">
   <p:tag name="KSO_WM_BEAUTIFY_FLAG" val=""/>
 </p:tagLst>
 </file>
 
+<file path=ppt/tags/tag120.xml><?xml version="1.0" encoding="utf-8"?>
+<p:tagLst xmlns:p="http://schemas.openxmlformats.org/presentationml/2006/main">
+  <p:tag name="KSO_WM_BEAUTIFY_FLAG" val=""/>
+</p:tagLst>
+</file>
+
+<file path=ppt/tags/tag121.xml><?xml version="1.0" encoding="utf-8"?>
+<p:tagLst xmlns:p="http://schemas.openxmlformats.org/presentationml/2006/main">
+  <p:tag name="KSO_WM_BEAUTIFY_FLAG" val=""/>
+</p:tagLst>
+</file>
+
+<file path=ppt/tags/tag122.xml><?xml version="1.0" encoding="utf-8"?>
+<p:tagLst xmlns:p="http://schemas.openxmlformats.org/presentationml/2006/main">
+  <p:tag name="KSO_WM_BEAUTIFY_FLAG" val=""/>
+</p:tagLst>
+</file>
+
+<file path=ppt/tags/tag123.xml><?xml version="1.0" encoding="utf-8"?>
+<p:tagLst xmlns:p="http://schemas.openxmlformats.org/presentationml/2006/main">
+  <p:tag name="KSO_WM_BEAUTIFY_FLAG" val=""/>
+</p:tagLst>
+</file>
+
+<file path=ppt/tags/tag124.xml><?xml version="1.0" encoding="utf-8"?>
+<p:tagLst xmlns:p="http://schemas.openxmlformats.org/presentationml/2006/main">
+  <p:tag name="KSO_WM_BEAUTIFY_FLAG" val=""/>
+</p:tagLst>
+</file>
+
+<file path=ppt/tags/tag125.xml><?xml version="1.0" encoding="utf-8"?>
+<p:tagLst xmlns:p="http://schemas.openxmlformats.org/presentationml/2006/main">
+  <p:tag name="KSO_WM_BEAUTIFY_FLAG" val=""/>
+</p:tagLst>
+</file>
+
+<file path=ppt/tags/tag126.xml><?xml version="1.0" encoding="utf-8"?>
+<p:tagLst xmlns:p="http://schemas.openxmlformats.org/presentationml/2006/main">
+  <p:tag name="KSO_WM_BEAUTIFY_FLAG" val=""/>
+</p:tagLst>
+</file>
+
+<file path=ppt/tags/tag127.xml><?xml version="1.0" encoding="utf-8"?>
+<p:tagLst xmlns:p="http://schemas.openxmlformats.org/presentationml/2006/main">
+  <p:tag name="KSO_WM_BEAUTIFY_FLAG" val=""/>
+</p:tagLst>
+</file>
+
+<file path=ppt/tags/tag128.xml><?xml version="1.0" encoding="utf-8"?>
+<p:tagLst xmlns:p="http://schemas.openxmlformats.org/presentationml/2006/main">
+  <p:tag name="KSO_WM_BEAUTIFY_FLAG" val=""/>
+</p:tagLst>
+</file>
+
+<file path=ppt/tags/tag129.xml><?xml version="1.0" encoding="utf-8"?>
+<p:tagLst xmlns:p="http://schemas.openxmlformats.org/presentationml/2006/main">
+  <p:tag name="KSO_WM_BEAUTIFY_FLAG" val=""/>
+</p:tagLst>
+</file>
+
 <file path=ppt/tags/tag13.xml><?xml version="1.0" encoding="utf-8"?>
+<p:tagLst xmlns:p="http://schemas.openxmlformats.org/presentationml/2006/main">
+  <p:tag name="KSO_WM_BEAUTIFY_FLAG" val=""/>
+</p:tagLst>
+</file>
+
+<file path=ppt/tags/tag130.xml><?xml version="1.0" encoding="utf-8"?>
+<p:tagLst xmlns:p="http://schemas.openxmlformats.org/presentationml/2006/main">
+  <p:tag name="KSO_WM_BEAUTIFY_FLAG" val=""/>
+</p:tagLst>
+</file>
+
+<file path=ppt/tags/tag131.xml><?xml version="1.0" encoding="utf-8"?>
+<p:tagLst xmlns:p="http://schemas.openxmlformats.org/presentationml/2006/main">
+  <p:tag name="KSO_WM_BEAUTIFY_FLAG" val=""/>
+</p:tagLst>
+</file>
+
+<file path=ppt/tags/tag132.xml><?xml version="1.0" encoding="utf-8"?>
+<p:tagLst xmlns:p="http://schemas.openxmlformats.org/presentationml/2006/main">
+  <p:tag name="KSO_WM_BEAUTIFY_FLAG" val=""/>
+</p:tagLst>
+</file>
+
+<file path=ppt/tags/tag133.xml><?xml version="1.0" encoding="utf-8"?>
 <p:tagLst xmlns:p="http://schemas.openxmlformats.org/presentationml/2006/main">
   <p:tag name="KSO_WM_BEAUTIFY_FLAG" val=""/>
 </p:tagLst>

</xml_diff>

<commit_message>
Prompt Stealing Attacks Against Text-to-Image Generation Models
</commit_message>
<xml_diff>
--- a/Attack/Adversarial_Attack/VLP/论文作图.pptx
+++ b/Attack/Adversarial_Attack/VLP/论文作图.pptx
@@ -11427,7 +11427,7 @@
         </p:blipFill>
         <p:spPr>
           <a:xfrm>
-            <a:off x="1369060" y="2323465"/>
+            <a:off x="353060" y="2069465"/>
             <a:ext cx="9342755" cy="3785235"/>
           </a:xfrm>
           <a:prstGeom prst="rect">
@@ -11447,7 +11447,7 @@
         </p:nvSpPr>
         <p:spPr>
           <a:xfrm>
-            <a:off x="1369060" y="6040120"/>
+            <a:off x="-154940" y="6040120"/>
             <a:ext cx="3463290" cy="575310"/>
           </a:xfrm>
           <a:prstGeom prst="rect">
@@ -11520,7 +11520,7 @@
         </p:nvSpPr>
         <p:spPr>
           <a:xfrm>
-            <a:off x="332105" y="1114425"/>
+            <a:off x="-683895" y="1368425"/>
             <a:ext cx="4521200" cy="575310"/>
           </a:xfrm>
           <a:prstGeom prst="rect">
@@ -11616,7 +11616,7 @@
         </p:nvSpPr>
         <p:spPr>
           <a:xfrm>
-            <a:off x="6301105" y="98425"/>
+            <a:off x="5285105" y="98425"/>
             <a:ext cx="4521200" cy="575310"/>
           </a:xfrm>
           <a:prstGeom prst="rect">
@@ -11720,7 +11720,7 @@
         </p:blipFill>
         <p:spPr>
           <a:xfrm>
-            <a:off x="8363585" y="923925"/>
+            <a:off x="7347585" y="669925"/>
             <a:ext cx="3505200" cy="584200"/>
           </a:xfrm>
           <a:prstGeom prst="rect">
@@ -11748,7 +11748,7 @@
         </p:blipFill>
         <p:spPr>
           <a:xfrm>
-            <a:off x="9925685" y="1544320"/>
+            <a:off x="8909685" y="1290320"/>
             <a:ext cx="1943100" cy="279400"/>
           </a:xfrm>
           <a:prstGeom prst="rect">
@@ -11776,7 +11776,7 @@
         </p:blipFill>
         <p:spPr>
           <a:xfrm>
-            <a:off x="8659495" y="1558925"/>
+            <a:off x="7643495" y="1304925"/>
             <a:ext cx="1117600" cy="228600"/>
           </a:xfrm>
           <a:prstGeom prst="rect">
@@ -11796,7 +11796,7 @@
         </p:nvSpPr>
         <p:spPr>
           <a:xfrm>
-            <a:off x="7698105" y="1797685"/>
+            <a:off x="6682105" y="1543685"/>
             <a:ext cx="4521200" cy="575310"/>
           </a:xfrm>
           <a:prstGeom prst="rect">
@@ -11940,7 +11940,7 @@
         </p:blipFill>
         <p:spPr>
           <a:xfrm>
-            <a:off x="4688205" y="960755"/>
+            <a:off x="3672205" y="706755"/>
             <a:ext cx="3822700" cy="749300"/>
           </a:xfrm>
           <a:prstGeom prst="rect">
@@ -11960,7 +11960,7 @@
         </p:nvSpPr>
         <p:spPr>
           <a:xfrm>
-            <a:off x="4396105" y="1797685"/>
+            <a:off x="3380105" y="1543685"/>
             <a:ext cx="4521200" cy="575310"/>
           </a:xfrm>
           <a:prstGeom prst="rect">
@@ -12029,6 +12029,741 @@
           </a:p>
         </p:txBody>
       </p:sp>
+      <p:pic>
+        <p:nvPicPr>
+          <p:cNvPr id="13" name="图片 12"/>
+          <p:cNvPicPr>
+            <a:picLocks noChangeAspect="1"/>
+          </p:cNvPicPr>
+          <p:nvPr>
+            <p:custDataLst>
+              <p:tags r:id="rId16"/>
+            </p:custDataLst>
+          </p:nvPr>
+        </p:nvPicPr>
+        <p:blipFill>
+          <a:blip r:embed="rId17"/>
+          <a:stretch>
+            <a:fillRect/>
+          </a:stretch>
+        </p:blipFill>
+        <p:spPr>
+          <a:xfrm>
+            <a:off x="3329305" y="5704840"/>
+            <a:ext cx="2578100" cy="1054100"/>
+          </a:xfrm>
+          <a:prstGeom prst="rect">
+            <a:avLst/>
+          </a:prstGeom>
+        </p:spPr>
+      </p:pic>
+      <p:pic>
+        <p:nvPicPr>
+          <p:cNvPr id="14" name="图片 13"/>
+          <p:cNvPicPr>
+            <a:picLocks noChangeAspect="1"/>
+          </p:cNvPicPr>
+          <p:nvPr>
+            <p:custDataLst>
+              <p:tags r:id="rId18"/>
+            </p:custDataLst>
+          </p:nvPr>
+        </p:nvPicPr>
+        <p:blipFill>
+          <a:blip r:embed="rId19"/>
+          <a:stretch>
+            <a:fillRect/>
+          </a:stretch>
+        </p:blipFill>
+        <p:spPr>
+          <a:xfrm>
+            <a:off x="5661660" y="5704840"/>
+            <a:ext cx="2451100" cy="520700"/>
+          </a:xfrm>
+          <a:prstGeom prst="rect">
+            <a:avLst/>
+          </a:prstGeom>
+        </p:spPr>
+      </p:pic>
+      <p:pic>
+        <p:nvPicPr>
+          <p:cNvPr id="15" name="图片 14"/>
+          <p:cNvPicPr>
+            <a:picLocks noChangeAspect="1"/>
+          </p:cNvPicPr>
+          <p:nvPr>
+            <p:custDataLst>
+              <p:tags r:id="rId20"/>
+            </p:custDataLst>
+          </p:nvPr>
+        </p:nvPicPr>
+        <p:blipFill>
+          <a:blip r:embed="rId21"/>
+          <a:stretch>
+            <a:fillRect/>
+          </a:stretch>
+        </p:blipFill>
+        <p:spPr>
+          <a:xfrm>
+            <a:off x="5798820" y="6285230"/>
+            <a:ext cx="1930400" cy="330200"/>
+          </a:xfrm>
+          <a:prstGeom prst="rect">
+            <a:avLst/>
+          </a:prstGeom>
+        </p:spPr>
+      </p:pic>
+      <p:sp>
+        <p:nvSpPr>
+          <p:cNvPr id="16" name="文本框 15"/>
+          <p:cNvSpPr txBox="1"/>
+          <p:nvPr>
+            <p:custDataLst>
+              <p:tags r:id="rId22"/>
+            </p:custDataLst>
+          </p:nvPr>
+        </p:nvSpPr>
+        <p:spPr>
+          <a:xfrm>
+            <a:off x="7719060" y="6040120"/>
+            <a:ext cx="3463290" cy="575310"/>
+          </a:xfrm>
+          <a:prstGeom prst="rect">
+            <a:avLst/>
+          </a:prstGeom>
+          <a:noFill/>
+        </p:spPr>
+        <p:txBody>
+          <a:bodyPr wrap="square" rtlCol="0">
+            <a:noAutofit/>
+          </a:bodyPr>
+          <a:p>
+            <a:pPr algn="ctr"/>
+            <a:r>
+              <a:rPr lang="zh-CN" altLang="en-US" sz="1200" b="1">
+                <a:latin typeface="微软雅黑" charset="0"/>
+                <a:ea typeface="微软雅黑" charset="0"/>
+                <a:cs typeface="微软雅黑" charset="0"/>
+              </a:rPr>
+              <a:t>让扰动后的图像、文本、图像</a:t>
+            </a:r>
+            <a:r>
+              <a:rPr lang="en-US" altLang="zh-CN" sz="1200" b="1">
+                <a:latin typeface="微软雅黑" charset="0"/>
+                <a:ea typeface="微软雅黑" charset="0"/>
+                <a:cs typeface="微软雅黑" charset="0"/>
+              </a:rPr>
+              <a:t>-</a:t>
+            </a:r>
+            <a:r>
+              <a:rPr lang="zh-CN" altLang="en-US" sz="1200" b="1">
+                <a:latin typeface="微软雅黑" charset="0"/>
+                <a:ea typeface="微软雅黑" charset="0"/>
+                <a:cs typeface="微软雅黑" charset="0"/>
+              </a:rPr>
+              <a:t>文本和</a:t>
+            </a:r>
+            <a:endParaRPr lang="zh-CN" altLang="en-US" sz="1200" b="1">
+              <a:latin typeface="微软雅黑" charset="0"/>
+              <a:ea typeface="微软雅黑" charset="0"/>
+              <a:cs typeface="微软雅黑" charset="0"/>
+            </a:endParaRPr>
+          </a:p>
+          <a:p>
+            <a:pPr algn="ctr"/>
+            <a:r>
+              <a:rPr lang="zh-CN" altLang="en-US" sz="1200" b="1">
+                <a:latin typeface="微软雅黑" charset="0"/>
+                <a:ea typeface="微软雅黑" charset="0"/>
+                <a:cs typeface="微软雅黑" charset="0"/>
+              </a:rPr>
+              <a:t>初始的图像</a:t>
+            </a:r>
+            <a:r>
+              <a:rPr lang="en-US" altLang="zh-CN" sz="1200" b="1">
+                <a:latin typeface="微软雅黑" charset="0"/>
+                <a:ea typeface="微软雅黑" charset="0"/>
+                <a:cs typeface="微软雅黑" charset="0"/>
+              </a:rPr>
+              <a:t>-</a:t>
+            </a:r>
+            <a:r>
+              <a:rPr lang="zh-CN" altLang="en-US" sz="1200" b="1">
+                <a:latin typeface="微软雅黑" charset="0"/>
+                <a:ea typeface="微软雅黑" charset="0"/>
+                <a:cs typeface="微软雅黑" charset="0"/>
+              </a:rPr>
+              <a:t>文本尽可能</a:t>
+            </a:r>
+            <a:r>
+              <a:rPr lang="zh-CN" altLang="en-US" sz="1200" b="1">
+                <a:latin typeface="微软雅黑" charset="0"/>
+                <a:ea typeface="微软雅黑" charset="0"/>
+                <a:cs typeface="微软雅黑" charset="0"/>
+              </a:rPr>
+              <a:t>正交</a:t>
+            </a:r>
+            <a:endParaRPr lang="zh-CN" altLang="en-US" sz="1200" b="1">
+              <a:latin typeface="微软雅黑" charset="0"/>
+              <a:ea typeface="微软雅黑" charset="0"/>
+              <a:cs typeface="微软雅黑" charset="0"/>
+            </a:endParaRPr>
+          </a:p>
+        </p:txBody>
+      </p:sp>
+      <p:pic>
+        <p:nvPicPr>
+          <p:cNvPr id="17" name="图片 16"/>
+          <p:cNvPicPr>
+            <a:picLocks noChangeAspect="1"/>
+          </p:cNvPicPr>
+          <p:nvPr>
+            <p:custDataLst>
+              <p:tags r:id="rId23"/>
+            </p:custDataLst>
+          </p:nvPr>
+        </p:nvPicPr>
+        <p:blipFill>
+          <a:blip r:embed="rId24"/>
+          <a:stretch>
+            <a:fillRect/>
+          </a:stretch>
+        </p:blipFill>
+        <p:spPr>
+          <a:xfrm>
+            <a:off x="0" y="98425"/>
+            <a:ext cx="4025900" cy="393700"/>
+          </a:xfrm>
+          <a:prstGeom prst="rect">
+            <a:avLst/>
+          </a:prstGeom>
+        </p:spPr>
+      </p:pic>
+      <p:sp>
+        <p:nvSpPr>
+          <p:cNvPr id="19" name="文本框 18"/>
+          <p:cNvSpPr txBox="1"/>
+          <p:nvPr>
+            <p:custDataLst>
+              <p:tags r:id="rId25"/>
+            </p:custDataLst>
+          </p:nvPr>
+        </p:nvSpPr>
+        <p:spPr>
+          <a:xfrm>
+            <a:off x="-302895" y="527685"/>
+            <a:ext cx="4521200" cy="575310"/>
+          </a:xfrm>
+          <a:prstGeom prst="rect">
+            <a:avLst/>
+          </a:prstGeom>
+          <a:noFill/>
+        </p:spPr>
+        <p:txBody>
+          <a:bodyPr wrap="square" rtlCol="0">
+            <a:noAutofit/>
+          </a:bodyPr>
+          <a:p>
+            <a:pPr algn="ctr"/>
+            <a:r>
+              <a:rPr lang="zh-CN" altLang="en-US" sz="1200" b="1">
+                <a:latin typeface="微软雅黑" charset="0"/>
+                <a:ea typeface="微软雅黑" charset="0"/>
+                <a:cs typeface="微软雅黑" charset="0"/>
+              </a:rPr>
+              <a:t>总损失</a:t>
+            </a:r>
+            <a:r>
+              <a:rPr lang="en-US" altLang="zh-CN" sz="1200" b="1">
+                <a:latin typeface="微软雅黑" charset="0"/>
+                <a:ea typeface="微软雅黑" charset="0"/>
+                <a:cs typeface="微软雅黑" charset="0"/>
+              </a:rPr>
+              <a:t>=OGFH</a:t>
+            </a:r>
+            <a:r>
+              <a:rPr lang="zh-CN" altLang="en-US" sz="1200" b="1">
+                <a:latin typeface="微软雅黑" charset="0"/>
+                <a:ea typeface="微软雅黑" charset="0"/>
+                <a:cs typeface="微软雅黑" charset="0"/>
+              </a:rPr>
+              <a:t>损失</a:t>
+            </a:r>
+            <a:r>
+              <a:rPr lang="en-US" altLang="zh-CN" sz="1200" b="1">
+                <a:latin typeface="微软雅黑" charset="0"/>
+                <a:ea typeface="微软雅黑" charset="0"/>
+                <a:cs typeface="微软雅黑" charset="0"/>
+              </a:rPr>
+              <a:t>+10*ADFP</a:t>
+            </a:r>
+            <a:r>
+              <a:rPr lang="zh-CN" altLang="en-US" sz="1200" b="1">
+                <a:latin typeface="微软雅黑" charset="0"/>
+                <a:ea typeface="微软雅黑" charset="0"/>
+                <a:cs typeface="微软雅黑" charset="0"/>
+              </a:rPr>
+              <a:t>损失</a:t>
+            </a:r>
+            <a:endParaRPr lang="zh-CN" altLang="en-US" sz="1200" b="1">
+              <a:latin typeface="微软雅黑" charset="0"/>
+              <a:ea typeface="微软雅黑" charset="0"/>
+              <a:cs typeface="微软雅黑" charset="0"/>
+            </a:endParaRPr>
+          </a:p>
+        </p:txBody>
+      </p:sp>
+      <p:sp>
+        <p:nvSpPr>
+          <p:cNvPr id="22" name="矩形: 圆角 36"/>
+          <p:cNvSpPr/>
+          <p:nvPr>
+            <p:custDataLst>
+              <p:tags r:id="rId26"/>
+            </p:custDataLst>
+          </p:nvPr>
+        </p:nvSpPr>
+        <p:spPr>
+          <a:xfrm rot="10800000" flipV="1">
+            <a:off x="-23495" y="0"/>
+            <a:ext cx="4025900" cy="879475"/>
+          </a:xfrm>
+          <a:prstGeom prst="roundRect">
+            <a:avLst>
+              <a:gd name="adj" fmla="val 10039"/>
+            </a:avLst>
+          </a:prstGeom>
+          <a:noFill/>
+          <a:ln w="38100">
+            <a:solidFill>
+              <a:schemeClr val="tx1"/>
+            </a:solidFill>
+            <a:prstDash val="lgDash"/>
+          </a:ln>
+        </p:spPr>
+        <p:style>
+          <a:lnRef idx="2">
+            <a:schemeClr val="accent1">
+              <a:shade val="15000"/>
+            </a:schemeClr>
+          </a:lnRef>
+          <a:fillRef idx="1">
+            <a:schemeClr val="accent1"/>
+          </a:fillRef>
+          <a:effectRef idx="0">
+            <a:schemeClr val="accent1"/>
+          </a:effectRef>
+          <a:fontRef idx="minor">
+            <a:schemeClr val="lt1"/>
+          </a:fontRef>
+        </p:style>
+        <p:txBody>
+          <a:bodyPr rtlCol="0" anchor="ctr"/>
+          <a:p>
+            <a:pPr algn="ctr"/>
+            <a:endParaRPr lang="zh-CN" altLang="en-US"/>
+          </a:p>
+        </p:txBody>
+      </p:sp>
+      <p:sp>
+        <p:nvSpPr>
+          <p:cNvPr id="20" name="矩形: 圆角 36"/>
+          <p:cNvSpPr/>
+          <p:nvPr>
+            <p:custDataLst>
+              <p:tags r:id="rId27"/>
+            </p:custDataLst>
+          </p:nvPr>
+        </p:nvSpPr>
+        <p:spPr>
+          <a:xfrm rot="10800000" flipV="1">
+            <a:off x="3672840" y="127000"/>
+            <a:ext cx="7530465" cy="2083435"/>
+          </a:xfrm>
+          <a:prstGeom prst="roundRect">
+            <a:avLst>
+              <a:gd name="adj" fmla="val 10039"/>
+            </a:avLst>
+          </a:prstGeom>
+          <a:noFill/>
+          <a:ln w="38100">
+            <a:solidFill>
+              <a:schemeClr val="tx1"/>
+            </a:solidFill>
+            <a:prstDash val="lgDash"/>
+          </a:ln>
+        </p:spPr>
+        <p:style>
+          <a:lnRef idx="2">
+            <a:schemeClr val="accent1">
+              <a:shade val="15000"/>
+            </a:schemeClr>
+          </a:lnRef>
+          <a:fillRef idx="1">
+            <a:schemeClr val="accent1"/>
+          </a:fillRef>
+          <a:effectRef idx="0">
+            <a:schemeClr val="accent1"/>
+          </a:effectRef>
+          <a:fontRef idx="minor">
+            <a:schemeClr val="lt1"/>
+          </a:fontRef>
+        </p:style>
+        <p:txBody>
+          <a:bodyPr rtlCol="0" anchor="ctr"/>
+          <a:p>
+            <a:pPr algn="ctr"/>
+            <a:endParaRPr lang="zh-CN" altLang="en-US"/>
+          </a:p>
+        </p:txBody>
+      </p:sp>
+      <p:sp>
+        <p:nvSpPr>
+          <p:cNvPr id="21" name="矩形: 圆角 36"/>
+          <p:cNvSpPr/>
+          <p:nvPr>
+            <p:custDataLst>
+              <p:tags r:id="rId28"/>
+            </p:custDataLst>
+          </p:nvPr>
+        </p:nvSpPr>
+        <p:spPr>
+          <a:xfrm rot="10800000" flipV="1">
+            <a:off x="-10160" y="1270000"/>
+            <a:ext cx="3203575" cy="749300"/>
+          </a:xfrm>
+          <a:prstGeom prst="roundRect">
+            <a:avLst>
+              <a:gd name="adj" fmla="val 10039"/>
+            </a:avLst>
+          </a:prstGeom>
+          <a:noFill/>
+          <a:ln w="38100">
+            <a:solidFill>
+              <a:schemeClr val="tx1"/>
+            </a:solidFill>
+            <a:prstDash val="lgDash"/>
+          </a:ln>
+        </p:spPr>
+        <p:style>
+          <a:lnRef idx="2">
+            <a:schemeClr val="accent1">
+              <a:shade val="15000"/>
+            </a:schemeClr>
+          </a:lnRef>
+          <a:fillRef idx="1">
+            <a:schemeClr val="accent1"/>
+          </a:fillRef>
+          <a:effectRef idx="0">
+            <a:schemeClr val="accent1"/>
+          </a:effectRef>
+          <a:fontRef idx="minor">
+            <a:schemeClr val="lt1"/>
+          </a:fontRef>
+        </p:style>
+        <p:txBody>
+          <a:bodyPr rtlCol="0" anchor="ctr"/>
+          <a:p>
+            <a:pPr algn="ctr"/>
+            <a:endParaRPr lang="zh-CN" altLang="en-US"/>
+          </a:p>
+        </p:txBody>
+      </p:sp>
+      <p:sp>
+        <p:nvSpPr>
+          <p:cNvPr id="23" name="矩形: 圆角 36"/>
+          <p:cNvSpPr/>
+          <p:nvPr>
+            <p:custDataLst>
+              <p:tags r:id="rId29"/>
+            </p:custDataLst>
+          </p:nvPr>
+        </p:nvSpPr>
+        <p:spPr>
+          <a:xfrm rot="10800000" flipV="1">
+            <a:off x="-10160" y="2917190"/>
+            <a:ext cx="3203575" cy="3674110"/>
+          </a:xfrm>
+          <a:prstGeom prst="roundRect">
+            <a:avLst>
+              <a:gd name="adj" fmla="val 10039"/>
+            </a:avLst>
+          </a:prstGeom>
+          <a:noFill/>
+          <a:ln w="38100">
+            <a:solidFill>
+              <a:schemeClr val="tx1"/>
+            </a:solidFill>
+            <a:prstDash val="lgDash"/>
+          </a:ln>
+        </p:spPr>
+        <p:style>
+          <a:lnRef idx="2">
+            <a:schemeClr val="accent1">
+              <a:shade val="15000"/>
+            </a:schemeClr>
+          </a:lnRef>
+          <a:fillRef idx="1">
+            <a:schemeClr val="accent1"/>
+          </a:fillRef>
+          <a:effectRef idx="0">
+            <a:schemeClr val="accent1"/>
+          </a:effectRef>
+          <a:fontRef idx="minor">
+            <a:schemeClr val="lt1"/>
+          </a:fontRef>
+        </p:style>
+        <p:txBody>
+          <a:bodyPr rtlCol="0" anchor="ctr"/>
+          <a:p>
+            <a:pPr algn="ctr"/>
+            <a:endParaRPr lang="zh-CN" altLang="en-US"/>
+          </a:p>
+        </p:txBody>
+      </p:sp>
+      <p:sp>
+        <p:nvSpPr>
+          <p:cNvPr id="24" name="矩形: 圆角 36"/>
+          <p:cNvSpPr/>
+          <p:nvPr>
+            <p:custDataLst>
+              <p:tags r:id="rId30"/>
+            </p:custDataLst>
+          </p:nvPr>
+        </p:nvSpPr>
+        <p:spPr>
+          <a:xfrm rot="10800000" flipV="1">
+            <a:off x="3291840" y="5791200"/>
+            <a:ext cx="7891145" cy="1054100"/>
+          </a:xfrm>
+          <a:prstGeom prst="roundRect">
+            <a:avLst>
+              <a:gd name="adj" fmla="val 10039"/>
+            </a:avLst>
+          </a:prstGeom>
+          <a:noFill/>
+          <a:ln w="38100">
+            <a:solidFill>
+              <a:schemeClr val="tx1"/>
+            </a:solidFill>
+            <a:prstDash val="lgDash"/>
+          </a:ln>
+        </p:spPr>
+        <p:style>
+          <a:lnRef idx="2">
+            <a:schemeClr val="accent1">
+              <a:shade val="15000"/>
+            </a:schemeClr>
+          </a:lnRef>
+          <a:fillRef idx="1">
+            <a:schemeClr val="accent1"/>
+          </a:fillRef>
+          <a:effectRef idx="0">
+            <a:schemeClr val="accent1"/>
+          </a:effectRef>
+          <a:fontRef idx="minor">
+            <a:schemeClr val="lt1"/>
+          </a:fontRef>
+        </p:style>
+        <p:txBody>
+          <a:bodyPr rtlCol="0" anchor="ctr"/>
+          <a:p>
+            <a:pPr algn="ctr"/>
+            <a:endParaRPr lang="zh-CN" altLang="en-US"/>
+          </a:p>
+        </p:txBody>
+      </p:sp>
+      <p:sp>
+        <p:nvSpPr>
+          <p:cNvPr id="25" name="矩形: 圆角 36"/>
+          <p:cNvSpPr/>
+          <p:nvPr>
+            <p:custDataLst>
+              <p:tags r:id="rId31"/>
+            </p:custDataLst>
+          </p:nvPr>
+        </p:nvSpPr>
+        <p:spPr>
+          <a:xfrm rot="10800000" flipV="1">
+            <a:off x="3672840" y="3048000"/>
+            <a:ext cx="2343150" cy="798195"/>
+          </a:xfrm>
+          <a:prstGeom prst="roundRect">
+            <a:avLst>
+              <a:gd name="adj" fmla="val 10039"/>
+            </a:avLst>
+          </a:prstGeom>
+          <a:noFill/>
+          <a:ln w="38100">
+            <a:solidFill>
+              <a:schemeClr val="tx1"/>
+            </a:solidFill>
+            <a:prstDash val="lgDash"/>
+          </a:ln>
+        </p:spPr>
+        <p:style>
+          <a:lnRef idx="2">
+            <a:schemeClr val="accent1">
+              <a:shade val="15000"/>
+            </a:schemeClr>
+          </a:lnRef>
+          <a:fillRef idx="1">
+            <a:schemeClr val="accent1"/>
+          </a:fillRef>
+          <a:effectRef idx="0">
+            <a:schemeClr val="accent1"/>
+          </a:effectRef>
+          <a:fontRef idx="minor">
+            <a:schemeClr val="lt1"/>
+          </a:fontRef>
+        </p:style>
+        <p:txBody>
+          <a:bodyPr rtlCol="0" anchor="ctr"/>
+          <a:p>
+            <a:pPr algn="ctr"/>
+            <a:endParaRPr lang="zh-CN" altLang="en-US"/>
+          </a:p>
+        </p:txBody>
+      </p:sp>
+      <p:sp>
+        <p:nvSpPr>
+          <p:cNvPr id="27" name="矩形: 圆角 36"/>
+          <p:cNvSpPr/>
+          <p:nvPr>
+            <p:custDataLst>
+              <p:tags r:id="rId32"/>
+            </p:custDataLst>
+          </p:nvPr>
+        </p:nvSpPr>
+        <p:spPr>
+          <a:xfrm rot="10800000" flipV="1">
+            <a:off x="3672840" y="2249805"/>
+            <a:ext cx="2343150" cy="798195"/>
+          </a:xfrm>
+          <a:prstGeom prst="roundRect">
+            <a:avLst>
+              <a:gd name="adj" fmla="val 10039"/>
+            </a:avLst>
+          </a:prstGeom>
+          <a:noFill/>
+          <a:ln w="38100">
+            <a:solidFill>
+              <a:schemeClr val="tx1"/>
+            </a:solidFill>
+            <a:prstDash val="lgDash"/>
+          </a:ln>
+        </p:spPr>
+        <p:style>
+          <a:lnRef idx="2">
+            <a:schemeClr val="accent1">
+              <a:shade val="15000"/>
+            </a:schemeClr>
+          </a:lnRef>
+          <a:fillRef idx="1">
+            <a:schemeClr val="accent1"/>
+          </a:fillRef>
+          <a:effectRef idx="0">
+            <a:schemeClr val="accent1"/>
+          </a:effectRef>
+          <a:fontRef idx="minor">
+            <a:schemeClr val="lt1"/>
+          </a:fontRef>
+        </p:style>
+        <p:txBody>
+          <a:bodyPr rtlCol="0" anchor="ctr"/>
+          <a:p>
+            <a:pPr algn="ctr"/>
+            <a:endParaRPr lang="zh-CN" altLang="en-US"/>
+          </a:p>
+        </p:txBody>
+      </p:sp>
+      <p:cxnSp>
+        <p:nvCxnSpPr>
+          <p:cNvPr id="28" name="直接连接符 27"/>
+          <p:cNvCxnSpPr>
+            <a:stCxn id="27" idx="1"/>
+            <a:endCxn id="20" idx="2"/>
+          </p:cNvCxnSpPr>
+          <p:nvPr/>
+        </p:nvCxnSpPr>
+        <p:spPr>
+          <a:xfrm flipV="1">
+            <a:off x="6015990" y="2210435"/>
+            <a:ext cx="1422400" cy="438785"/>
+          </a:xfrm>
+          <a:prstGeom prst="line">
+            <a:avLst/>
+          </a:prstGeom>
+          <a:ln w="38100" cap="flat" cmpd="sng">
+            <a:solidFill>
+              <a:schemeClr val="tx1"/>
+            </a:solidFill>
+            <a:prstDash val="solid"/>
+            <a:miter lim="800000"/>
+            <a:headEnd type="none"/>
+            <a:tailEnd type="none"/>
+          </a:ln>
+        </p:spPr>
+        <p:style>
+          <a:lnRef idx="2">
+            <a:schemeClr val="accent1"/>
+          </a:lnRef>
+          <a:fillRef idx="0">
+            <a:srgbClr val="FFFFFF"/>
+          </a:fillRef>
+          <a:effectRef idx="0">
+            <a:srgbClr val="FFFFFF"/>
+          </a:effectRef>
+          <a:fontRef idx="minor">
+            <a:schemeClr val="tx1"/>
+          </a:fontRef>
+        </p:style>
+      </p:cxnSp>
+      <p:cxnSp>
+        <p:nvCxnSpPr>
+          <p:cNvPr id="29" name="直接连接符 28"/>
+          <p:cNvCxnSpPr>
+            <a:endCxn id="21" idx="2"/>
+          </p:cNvCxnSpPr>
+          <p:nvPr>
+            <p:custDataLst>
+              <p:tags r:id="rId33"/>
+            </p:custDataLst>
+          </p:nvPr>
+        </p:nvCxnSpPr>
+        <p:spPr>
+          <a:xfrm flipH="1" flipV="1">
+            <a:off x="1591945" y="2019300"/>
+            <a:ext cx="2080895" cy="1408430"/>
+          </a:xfrm>
+          <a:prstGeom prst="line">
+            <a:avLst/>
+          </a:prstGeom>
+          <a:ln w="38100" cap="flat" cmpd="sng">
+            <a:solidFill>
+              <a:schemeClr val="tx1"/>
+            </a:solidFill>
+            <a:prstDash val="solid"/>
+            <a:miter lim="800000"/>
+            <a:headEnd type="none"/>
+            <a:tailEnd type="none"/>
+          </a:ln>
+        </p:spPr>
+        <p:style>
+          <a:lnRef idx="2">
+            <a:schemeClr val="accent1"/>
+          </a:lnRef>
+          <a:fillRef idx="0">
+            <a:srgbClr val="FFFFFF"/>
+          </a:fillRef>
+          <a:effectRef idx="0">
+            <a:srgbClr val="FFFFFF"/>
+          </a:effectRef>
+          <a:fontRef idx="minor">
+            <a:schemeClr val="tx1"/>
+          </a:fontRef>
+        </p:style>
+      </p:cxnSp>
     </p:spTree>
   </p:cSld>
   <p:clrMapOvr>
@@ -12271,7 +13006,91 @@
 </p:tagLst>
 </file>
 
+<file path=ppt/tags/tag134.xml><?xml version="1.0" encoding="utf-8"?>
+<p:tagLst xmlns:p="http://schemas.openxmlformats.org/presentationml/2006/main">
+  <p:tag name="KSO_WM_BEAUTIFY_FLAG" val=""/>
+</p:tagLst>
+</file>
+
+<file path=ppt/tags/tag135.xml><?xml version="1.0" encoding="utf-8"?>
+<p:tagLst xmlns:p="http://schemas.openxmlformats.org/presentationml/2006/main">
+  <p:tag name="KSO_WM_BEAUTIFY_FLAG" val=""/>
+</p:tagLst>
+</file>
+
+<file path=ppt/tags/tag136.xml><?xml version="1.0" encoding="utf-8"?>
+<p:tagLst xmlns:p="http://schemas.openxmlformats.org/presentationml/2006/main">
+  <p:tag name="KSO_WM_BEAUTIFY_FLAG" val=""/>
+</p:tagLst>
+</file>
+
+<file path=ppt/tags/tag137.xml><?xml version="1.0" encoding="utf-8"?>
+<p:tagLst xmlns:p="http://schemas.openxmlformats.org/presentationml/2006/main">
+  <p:tag name="KSO_WM_BEAUTIFY_FLAG" val=""/>
+</p:tagLst>
+</file>
+
+<file path=ppt/tags/tag138.xml><?xml version="1.0" encoding="utf-8"?>
+<p:tagLst xmlns:p="http://schemas.openxmlformats.org/presentationml/2006/main">
+  <p:tag name="KSO_WM_BEAUTIFY_FLAG" val=""/>
+</p:tagLst>
+</file>
+
+<file path=ppt/tags/tag139.xml><?xml version="1.0" encoding="utf-8"?>
+<p:tagLst xmlns:p="http://schemas.openxmlformats.org/presentationml/2006/main">
+  <p:tag name="KSO_WM_BEAUTIFY_FLAG" val=""/>
+</p:tagLst>
+</file>
+
 <file path=ppt/tags/tag14.xml><?xml version="1.0" encoding="utf-8"?>
+<p:tagLst xmlns:p="http://schemas.openxmlformats.org/presentationml/2006/main">
+  <p:tag name="KSO_WM_BEAUTIFY_FLAG" val=""/>
+</p:tagLst>
+</file>
+
+<file path=ppt/tags/tag140.xml><?xml version="1.0" encoding="utf-8"?>
+<p:tagLst xmlns:p="http://schemas.openxmlformats.org/presentationml/2006/main">
+  <p:tag name="KSO_WM_BEAUTIFY_FLAG" val=""/>
+</p:tagLst>
+</file>
+
+<file path=ppt/tags/tag141.xml><?xml version="1.0" encoding="utf-8"?>
+<p:tagLst xmlns:p="http://schemas.openxmlformats.org/presentationml/2006/main">
+  <p:tag name="KSO_WM_BEAUTIFY_FLAG" val=""/>
+</p:tagLst>
+</file>
+
+<file path=ppt/tags/tag142.xml><?xml version="1.0" encoding="utf-8"?>
+<p:tagLst xmlns:p="http://schemas.openxmlformats.org/presentationml/2006/main">
+  <p:tag name="KSO_WM_BEAUTIFY_FLAG" val=""/>
+</p:tagLst>
+</file>
+
+<file path=ppt/tags/tag143.xml><?xml version="1.0" encoding="utf-8"?>
+<p:tagLst xmlns:p="http://schemas.openxmlformats.org/presentationml/2006/main">
+  <p:tag name="KSO_WM_BEAUTIFY_FLAG" val=""/>
+</p:tagLst>
+</file>
+
+<file path=ppt/tags/tag144.xml><?xml version="1.0" encoding="utf-8"?>
+<p:tagLst xmlns:p="http://schemas.openxmlformats.org/presentationml/2006/main">
+  <p:tag name="KSO_WM_BEAUTIFY_FLAG" val=""/>
+</p:tagLst>
+</file>
+
+<file path=ppt/tags/tag145.xml><?xml version="1.0" encoding="utf-8"?>
+<p:tagLst xmlns:p="http://schemas.openxmlformats.org/presentationml/2006/main">
+  <p:tag name="KSO_WM_BEAUTIFY_FLAG" val=""/>
+</p:tagLst>
+</file>
+
+<file path=ppt/tags/tag146.xml><?xml version="1.0" encoding="utf-8"?>
+<p:tagLst xmlns:p="http://schemas.openxmlformats.org/presentationml/2006/main">
+  <p:tag name="KSO_WM_BEAUTIFY_FLAG" val=""/>
+</p:tagLst>
+</file>
+
+<file path=ppt/tags/tag147.xml><?xml version="1.0" encoding="utf-8"?>
 <p:tagLst xmlns:p="http://schemas.openxmlformats.org/presentationml/2006/main">
   <p:tag name="KSO_WM_BEAUTIFY_FLAG" val=""/>
 </p:tagLst>

</xml_diff>